<commit_message>
Prezentacja: font Segoe UI, paleta jak w eksploratorze, odświeżone rendery 3D
Zmiany z równoległej sesji; plik otwiera się w PowerPoincie (15 slajdów).

Co-Authored-By: Claude Opus 5.5 <noreply@anthropic.com>
Claude-Session: https://claude.ai/code/session_01SiWtycbk3CawaRuqShhbfb
</commit_message>
<xml_diff>
--- a/docs/prezentacja/NeuroFly.pptx
+++ b/docs/prezentacja/NeuroFly.pptx
@@ -121,57 +121,57 @@
   <p:extLst>
     <p:ext uri="{521415D9-36F7-43E2-AB2F-B90AF26B5E84}">
       <p14:sectionLst xmlns:p14="http://schemas.microsoft.com/office/powerpoint/2010/main">
-        <p14:section name="Start" id="{68f7fe0f-a481-696b-66e4-f772c0285493}">
+        <p14:section name="Start" id="{58eddcb5-0cbc-8226-5f0f-2f09ae246e7c}">
           <p14:sldIdLst>
             <p14:sldId id="256"/>
           </p14:sldIdLst>
         </p14:section>
-        <p14:section name="Idea" id="{a3f5f37e-4da1-5a93-f6e5-0870603cb87f}">
+        <p14:section name="Idea" id="{58769b5f-0481-98c4-d677-0aa861d2f978}">
           <p14:sldIdLst>
             <p14:sldId id="257"/>
           </p14:sldIdLst>
         </p14:section>
-        <p14:section name="Pipeline" id="{22c3f63c-357e-4928-c944-ef5b3c168646}">
+        <p14:section name="Pipeline" id="{52250c8f-7f5c-8812-ccff-b8125554d3c9}">
           <p14:sldIdLst>
             <p14:sldId id="258"/>
             <p14:sldId id="259"/>
           </p14:sldIdLst>
         </p14:section>
-        <p14:section name="Connectome" id="{b1857c81-55ef-e64f-7421-9e03763d4984}">
+        <p14:section name="Connectome" id="{eb7da69f-d244-9ec3-b2b5-569caea5f49a}">
           <p14:sldIdLst>
             <p14:sldId id="260"/>
             <p14:sldId id="261"/>
             <p14:sldId id="262"/>
           </p14:sldIdLst>
         </p14:section>
-        <p14:section name="Odczyt" id="{88936942-08af-69e1-440d-8e3da1e1e38b}">
+        <p14:section name="Odczyt" id="{19126d82-0844-3ae7-5ae4-5b480de79811}">
           <p14:sldIdLst>
             <p14:sldId id="263"/>
             <p14:sldId id="264"/>
           </p14:sldIdLst>
         </p14:section>
-        <p14:section name="Symulator" id="{edd1eef7-3060-f967-2459-3d4b3cf869b4}">
+        <p14:section name="Symulator" id="{4a1f525b-e8a3-8c9f-6f28-2a92200cd316}">
           <p14:sldIdLst>
             <p14:sldId id="265"/>
           </p14:sldIdLst>
         </p14:section>
-        <p14:section name="Trening" id="{30a5e6e8-2cc5-f253-fd0e-7f640c2d5aeb}">
+        <p14:section name="Trening" id="{d80fd524-ccaa-4753-e9dd-4297c0f29c7f}">
           <p14:sldIdLst>
             <p14:sldId id="266"/>
           </p14:sldIdLst>
         </p14:section>
-        <p14:section name="Wyniki" id="{7d91245d-a040-047f-8c00-1498826f2aa7}">
+        <p14:section name="Wyniki" id="{2bab04b2-5009-3895-74d9-2b881851198b}">
           <p14:sldIdLst>
             <p14:sldId id="267"/>
             <p14:sldId id="268"/>
           </p14:sldIdLst>
         </p14:section>
-        <p14:section name="Uczciwość" id="{20746417-9300-37f7-2188-81cfd79297ef}">
+        <p14:section name="Uczciwość" id="{46faf1c3-b6a5-72f2-6206-655dfdc78d50}">
           <p14:sldIdLst>
             <p14:sldId id="269"/>
           </p14:sldIdLst>
         </p14:section>
-        <p14:section name="Koniec" id="{2500c30d-143f-86be-4cd9-c3c4c682dc86}">
+        <p14:section name="Koniec" id="{1c3b5fb0-19ac-a7df-b6c0-6a48e823cec9}">
           <p14:sldIdLst>
             <p14:sldId id="270"/>
           </p14:sldIdLst>
@@ -281,7 +281,7 @@
             <c:bubble3D val="0"/>
             <c:spPr>
               <a:solidFill>
-                <a:srgbClr val="2DD4BF"/>
+                <a:srgbClr val="2FD3C4"/>
               </a:solidFill>
               <a:effectLst/>
             </c:spPr>
@@ -581,7 +581,7 @@
           </c:tx>
           <c:spPr>
             <a:solidFill>
-              <a:srgbClr val="2DD4BF"/>
+              <a:srgbClr val="2FD3C4"/>
             </a:solidFill>
             <a:effectLst/>
           </c:spPr>
@@ -2083,7 +2083,7 @@
           <a:p>
             <a:r>
               <a:rPr lang="en-US" dirty="0"/>
-              <a:t>Oficjalny BANC v888 (Bates et al. 2026, publiczny bucket Lee Lab). Somy z kolumny position; kolory: wzrok teal, DN amber, motoneurony rose. Żadnych syntetycznych grafów.</a:t>
+              <a:t>Oficjalny BANC v888 (Bates et al. 2026, publiczny bucket Lee Lab). Somy z kolumny position; kolory jak w eksploratorze: wzrok teal, interneurony fiolet, DN amber, motoneurony rose. Żadnych syntetycznych grafów.</a:t>
             </a:r>
             <a:endParaRPr lang="en-US" dirty="0"/>
           </a:p>
@@ -3592,7 +3592,7 @@
             <a:r>
               <a:rPr lang="en-US" sz="2000" b="1" dirty="0">
                 <a:solidFill>
-                  <a:srgbClr val="2DD4BF"/>
+                  <a:srgbClr val="2FD3C4"/>
                 </a:solidFill>
               </a:rPr>
               <a:t>1</a:t>
@@ -3734,7 +3734,7 @@
             <a:r>
               <a:rPr lang="en-US" sz="2000" b="1" dirty="0">
                 <a:solidFill>
-                  <a:srgbClr val="2DD4BF"/>
+                  <a:srgbClr val="2FD3C4"/>
                 </a:solidFill>
               </a:rPr>
               <a:t>2</a:t>
@@ -3876,7 +3876,7 @@
             <a:r>
               <a:rPr lang="en-US" sz="2000" b="1" dirty="0">
                 <a:solidFill>
-                  <a:srgbClr val="2DD4BF"/>
+                  <a:srgbClr val="2FD3C4"/>
                 </a:solidFill>
               </a:rPr>
               <a:t>3</a:t>
@@ -4018,7 +4018,7 @@
             <a:r>
               <a:rPr lang="en-US" sz="2000" b="1" dirty="0">
                 <a:solidFill>
-                  <a:srgbClr val="2DD4BF"/>
+                  <a:srgbClr val="2FD3C4"/>
                 </a:solidFill>
               </a:rPr>
               <a:t>4</a:t>
@@ -4184,11 +4184,11 @@
             <a:avLst/>
           </a:prstGeom>
           <a:solidFill>
-            <a:srgbClr val="FBBF24"/>
+            <a:srgbClr val="FFB547"/>
           </a:solidFill>
           <a:ln w="12700">
             <a:solidFill>
-              <a:srgbClr val="FBBF24"/>
+              <a:srgbClr val="FFB547"/>
             </a:solidFill>
             <a:prstDash val="solid"/>
           </a:ln>
@@ -4245,11 +4245,11 @@
             <a:avLst/>
           </a:prstGeom>
           <a:solidFill>
-            <a:srgbClr val="60A5FA"/>
+            <a:srgbClr val="4F8CFF"/>
           </a:solidFill>
           <a:ln w="12700">
             <a:solidFill>
-              <a:srgbClr val="60A5FA"/>
+              <a:srgbClr val="4F8CFF"/>
             </a:solidFill>
             <a:prstDash val="solid"/>
           </a:ln>
@@ -4548,7 +4548,7 @@
             <a:r>
               <a:rPr lang="en-US" sz="3600" b="1" dirty="0">
                 <a:solidFill>
-                  <a:srgbClr val="2DD4BF"/>
+                  <a:srgbClr val="2FD3C4"/>
                 </a:solidFill>
               </a:rPr>
               <a:t>2,65°</a:t>
@@ -5082,7 +5082,7 @@
             <a:r>
               <a:rPr lang="en-US" sz="3600" b="1" dirty="0">
                 <a:solidFill>
-                  <a:srgbClr val="2DD4BF"/>
+                  <a:srgbClr val="2FD3C4"/>
                 </a:solidFill>
               </a:rPr>
               <a:t>9,0 m</a:t>
@@ -5354,11 +5354,11 @@
             <a:avLst/>
           </a:prstGeom>
           <a:solidFill>
-            <a:srgbClr val="2DD4BF"/>
+            <a:srgbClr val="2FD3C4"/>
           </a:solidFill>
           <a:ln w="12700">
             <a:solidFill>
-              <a:srgbClr val="2DD4BF"/>
+              <a:srgbClr val="2FD3C4"/>
             </a:solidFill>
             <a:prstDash val="solid"/>
           </a:ln>
@@ -5415,11 +5415,11 @@
             <a:avLst/>
           </a:prstGeom>
           <a:solidFill>
-            <a:srgbClr val="FBBF24"/>
+            <a:srgbClr val="FFB547"/>
           </a:solidFill>
           <a:ln w="12700">
             <a:solidFill>
-              <a:srgbClr val="FBBF24"/>
+              <a:srgbClr val="FFB547"/>
             </a:solidFill>
             <a:prstDash val="solid"/>
           </a:ln>
@@ -5900,7 +5900,7 @@
             <a:r>
               <a:rPr lang="en-US" sz="1200" dirty="0">
                 <a:solidFill>
-                  <a:srgbClr val="2DD4BF"/>
+                  <a:srgbClr val="2FD3C4"/>
                 </a:solidFill>
               </a:rPr>
               <a:t>github.com/FalconDevX/neurofly</a:t>
@@ -6021,11 +6021,11 @@
             <a:avLst/>
           </a:prstGeom>
           <a:solidFill>
-            <a:srgbClr val="2DD4BF"/>
+            <a:srgbClr val="2FD3C4"/>
           </a:solidFill>
           <a:ln w="12700">
             <a:solidFill>
-              <a:srgbClr val="2DD4BF"/>
+              <a:srgbClr val="2FD3C4"/>
             </a:solidFill>
             <a:prstDash val="solid"/>
           </a:ln>
@@ -6152,11 +6152,11 @@
             <a:avLst/>
           </a:prstGeom>
           <a:solidFill>
-            <a:srgbClr val="FBBF24"/>
+            <a:srgbClr val="FFB547"/>
           </a:solidFill>
           <a:ln w="12700">
             <a:solidFill>
-              <a:srgbClr val="FBBF24"/>
+              <a:srgbClr val="FFB547"/>
             </a:solidFill>
             <a:prstDash val="solid"/>
           </a:ln>
@@ -6283,11 +6283,11 @@
             <a:avLst/>
           </a:prstGeom>
           <a:solidFill>
-            <a:srgbClr val="FB7185"/>
+            <a:srgbClr val="FF4FB0"/>
           </a:solidFill>
           <a:ln w="12700">
             <a:solidFill>
-              <a:srgbClr val="FB7185"/>
+              <a:srgbClr val="FF4FB0"/>
             </a:solidFill>
             <a:prstDash val="solid"/>
           </a:ln>
@@ -6414,11 +6414,11 @@
             <a:avLst/>
           </a:prstGeom>
           <a:solidFill>
-            <a:srgbClr val="60A5FA"/>
+            <a:srgbClr val="4F8CFF"/>
           </a:solidFill>
           <a:ln w="12700">
             <a:solidFill>
-              <a:srgbClr val="60A5FA"/>
+              <a:srgbClr val="4F8CFF"/>
             </a:solidFill>
             <a:prstDash val="solid"/>
           </a:ln>
@@ -6677,11 +6677,11 @@
             <a:avLst/>
           </a:prstGeom>
           <a:solidFill>
-            <a:srgbClr val="2DD4BF"/>
+            <a:srgbClr val="2FD3C4"/>
           </a:solidFill>
           <a:ln w="12700">
             <a:solidFill>
-              <a:srgbClr val="2DD4BF"/>
+              <a:srgbClr val="2FD3C4"/>
             </a:solidFill>
             <a:prstDash val="solid"/>
           </a:ln>
@@ -6832,11 +6832,11 @@
             <a:avLst/>
           </a:prstGeom>
           <a:solidFill>
-            <a:srgbClr val="2DD4BF"/>
+            <a:srgbClr val="2FD3C4"/>
           </a:solidFill>
           <a:ln w="12700">
             <a:solidFill>
-              <a:srgbClr val="2DD4BF"/>
+              <a:srgbClr val="2FD3C4"/>
             </a:solidFill>
             <a:prstDash val="solid"/>
           </a:ln>
@@ -6987,11 +6987,11 @@
             <a:avLst/>
           </a:prstGeom>
           <a:solidFill>
-            <a:srgbClr val="2DD4BF"/>
+            <a:srgbClr val="2FD3C4"/>
           </a:solidFill>
           <a:ln w="12700">
             <a:solidFill>
-              <a:srgbClr val="2DD4BF"/>
+              <a:srgbClr val="2FD3C4"/>
             </a:solidFill>
             <a:prstDash val="solid"/>
           </a:ln>
@@ -7142,11 +7142,11 @@
             <a:avLst/>
           </a:prstGeom>
           <a:solidFill>
-            <a:srgbClr val="2DD4BF"/>
+            <a:srgbClr val="2FD3C4"/>
           </a:solidFill>
           <a:ln w="12700">
             <a:solidFill>
-              <a:srgbClr val="2DD4BF"/>
+              <a:srgbClr val="2FD3C4"/>
             </a:solidFill>
             <a:prstDash val="solid"/>
           </a:ln>
@@ -7273,11 +7273,11 @@
             <a:avLst/>
           </a:prstGeom>
           <a:solidFill>
-            <a:srgbClr val="FBBF24"/>
+            <a:srgbClr val="FFB547"/>
           </a:solidFill>
           <a:ln w="12700">
             <a:solidFill>
-              <a:srgbClr val="FBBF24"/>
+              <a:srgbClr val="FFB547"/>
             </a:solidFill>
             <a:prstDash val="solid"/>
           </a:ln>
@@ -7428,11 +7428,11 @@
             <a:avLst/>
           </a:prstGeom>
           <a:solidFill>
-            <a:srgbClr val="FB7185"/>
+            <a:srgbClr val="FF4FB0"/>
           </a:solidFill>
           <a:ln w="12700">
             <a:solidFill>
-              <a:srgbClr val="FB7185"/>
+              <a:srgbClr val="FF4FB0"/>
             </a:solidFill>
             <a:prstDash val="solid"/>
           </a:ln>
@@ -7738,11 +7738,11 @@
             <a:avLst/>
           </a:prstGeom>
           <a:solidFill>
-            <a:srgbClr val="60A5FA"/>
+            <a:srgbClr val="4F8CFF"/>
           </a:solidFill>
           <a:ln w="12700">
             <a:solidFill>
-              <a:srgbClr val="60A5FA"/>
+              <a:srgbClr val="4F8CFF"/>
             </a:solidFill>
             <a:prstDash val="solid"/>
           </a:ln>
@@ -8727,11 +8727,11 @@
             <a:avLst/>
           </a:prstGeom>
           <a:solidFill>
-            <a:srgbClr val="2DD4BF"/>
+            <a:srgbClr val="2FD3C4"/>
           </a:solidFill>
           <a:ln w="12700">
             <a:solidFill>
-              <a:srgbClr val="2DD4BF"/>
+              <a:srgbClr val="2FD3C4"/>
             </a:solidFill>
             <a:prstDash val="solid"/>
           </a:ln>
@@ -8788,11 +8788,11 @@
             <a:avLst/>
           </a:prstGeom>
           <a:solidFill>
-            <a:srgbClr val="A1A1AA"/>
+            <a:srgbClr val="A98BFF"/>
           </a:solidFill>
           <a:ln w="12700">
             <a:solidFill>
-              <a:srgbClr val="A1A1AA"/>
+              <a:srgbClr val="A98BFF"/>
             </a:solidFill>
             <a:prstDash val="solid"/>
           </a:ln>
@@ -8849,11 +8849,11 @@
             <a:avLst/>
           </a:prstGeom>
           <a:solidFill>
-            <a:srgbClr val="FB7185"/>
+            <a:srgbClr val="FF4FB0"/>
           </a:solidFill>
           <a:ln w="12700">
             <a:solidFill>
-              <a:srgbClr val="FB7185"/>
+              <a:srgbClr val="FF4FB0"/>
             </a:solidFill>
             <a:prstDash val="solid"/>
           </a:ln>
@@ -8910,11 +8910,11 @@
             <a:avLst/>
           </a:prstGeom>
           <a:solidFill>
-            <a:srgbClr val="FBBF24"/>
+            <a:srgbClr val="FFB547"/>
           </a:solidFill>
           <a:ln w="12700">
             <a:solidFill>
-              <a:srgbClr val="FBBF24"/>
+              <a:srgbClr val="FFB547"/>
             </a:solidFill>
             <a:prstDash val="solid"/>
           </a:ln>
@@ -9164,7 +9164,7 @@
             <a:r>
               <a:rPr lang="en-US" sz="1400" b="1" dirty="0">
                 <a:solidFill>
-                  <a:srgbClr val="2DD4BF"/>
+                  <a:srgbClr val="2FD3C4"/>
                 </a:solidFill>
               </a:rPr>
               <a:t>W</a:t>
@@ -9236,7 +9236,7 @@
             <a:r>
               <a:rPr lang="en-US" sz="1400" b="1" dirty="0">
                 <a:solidFill>
-                  <a:srgbClr val="2DD4BF"/>
+                  <a:srgbClr val="2FD3C4"/>
                 </a:solidFill>
               </a:rPr>
               <a:t>τ, dt, g</a:t>
@@ -9308,7 +9308,7 @@
             <a:r>
               <a:rPr lang="en-US" sz="1400" b="1" dirty="0">
                 <a:solidFill>
-                  <a:srgbClr val="2DD4BF"/>
+                  <a:srgbClr val="2FD3C4"/>
                 </a:solidFill>
               </a:rPr>
               <a:t>I</a:t>
@@ -9380,7 +9380,7 @@
             <a:r>
               <a:rPr lang="en-US" sz="1400" b="1" dirty="0">
                 <a:solidFill>
-                  <a:srgbClr val="2DD4BF"/>
+                  <a:srgbClr val="2FD3C4"/>
                 </a:solidFill>
               </a:rPr>
               <a:t>GPU</a:t>
@@ -9510,11 +9510,11 @@
             <a:avLst/>
           </a:prstGeom>
           <a:solidFill>
-            <a:srgbClr val="2DD4BF"/>
+            <a:srgbClr val="2FD3C4"/>
           </a:solidFill>
           <a:ln w="12700">
             <a:solidFill>
-              <a:srgbClr val="2DD4BF"/>
+              <a:srgbClr val="2FD3C4"/>
             </a:solidFill>
             <a:prstDash val="solid"/>
           </a:ln>
@@ -9571,11 +9571,11 @@
             <a:avLst/>
           </a:prstGeom>
           <a:solidFill>
-            <a:srgbClr val="FB7185"/>
+            <a:srgbClr val="FF4FB0"/>
           </a:solidFill>
           <a:ln w="12700">
             <a:solidFill>
-              <a:srgbClr val="FB7185"/>
+              <a:srgbClr val="FF4FB0"/>
             </a:solidFill>
             <a:prstDash val="solid"/>
           </a:ln>
@@ -9632,11 +9632,11 @@
             <a:avLst/>
           </a:prstGeom>
           <a:solidFill>
-            <a:srgbClr val="FB7185"/>
+            <a:srgbClr val="FF4FB0"/>
           </a:solidFill>
           <a:ln w="12700">
             <a:solidFill>
-              <a:srgbClr val="FB7185"/>
+              <a:srgbClr val="FF4FB0"/>
             </a:solidFill>
             <a:prstDash val="solid"/>
           </a:ln>
@@ -9693,11 +9693,11 @@
             <a:avLst/>
           </a:prstGeom>
           <a:solidFill>
-            <a:srgbClr val="FB7185"/>
+            <a:srgbClr val="FF4FB0"/>
           </a:solidFill>
           <a:ln w="12700">
             <a:solidFill>
-              <a:srgbClr val="FB7185"/>
+              <a:srgbClr val="FF4FB0"/>
             </a:solidFill>
             <a:prstDash val="solid"/>
           </a:ln>
@@ -9922,11 +9922,11 @@
             <a:avLst/>
           </a:prstGeom>
           <a:solidFill>
-            <a:srgbClr val="FBBF24"/>
+            <a:srgbClr val="FFB547"/>
           </a:solidFill>
           <a:ln w="12700">
             <a:solidFill>
-              <a:srgbClr val="FBBF24"/>
+              <a:srgbClr val="FFB547"/>
             </a:solidFill>
             <a:prstDash val="solid"/>
           </a:ln>
@@ -10055,11 +10055,11 @@
             <a:avLst/>
           </a:prstGeom>
           <a:solidFill>
-            <a:srgbClr val="FBBF24"/>
+            <a:srgbClr val="FFB547"/>
           </a:solidFill>
           <a:ln w="12700">
             <a:solidFill>
-              <a:srgbClr val="FBBF24"/>
+              <a:srgbClr val="FFB547"/>
             </a:solidFill>
             <a:prstDash val="solid"/>
           </a:ln>
@@ -10188,11 +10188,11 @@
             <a:avLst/>
           </a:prstGeom>
           <a:solidFill>
-            <a:srgbClr val="FB7185"/>
+            <a:srgbClr val="FF4FB0"/>
           </a:solidFill>
           <a:ln w="12700">
             <a:solidFill>
-              <a:srgbClr val="FB7185"/>
+              <a:srgbClr val="FF4FB0"/>
             </a:solidFill>
             <a:prstDash val="solid"/>
           </a:ln>
@@ -10321,11 +10321,11 @@
             <a:avLst/>
           </a:prstGeom>
           <a:solidFill>
-            <a:srgbClr val="FB7185"/>
+            <a:srgbClr val="FF4FB0"/>
           </a:solidFill>
           <a:ln w="12700">
             <a:solidFill>
-              <a:srgbClr val="FB7185"/>
+              <a:srgbClr val="FF4FB0"/>
             </a:solidFill>
             <a:prstDash val="solid"/>
           </a:ln>
@@ -10454,11 +10454,11 @@
             <a:avLst/>
           </a:prstGeom>
           <a:solidFill>
-            <a:srgbClr val="FB7185"/>
+            <a:srgbClr val="FF4FB0"/>
           </a:solidFill>
           <a:ln w="12700">
             <a:solidFill>
-              <a:srgbClr val="FB7185"/>
+              <a:srgbClr val="FF4FB0"/>
             </a:solidFill>
             <a:prstDash val="solid"/>
           </a:ln>
@@ -10587,11 +10587,11 @@
             <a:avLst/>
           </a:prstGeom>
           <a:solidFill>
-            <a:srgbClr val="60A5FA"/>
+            <a:srgbClr val="4F8CFF"/>
           </a:solidFill>
           <a:ln w="12700">
             <a:solidFill>
-              <a:srgbClr val="60A5FA"/>
+              <a:srgbClr val="4F8CFF"/>
             </a:solidFill>
             <a:prstDash val="solid"/>
           </a:ln>
@@ -10856,7 +10856,7 @@
             <a:r>
               <a:rPr lang="en-US" sz="3600" b="1" dirty="0">
                 <a:solidFill>
-                  <a:srgbClr val="2DD4BF"/>
+                  <a:srgbClr val="2FD3C4"/>
                 </a:solidFill>
               </a:rPr>
               <a:t>99%</a:t>
@@ -11320,7 +11320,7 @@
             <a:r>
               <a:rPr lang="en-US" sz="3600" b="1" dirty="0">
                 <a:solidFill>
-                  <a:srgbClr val="2DD4BF"/>
+                  <a:srgbClr val="2FD3C4"/>
                 </a:solidFill>
               </a:rPr>
               <a:t>80%</a:t>
@@ -11392,7 +11392,7 @@
             <a:r>
               <a:rPr lang="en-US" sz="3600" b="1" dirty="0">
                 <a:solidFill>
-                  <a:srgbClr val="2DD4BF"/>
+                  <a:srgbClr val="2FD3C4"/>
                 </a:solidFill>
               </a:rPr>
               <a:t>16 927</a:t>
@@ -11527,49 +11527,49 @@
 </file>
 
 <file path=ppt/theme/theme1.xml><?xml version="1.0" encoding="utf-8"?>
-<a:theme xmlns:a="http://schemas.openxmlformats.org/drawingml/2006/main" name="NeuroFly">
+<a:theme xmlns:a="http://schemas.openxmlformats.org/drawingml/2006/main" name="Office Theme">
   <a:themeElements>
-    <a:clrScheme name="NeuroFly">
+    <a:clrScheme name="Office">
       <a:dk1>
-        <a:srgbClr val="09090B"/>
+        <a:sysClr val="windowText" lastClr="000000"/>
       </a:dk1>
       <a:lt1>
-        <a:srgbClr val="FAFAFA"/>
+        <a:sysClr val="window" lastClr="FFFFFF"/>
       </a:lt1>
       <a:dk2>
-        <a:srgbClr val="18181B"/>
+        <a:srgbClr val="44546A"/>
       </a:dk2>
       <a:lt2>
-        <a:srgbClr val="A1A1AA"/>
+        <a:srgbClr val="E7E6E6"/>
       </a:lt2>
       <a:accent1>
-        <a:srgbClr val="2DD4BF"/>
+        <a:srgbClr val="4472C4"/>
       </a:accent1>
       <a:accent2>
-        <a:srgbClr val="FBBF24"/>
+        <a:srgbClr val="ED7D31"/>
       </a:accent2>
       <a:accent3>
-        <a:srgbClr val="FB7185"/>
+        <a:srgbClr val="A5A5A5"/>
       </a:accent3>
       <a:accent4>
-        <a:srgbClr val="60A5FA"/>
+        <a:srgbClr val="FFC000"/>
       </a:accent4>
       <a:accent5>
-        <a:srgbClr val="52525B"/>
+        <a:srgbClr val="5B9BD5"/>
       </a:accent5>
       <a:accent6>
-        <a:srgbClr val="27272A"/>
+        <a:srgbClr val="70AD47"/>
       </a:accent6>
       <a:hlink>
-        <a:srgbClr val="2DD4BF"/>
+        <a:srgbClr val="0563C1"/>
       </a:hlink>
       <a:folHlink>
-        <a:srgbClr val="A1A1AA"/>
+        <a:srgbClr val="954F72"/>
       </a:folHlink>
     </a:clrScheme>
-    <a:fontScheme name="NeuroFly">
+    <a:fontScheme name="Office">
       <a:majorFont>
-        <a:latin typeface="Calibri"/>
+        <a:latin typeface="Segoe UI"/>
         <a:ea typeface=""/>
         <a:cs typeface=""/>
         <a:font script="Jpan" typeface="游ゴシック Light"/>
@@ -11621,7 +11621,7 @@
         <a:font script="Tfng" typeface="Ebrima"/>
       </a:majorFont>
       <a:minorFont>
-        <a:latin typeface="Calibri"/>
+        <a:latin typeface="Segoe UI"/>
         <a:ea typeface=""/>
         <a:cs typeface=""/>
         <a:font script="Jpan" typeface="游ゴシック"/>

</xml_diff>

<commit_message>
Półprzezroczyste ciało muszki wokół connectomu: eksplorator (z przełącznikiem) i pierwszy slajd
- scripts/export_fly_body.py: siatki NeuroMechFly (FlyGym, 55 tys. wierzchołków) w układzie
  BANC — głowa do góry, strona brzuszna do widza, skrzydła rozłożone; skala i przesunięcie:
  głowa → mózg, tułów → VNC (ilustracyjnie; w BANC łącznik szyjny jest rozciągnięty)
- explorer: ciało jako szare „szkło” (Fresnel: jaśniejsze krawędzie, przezroczysty środek),
  szkielety obwodu lotu jaśniejsze, gdy ciało jest widoczne; przycisk „Fly body”
  (zapamiętany w przeglądarce); sync-data kopiuje fly_body.*
- prezentacja: render fly_xray (ciało + somy + obwód lotu z poświatą) na pierwszym slajdzie

Co-Authored-By: Claude Opus 5.5 <noreply@anthropic.com>
Claude-Session: https://claude.ai/code/session_01SiWtycbk3CawaRuqShhbfb
</commit_message>
<xml_diff>
--- a/docs/prezentacja/NeuroFly.pptx
+++ b/docs/prezentacja/NeuroFly.pptx
@@ -121,57 +121,57 @@
   <p:extLst>
     <p:ext uri="{521415D9-36F7-43E2-AB2F-B90AF26B5E84}">
       <p14:sectionLst xmlns:p14="http://schemas.microsoft.com/office/powerpoint/2010/main">
-        <p14:section name="Start" id="{58eddcb5-0cbc-8226-5f0f-2f09ae246e7c}">
+        <p14:section name="Start" id="{a1833e3a-3786-ca32-58ed-fa1d42b4e91c}">
           <p14:sldIdLst>
             <p14:sldId id="256"/>
           </p14:sldIdLst>
         </p14:section>
-        <p14:section name="Idea" id="{58769b5f-0481-98c4-d677-0aa861d2f978}">
+        <p14:section name="Idea" id="{4cbbccd4-657f-0bf4-42f7-4f2e9cf8310e}">
           <p14:sldIdLst>
             <p14:sldId id="257"/>
           </p14:sldIdLst>
         </p14:section>
-        <p14:section name="Pipeline" id="{52250c8f-7f5c-8812-ccff-b8125554d3c9}">
+        <p14:section name="Pipeline" id="{bea17412-fcae-9ec3-ff71-683df0b30d22}">
           <p14:sldIdLst>
             <p14:sldId id="258"/>
             <p14:sldId id="259"/>
           </p14:sldIdLst>
         </p14:section>
-        <p14:section name="Connectome" id="{eb7da69f-d244-9ec3-b2b5-569caea5f49a}">
+        <p14:section name="Connectome" id="{153a9e54-fdf9-511e-4066-82c8598deb94}">
           <p14:sldIdLst>
             <p14:sldId id="260"/>
             <p14:sldId id="261"/>
             <p14:sldId id="262"/>
           </p14:sldIdLst>
         </p14:section>
-        <p14:section name="Odczyt" id="{19126d82-0844-3ae7-5ae4-5b480de79811}">
+        <p14:section name="Odczyt" id="{ea834916-45be-c40d-0b05-647a84c69752}">
           <p14:sldIdLst>
             <p14:sldId id="263"/>
             <p14:sldId id="264"/>
           </p14:sldIdLst>
         </p14:section>
-        <p14:section name="Symulator" id="{4a1f525b-e8a3-8c9f-6f28-2a92200cd316}">
+        <p14:section name="Symulator" id="{699fe6e3-79ef-c0d9-67f9-e34f623892aa}">
           <p14:sldIdLst>
             <p14:sldId id="265"/>
           </p14:sldIdLst>
         </p14:section>
-        <p14:section name="Trening" id="{d80fd524-ccaa-4753-e9dd-4297c0f29c7f}">
+        <p14:section name="Trening" id="{ed7888fb-ebd4-3bca-2cda-2669467fb3b4}">
           <p14:sldIdLst>
             <p14:sldId id="266"/>
           </p14:sldIdLst>
         </p14:section>
-        <p14:section name="Wyniki" id="{2bab04b2-5009-3895-74d9-2b881851198b}">
+        <p14:section name="Wyniki" id="{2f9561c8-0f7b-c278-15ed-9a109962a581}">
           <p14:sldIdLst>
             <p14:sldId id="267"/>
             <p14:sldId id="268"/>
           </p14:sldIdLst>
         </p14:section>
-        <p14:section name="Uczciwość" id="{46faf1c3-b6a5-72f2-6206-655dfdc78d50}">
+        <p14:section name="Uczciwość" id="{c7dff4a4-ea51-a8aa-986f-5790f782465a}">
           <p14:sldIdLst>
             <p14:sldId id="269"/>
           </p14:sldIdLst>
         </p14:section>
-        <p14:section name="Koniec" id="{1c3b5fb0-19ac-a7df-b6c0-6a48e823cec9}">
+        <p14:section name="Koniec" id="{c42ac6df-e20e-6902-2ba0-bbb3df3bb926}">
           <p14:sldIdLst>
             <p14:sldId id="270"/>
           </p14:sldIdLst>
@@ -1203,7 +1203,7 @@
           <a:p>
             <a:r>
               <a:rPr lang="en-US" dirty="0"/>
-              <a:t>NeuroFly: obraz z kamer drona przechodzi przez model oka muszki (FlyVis), potem przez prawdziwy connectome Drosophila (BANC v888, mózg + brzuszny łańcuch nerwowy), a aktywność neuronów lotu steruje dronem w symulatorze.</a:t>
+              <a:t>NeuroFly: obraz z kamer drona przechodzi przez model oka muszki (FlyVis), potem przez prawdziwy connectome Drosophila (BANC v888, mózg + brzuszny łańcuch nerwowy), a aktywność neuronów lotu steruje dronem w symulatorze. Render: półprzezroczyste ciało NeuroMechFly (FlyGym) z connectomem BANC w środku — dopasowanie ciała ilustracyjne.</a:t>
             </a:r>
             <a:endParaRPr lang="en-US" dirty="0"/>
           </a:p>
@@ -3058,7 +3058,7 @@
       </p:grpSpPr>
       <p:pic>
         <p:nvPicPr>
-          <p:cNvPr id="2" name="render-connectome" descr="C:\NeuroFly\docs\prezentacja\assets\connectome_wide.jpg">    </p:cNvPr>
+          <p:cNvPr id="2" name="render-fly-xray" descr="C:\NeuroFly\docs\prezentacja\assets\fly_xray.jpg">    </p:cNvPr>
           <p:cNvPicPr>
             <a:picLocks noChangeAspect="1"/>
           </p:cNvPicPr>
@@ -3072,8 +3072,8 @@
         </p:blipFill>
         <p:spPr>
           <a:xfrm>
-            <a:off x="3749040" y="685800"/>
-            <a:ext cx="5394960" cy="2697480"/>
+            <a:off x="3246120" y="91440"/>
+            <a:ext cx="5897880" cy="3401568"/>
           </a:xfrm>
           <a:prstGeom prst="rect">
             <a:avLst/>
@@ -11527,47 +11527,47 @@
 </file>
 
 <file path=ppt/theme/theme1.xml><?xml version="1.0" encoding="utf-8"?>
-<a:theme xmlns:a="http://schemas.openxmlformats.org/drawingml/2006/main" name="Office Theme">
+<a:theme xmlns:a="http://schemas.openxmlformats.org/drawingml/2006/main" name="NeuroFly">
   <a:themeElements>
-    <a:clrScheme name="Office">
+    <a:clrScheme name="NeuroFly">
       <a:dk1>
-        <a:sysClr val="windowText" lastClr="000000"/>
+        <a:srgbClr val="09090B"/>
       </a:dk1>
       <a:lt1>
-        <a:sysClr val="window" lastClr="FFFFFF"/>
+        <a:srgbClr val="FAFAFA"/>
       </a:lt1>
       <a:dk2>
-        <a:srgbClr val="44546A"/>
+        <a:srgbClr val="18181B"/>
       </a:dk2>
       <a:lt2>
-        <a:srgbClr val="E7E6E6"/>
+        <a:srgbClr val="A1A1AA"/>
       </a:lt2>
       <a:accent1>
-        <a:srgbClr val="4472C4"/>
+        <a:srgbClr val="2FD3C4"/>
       </a:accent1>
       <a:accent2>
-        <a:srgbClr val="ED7D31"/>
+        <a:srgbClr val="FFB547"/>
       </a:accent2>
       <a:accent3>
-        <a:srgbClr val="A5A5A5"/>
+        <a:srgbClr val="FF4FB0"/>
       </a:accent3>
       <a:accent4>
-        <a:srgbClr val="FFC000"/>
+        <a:srgbClr val="4F8CFF"/>
       </a:accent4>
       <a:accent5>
-        <a:srgbClr val="5B9BD5"/>
+        <a:srgbClr val="52525B"/>
       </a:accent5>
       <a:accent6>
-        <a:srgbClr val="70AD47"/>
+        <a:srgbClr val="27272A"/>
       </a:accent6>
       <a:hlink>
-        <a:srgbClr val="0563C1"/>
+        <a:srgbClr val="2FD3C4"/>
       </a:hlink>
       <a:folHlink>
-        <a:srgbClr val="954F72"/>
+        <a:srgbClr val="A1A1AA"/>
       </a:folHlink>
     </a:clrScheme>
-    <a:fontScheme name="Office">
+    <a:fontScheme name="NeuroFly">
       <a:majorFont>
         <a:latin typeface="Segoe UI"/>
         <a:ea typeface=""/>

</xml_diff>

<commit_message>
Prezentacja: Roboto (osadzony w .pptx przez PowerPoint), etykiety renderów też w Roboto
- build.js: font nagłówków i treści Roboto (wykresy przez motyw)
- render_assets.py: etykiety na renderach 3D w Roboto
- embed_fonts.ps1: zapis przez PowerPoint z osadzonymi fontami — prezentacja wygląda
  tak samo na komputerach bez Roboto (Apache 2.0, github.com/googlefonts/roboto v2.138)

Co-Authored-By: Claude Opus 5.5 <noreply@anthropic.com>
Claude-Session: https://claude.ai/code/session_01SiWtycbk3CawaRuqShhbfb
</commit_message>
<xml_diff>
--- a/docs/prezentacja/NeuroFly.pptx
+++ b/docs/prezentacja/NeuroFly.pptx
@@ -1,9 +1,12 @@
 
 <file path=ppt/presentation.xml><?xml version="1.0" encoding="utf-8"?>
-<p:presentation xmlns:a="http://schemas.openxmlformats.org/drawingml/2006/main" xmlns:r="http://schemas.openxmlformats.org/officeDocument/2006/relationships" xmlns:p="http://schemas.openxmlformats.org/presentationml/2006/main" saveSubsetFonts="1" autoCompressPictures="0">
+<p:presentation xmlns:a="http://schemas.openxmlformats.org/drawingml/2006/main" xmlns:r="http://schemas.openxmlformats.org/officeDocument/2006/relationships" xmlns:p="http://schemas.openxmlformats.org/presentationml/2006/main" embedTrueTypeFonts="1" saveSubsetFonts="1" autoCompressPictures="0">
   <p:sldMasterIdLst>
     <p:sldMasterId id="2147483648" r:id="rId1"/>
   </p:sldMasterIdLst>
+  <p:notesMasterIdLst>
+    <p:notesMasterId r:id="rId17"/>
+  </p:notesMasterIdLst>
   <p:sldIdLst>
     <p:sldId id="256" r:id="rId2"/>
     <p:sldId id="257" r:id="rId3"/>
@@ -21,11 +24,24 @@
     <p:sldId id="269" r:id="rId15"/>
     <p:sldId id="270" r:id="rId16"/>
   </p:sldIdLst>
-  <p:notesMasterIdLst>
-    <p:notesMasterId r:id="rId17"/>
-  </p:notesMasterIdLst>
-  <p:sldSz cx="9144000" cy="5143500"/>
+  <p:sldSz cx="9144000" cy="5143500" type="screen16x9"/>
   <p:notesSz cx="5143500" cy="9144000"/>
+  <p:embeddedFontLst>
+    <p:embeddedFont>
+      <p:font typeface="Cambria" panose="02040503050406030204" pitchFamily="18" charset="0"/>
+      <p:regular r:id="rId18"/>
+      <p:bold r:id="rId19"/>
+      <p:italic r:id="rId20"/>
+      <p:boldItalic r:id="rId21"/>
+    </p:embeddedFont>
+    <p:embeddedFont>
+      <p:font typeface="Roboto" panose="02000000000000000000" pitchFamily="2" charset="0"/>
+      <p:regular r:id="rId22"/>
+      <p:bold r:id="rId23"/>
+      <p:italic r:id="rId24"/>
+      <p:boldItalic r:id="rId25"/>
+    </p:embeddedFont>
+  </p:embeddedFontLst>
   <p:defaultTextStyle>
     <a:lvl1pPr marL="0" algn="l" defTabSz="914400" rtl="0" eaLnBrk="1" latinLnBrk="0" hangingPunct="1">
       <a:defRPr sz="1800" kern="1200">
@@ -121,57 +137,57 @@
   <p:extLst>
     <p:ext uri="{521415D9-36F7-43E2-AB2F-B90AF26B5E84}">
       <p14:sectionLst xmlns:p14="http://schemas.microsoft.com/office/powerpoint/2010/main">
-        <p14:section name="Start" id="{a1833e3a-3786-ca32-58ed-fa1d42b4e91c}">
+        <p14:section name="Start" id="{B4698A53-E9A4-8FD9-8FC2-901CD3FD4E30}">
           <p14:sldIdLst>
             <p14:sldId id="256"/>
           </p14:sldIdLst>
         </p14:section>
-        <p14:section name="Idea" id="{4cbbccd4-657f-0bf4-42f7-4f2e9cf8310e}">
+        <p14:section name="Idea" id="{EDA2C285-5694-0EFE-3381-A1E089D14F59}">
           <p14:sldIdLst>
             <p14:sldId id="257"/>
           </p14:sldIdLst>
         </p14:section>
-        <p14:section name="Pipeline" id="{bea17412-fcae-9ec3-ff71-683df0b30d22}">
+        <p14:section name="Pipeline" id="{44615E25-F902-9F94-1659-411A0A0C7B93}">
           <p14:sldIdLst>
             <p14:sldId id="258"/>
             <p14:sldId id="259"/>
           </p14:sldIdLst>
         </p14:section>
-        <p14:section name="Connectome" id="{153a9e54-fdf9-511e-4066-82c8598deb94}">
+        <p14:section name="Connectome" id="{D0FE2DD8-74B5-E6CB-9E3E-FDB74A4FB596}">
           <p14:sldIdLst>
             <p14:sldId id="260"/>
             <p14:sldId id="261"/>
             <p14:sldId id="262"/>
           </p14:sldIdLst>
         </p14:section>
-        <p14:section name="Odczyt" id="{ea834916-45be-c40d-0b05-647a84c69752}">
+        <p14:section name="Odczyt" id="{BA5F89ED-B7BD-DDBF-DF30-7E47CCDB5436}">
           <p14:sldIdLst>
             <p14:sldId id="263"/>
             <p14:sldId id="264"/>
           </p14:sldIdLst>
         </p14:section>
-        <p14:section name="Symulator" id="{699fe6e3-79ef-c0d9-67f9-e34f623892aa}">
+        <p14:section name="Symulator" id="{F566EDF2-687A-617E-1963-1E0420337780}">
           <p14:sldIdLst>
             <p14:sldId id="265"/>
           </p14:sldIdLst>
         </p14:section>
-        <p14:section name="Trening" id="{ed7888fb-ebd4-3bca-2cda-2669467fb3b4}">
+        <p14:section name="Trening" id="{598CE636-DD19-9F8D-342D-8DBD0D818BBD}">
           <p14:sldIdLst>
             <p14:sldId id="266"/>
           </p14:sldIdLst>
         </p14:section>
-        <p14:section name="Wyniki" id="{2f9561c8-0f7b-c278-15ed-9a109962a581}">
+        <p14:section name="Wyniki" id="{FB0ACF77-609E-78ED-E52B-E60492E9D717}">
           <p14:sldIdLst>
             <p14:sldId id="267"/>
             <p14:sldId id="268"/>
           </p14:sldIdLst>
         </p14:section>
-        <p14:section name="Uczciwość" id="{c7dff4a4-ea51-a8aa-986f-5790f782465a}">
+        <p14:section name="Uczciwość" id="{25EEECC2-9FB7-E063-D2D3-812D36142CA7}">
           <p14:sldIdLst>
             <p14:sldId id="269"/>
           </p14:sldIdLst>
         </p14:section>
-        <p14:section name="Koniec" id="{c42ac6df-e20e-6902-2ba0-bbb3df3bb926}">
+        <p14:section name="Koniec" id="{A1EE520F-96A5-284E-F29C-70F4011ACE7F}">
           <p14:sldIdLst>
             <p14:sldId id="270"/>
           </p14:sldIdLst>
@@ -186,9 +202,11 @@
 </file>
 
 <file path=ppt/charts/chart1.xml><?xml version="1.0" encoding="utf-8"?>
-<c:chartSpace xmlns:c="http://schemas.openxmlformats.org/drawingml/2006/chart" xmlns:a="http://schemas.openxmlformats.org/drawingml/2006/main" xmlns:r="http://schemas.openxmlformats.org/officeDocument/2006/relationships">
+<c:chartSpace xmlns:c="http://schemas.openxmlformats.org/drawingml/2006/chart" xmlns:a="http://schemas.openxmlformats.org/drawingml/2006/main" xmlns:r="http://schemas.openxmlformats.org/officeDocument/2006/relationships" xmlns:c16r2="http://schemas.microsoft.com/office/drawing/2015/06/chart">
   <c:date1904 val="0"/>
+  <c:lang val="en-US"/>
   <c:roundedCorners val="1"/>
+  <c:style val="2"/>
   <c:chart>
     <c:autoTitleDeleted val="1"/>
     <c:plotArea>
@@ -218,62 +236,35 @@
             <a:effectLst/>
           </c:spPr>
           <c:invertIfNegative val="0"/>
-          <c:dLbls>
-            <c:numFmt formatCode="0&quot;%&quot;" sourceLinked="0"/>
-            <c:txPr>
-              <a:bodyPr/>
-              <a:lstStyle/>
-              <a:p>
-                <a:pPr>
-                  <a:defRPr b="0" i="0" strike="noStrike" sz="1200" u="none">
-                    <a:solidFill>
-                      <a:srgbClr val="FAFAFA"/>
-                    </a:solidFill>
-                    <a:latin typeface="+mn-lt"/>
-                  </a:defRPr>
-                </a:pPr>
-              </a:p>
-            </c:txPr>
-            <c:showLegendKey val="0"/>
-            <c:showVal val="1"/>
-            <c:showCatName val="0"/>
-            <c:showSerName val="0"/>
-            <c:showPercent val="0"/>
-            <c:showBubbleSize val="0"/>
-            <c:showLeaderLines val="0"/>
-          </c:dLbls>
           <c:dPt>
             <c:idx val="0"/>
             <c:invertIfNegative val="0"/>
             <c:bubble3D val="0"/>
-            <c:spPr>
-              <a:solidFill>
-                <a:srgbClr val="52525B"/>
-              </a:solidFill>
-              <a:effectLst/>
-            </c:spPr>
+            <c:extLst>
+              <c:ext xmlns:c16="http://schemas.microsoft.com/office/drawing/2014/chart" uri="{C3380CC4-5D6E-409C-BE32-E72D297353CC}">
+                <c16:uniqueId val="{00000001-1A1B-4A1A-A048-583FEE77A83A}"/>
+              </c:ext>
+            </c:extLst>
           </c:dPt>
           <c:dPt>
             <c:idx val="1"/>
             <c:invertIfNegative val="0"/>
             <c:bubble3D val="0"/>
-            <c:spPr>
-              <a:solidFill>
-                <a:srgbClr val="52525B"/>
-              </a:solidFill>
-              <a:effectLst/>
-            </c:spPr>
+            <c:extLst>
+              <c:ext xmlns:c16="http://schemas.microsoft.com/office/drawing/2014/chart" uri="{C3380CC4-5D6E-409C-BE32-E72D297353CC}">
+                <c16:uniqueId val="{00000003-1A1B-4A1A-A048-583FEE77A83A}"/>
+              </c:ext>
+            </c:extLst>
           </c:dPt>
           <c:dPt>
             <c:idx val="2"/>
             <c:invertIfNegative val="0"/>
             <c:bubble3D val="0"/>
-            <c:spPr>
-              <a:solidFill>
-                <a:srgbClr val="52525B"/>
-              </a:solidFill>
-              <a:effectLst/>
-            </c:spPr>
+            <c:extLst>
+              <c:ext xmlns:c16="http://schemas.microsoft.com/office/drawing/2014/chart" uri="{C3380CC4-5D6E-409C-BE32-E72D297353CC}">
+                <c16:uniqueId val="{00000005-1A1B-4A1A-A048-583FEE77A83A}"/>
+              </c:ext>
+            </c:extLst>
           </c:dPt>
           <c:dPt>
             <c:idx val="3"/>
@@ -285,28 +276,68 @@
               </a:solidFill>
               <a:effectLst/>
             </c:spPr>
+            <c:extLst>
+              <c:ext xmlns:c16="http://schemas.microsoft.com/office/drawing/2014/chart" uri="{C3380CC4-5D6E-409C-BE32-E72D297353CC}">
+                <c16:uniqueId val="{00000007-1A1B-4A1A-A048-583FEE77A83A}"/>
+              </c:ext>
+            </c:extLst>
           </c:dPt>
+          <c:dLbls>
+            <c:numFmt formatCode="0&quot;%&quot;" sourceLinked="0"/>
+            <c:spPr>
+              <a:noFill/>
+              <a:ln>
+                <a:noFill/>
+              </a:ln>
+              <a:effectLst/>
+            </c:spPr>
+            <c:txPr>
+              <a:bodyPr/>
+              <a:lstStyle/>
+              <a:p>
+                <a:pPr>
+                  <a:defRPr sz="1200" b="0" i="0" u="none" strike="noStrike">
+                    <a:solidFill>
+                      <a:srgbClr val="FAFAFA"/>
+                    </a:solidFill>
+                    <a:latin typeface="+mn-lt"/>
+                  </a:defRPr>
+                </a:pPr>
+                <a:endParaRPr lang="pl-PL"/>
+              </a:p>
+            </c:txPr>
+            <c:showLegendKey val="0"/>
+            <c:showVal val="1"/>
+            <c:showCatName val="0"/>
+            <c:showSerName val="0"/>
+            <c:showPercent val="0"/>
+            <c:showBubbleSize val="0"/>
+            <c:showLeaderLines val="0"/>
+            <c:extLst>
+              <c:ext xmlns:c15="http://schemas.microsoft.com/office/drawing/2012/chart" uri="{CE6537A1-D6FC-4f65-9D91-7224C49458BB}">
+                <c15:showLeaderLines val="0"/>
+              </c:ext>
+            </c:extLst>
+          </c:dLbls>
           <c:cat>
-            <c:multiLvlStrRef>
+            <c:strRef>
               <c:f>Sheet1!$A$2:$A$5</c:f>
-              <c:multiLvlStrCache>
+              <c:strCache>
                 <c:ptCount val="4"/>
-                <c:lvl>
-                  <c:pt idx="0">
-                    <c:v>6 średnich MN</c:v>
-                  </c:pt>
-                  <c:pt idx="1">
-                    <c:v>MN pojedynczo</c:v>
-                  </c:pt>
-                  <c:pt idx="2">
-                    <c:v>wzrok (VPN)</c:v>
-                  </c:pt>
-                  <c:pt idx="3">
-                    <c:v>DN lotu pojedynczo</c:v>
-                  </c:pt>
-                </c:lvl>
-              </c:multiLvlStrCache>
-            </c:multiLvlStrRef>
+                <c:pt idx="0">
+                  <c:v>6 średnich MN</c:v>
+                </c:pt>
+                <c:pt idx="1">
+                  <c:v>MN pojedynczo</c:v>
+                </c:pt>
+                <c:pt idx="2">
+                  <c:v>wzrok (VPN)</c:v>
+                </c:pt>
+                <c:pt idx="3">
+                  <c:v>DN lotu pojedynczo</c:v>
+                </c:pt>
+              </c:strCache>
+            </c:strRef>
           </c:cat>
           <c:val>
             <c:numRef>
@@ -329,36 +360,23 @@
               </c:numCache>
             </c:numRef>
           </c:val>
+          <c:extLst>
+            <c:ext xmlns:c16="http://schemas.microsoft.com/office/drawing/2014/chart" uri="{C3380CC4-5D6E-409C-BE32-E72D297353CC}">
+              <c16:uniqueId val="{00000008-1A1B-4A1A-A048-583FEE77A83A}"/>
+            </c:ext>
+          </c:extLst>
         </c:ser>
         <c:dLbls>
-          <c:numFmt formatCode="0&quot;%&quot;" sourceLinked="0"/>
-          <c:txPr>
-            <a:bodyPr/>
-            <a:lstStyle/>
-            <a:p>
-              <a:pPr>
-                <a:defRPr b="0" i="0" strike="noStrike" sz="1200" u="none">
-                  <a:solidFill>
-                    <a:srgbClr val="FAFAFA"/>
-                  </a:solidFill>
-                  <a:latin typeface="+mn-lt"/>
-                </a:defRPr>
-              </a:pPr>
-            </a:p>
-          </c:txPr>
           <c:showLegendKey val="0"/>
           <c:showVal val="1"/>
           <c:showCatName val="0"/>
           <c:showSerName val="0"/>
           <c:showPercent val="0"/>
           <c:showBubbleSize val="0"/>
-          <c:showLeaderLines val="0"/>
         </c:dLbls>
         <c:gapWidth val="150"/>
-        <c:overlap val="0"/>
         <c:axId val="2094734554"/>
         <c:axId val="2094734552"/>
-        <c:axId val="2094734556"/>
       </c:barChart>
       <c:catAx>
         <c:axId val="2094734554"/>
@@ -397,6 +415,7 @@
         <c:crosses val="autoZero"/>
         <c:auto val="1"/>
         <c:lblAlgn val="ctr"/>
+        <c:lblOffset val="100"/>
         <c:noMultiLvlLbl val="1"/>
       </c:catAx>
       <c:valAx>
@@ -412,30 +431,6 @@
         <c:majorTickMark val="out"/>
         <c:minorTickMark val="none"/>
         <c:tickLblPos val="low"/>
-        <c:spPr>
-          <a:ln w="12700" cap="flat">
-            <a:solidFill>
-              <a:srgbClr val="888888"/>
-            </a:solidFill>
-            <a:prstDash val="solid"/>
-            <a:round/>
-          </a:ln>
-        </c:spPr>
-        <c:txPr>
-          <a:bodyPr/>
-          <a:lstStyle/>
-          <a:p>
-            <a:pPr>
-              <a:defRPr sz="1200" b="0" i="0" u="none" strike="noStrike">
-                <a:solidFill>
-                  <a:srgbClr val="000000"/>
-                </a:solidFill>
-                <a:latin typeface="Arial"/>
-              </a:defRPr>
-            </a:pPr>
-            <a:endParaRPr lang="en-US"/>
-          </a:p>
-        </c:txPr>
         <c:crossAx val="2094734554"/>
         <c:crosses val="autoZero"/>
         <c:crossBetween val="between"/>
@@ -450,6 +445,7 @@
     </c:plotArea>
     <c:plotVisOnly val="1"/>
     <c:dispBlanksAs val="span"/>
+    <c:showDLblsOverMax val="1"/>
   </c:chart>
   <c:spPr>
     <a:noFill/>
@@ -465,9 +461,11 @@
 </file>
 
 <file path=ppt/charts/chart2.xml><?xml version="1.0" encoding="utf-8"?>
-<c:chartSpace xmlns:c="http://schemas.openxmlformats.org/drawingml/2006/chart" xmlns:a="http://schemas.openxmlformats.org/drawingml/2006/main" xmlns:r="http://schemas.openxmlformats.org/officeDocument/2006/relationships">
+<c:chartSpace xmlns:c="http://schemas.openxmlformats.org/drawingml/2006/chart" xmlns:a="http://schemas.openxmlformats.org/drawingml/2006/main" xmlns:r="http://schemas.openxmlformats.org/officeDocument/2006/relationships" xmlns:c16r2="http://schemas.microsoft.com/office/drawing/2015/06/chart">
   <c:date1904 val="0"/>
+  <c:lang val="en-US"/>
   <c:roundedCorners val="1"/>
+  <c:style val="2"/>
   <c:chart>
     <c:autoTitleDeleted val="1"/>
     <c:plotArea>
@@ -499,18 +497,26 @@
           <c:invertIfNegative val="0"/>
           <c:dLbls>
             <c:numFmt formatCode="0.0&quot;°&quot;" sourceLinked="0"/>
+            <c:spPr>
+              <a:noFill/>
+              <a:ln>
+                <a:noFill/>
+              </a:ln>
+              <a:effectLst/>
+            </c:spPr>
             <c:txPr>
               <a:bodyPr/>
               <a:lstStyle/>
               <a:p>
                 <a:pPr>
-                  <a:defRPr b="0" i="0" strike="noStrike" sz="1100" u="none">
+                  <a:defRPr sz="1100" b="0" i="0" u="none" strike="noStrike">
                     <a:solidFill>
                       <a:srgbClr val="FAFAFA"/>
                     </a:solidFill>
                     <a:latin typeface="+mn-lt"/>
                   </a:defRPr>
                 </a:pPr>
+                <a:endParaRPr lang="pl-PL"/>
               </a:p>
             </c:txPr>
             <c:showLegendKey val="0"/>
@@ -520,28 +526,31 @@
             <c:showPercent val="0"/>
             <c:showBubbleSize val="0"/>
             <c:showLeaderLines val="0"/>
+            <c:extLst>
+              <c:ext xmlns:c15="http://schemas.microsoft.com/office/drawing/2012/chart" uri="{CE6537A1-D6FC-4f65-9D91-7224C49458BB}">
+                <c15:showLeaderLines val="0"/>
+              </c:ext>
+            </c:extLst>
           </c:dLbls>
           <c:cat>
-            <c:multiLvlStrRef>
+            <c:strRef>
               <c:f>Sheet1!$A$2:$A$5</c:f>
-              <c:multiLvlStrCache>
+              <c:strCache>
                 <c:ptCount val="4"/>
-                <c:lvl>
-                  <c:pt idx="0">
-                    <c:v>cel −60°</c:v>
-                  </c:pt>
-                  <c:pt idx="1">
-                    <c:v>cel −30°</c:v>
-                  </c:pt>
-                  <c:pt idx="2">
-                    <c:v>cel +30°</c:v>
-                  </c:pt>
-                  <c:pt idx="3">
-                    <c:v>cel +60°</c:v>
-                  </c:pt>
-                </c:lvl>
-              </c:multiLvlStrCache>
-            </c:multiLvlStrRef>
+                <c:pt idx="0">
+                  <c:v>cel −60°</c:v>
+                </c:pt>
+                <c:pt idx="1">
+                  <c:v>cel −30°</c:v>
+                </c:pt>
+                <c:pt idx="2">
+                  <c:v>cel +30°</c:v>
+                </c:pt>
+                <c:pt idx="3">
+                  <c:v>cel +60°</c:v>
+                </c:pt>
+              </c:strCache>
+            </c:strRef>
           </c:cat>
           <c:val>
             <c:numRef>
@@ -564,6 +573,11 @@
               </c:numCache>
             </c:numRef>
           </c:val>
+          <c:extLst>
+            <c:ext xmlns:c16="http://schemas.microsoft.com/office/drawing/2014/chart" uri="{C3380CC4-5D6E-409C-BE32-E72D297353CC}">
+              <c16:uniqueId val="{00000000-176B-410A-A02C-EE2A4C1F5D0C}"/>
+            </c:ext>
+          </c:extLst>
         </c:ser>
         <c:ser>
           <c:idx val="1"/>
@@ -588,18 +602,26 @@
           <c:invertIfNegative val="0"/>
           <c:dLbls>
             <c:numFmt formatCode="0.0&quot;°&quot;" sourceLinked="0"/>
+            <c:spPr>
+              <a:noFill/>
+              <a:ln>
+                <a:noFill/>
+              </a:ln>
+              <a:effectLst/>
+            </c:spPr>
             <c:txPr>
               <a:bodyPr/>
               <a:lstStyle/>
               <a:p>
                 <a:pPr>
-                  <a:defRPr b="0" i="0" strike="noStrike" sz="1100" u="none">
+                  <a:defRPr sz="1100" b="0" i="0" u="none" strike="noStrike">
                     <a:solidFill>
                       <a:srgbClr val="FAFAFA"/>
                     </a:solidFill>
                     <a:latin typeface="+mn-lt"/>
                   </a:defRPr>
                 </a:pPr>
+                <a:endParaRPr lang="pl-PL"/>
               </a:p>
             </c:txPr>
             <c:showLegendKey val="0"/>
@@ -609,28 +631,31 @@
             <c:showPercent val="0"/>
             <c:showBubbleSize val="0"/>
             <c:showLeaderLines val="0"/>
+            <c:extLst>
+              <c:ext xmlns:c15="http://schemas.microsoft.com/office/drawing/2012/chart" uri="{CE6537A1-D6FC-4f65-9D91-7224C49458BB}">
+                <c15:showLeaderLines val="0"/>
+              </c:ext>
+            </c:extLst>
           </c:dLbls>
           <c:cat>
-            <c:multiLvlStrRef>
+            <c:strRef>
               <c:f>Sheet1!$A$2:$A$5</c:f>
-              <c:multiLvlStrCache>
+              <c:strCache>
                 <c:ptCount val="4"/>
-                <c:lvl>
-                  <c:pt idx="0">
-                    <c:v>cel −60°</c:v>
-                  </c:pt>
-                  <c:pt idx="1">
-                    <c:v>cel −30°</c:v>
-                  </c:pt>
-                  <c:pt idx="2">
-                    <c:v>cel +30°</c:v>
-                  </c:pt>
-                  <c:pt idx="3">
-                    <c:v>cel +60°</c:v>
-                  </c:pt>
-                </c:lvl>
-              </c:multiLvlStrCache>
-            </c:multiLvlStrRef>
+                <c:pt idx="0">
+                  <c:v>cel −60°</c:v>
+                </c:pt>
+                <c:pt idx="1">
+                  <c:v>cel −30°</c:v>
+                </c:pt>
+                <c:pt idx="2">
+                  <c:v>cel +30°</c:v>
+                </c:pt>
+                <c:pt idx="3">
+                  <c:v>cel +60°</c:v>
+                </c:pt>
+              </c:strCache>
+            </c:strRef>
           </c:cat>
           <c:val>
             <c:numRef>
@@ -645,44 +670,31 @@
                   <c:v>3.1</c:v>
                 </c:pt>
                 <c:pt idx="2">
-                  <c:v>2.3</c:v>
+                  <c:v>2.2999999999999998</c:v>
                 </c:pt>
                 <c:pt idx="3">
-                  <c:v>5.1</c:v>
+                  <c:v>5.0999999999999996</c:v>
                 </c:pt>
               </c:numCache>
             </c:numRef>
           </c:val>
+          <c:extLst>
+            <c:ext xmlns:c16="http://schemas.microsoft.com/office/drawing/2014/chart" uri="{C3380CC4-5D6E-409C-BE32-E72D297353CC}">
+              <c16:uniqueId val="{00000001-176B-410A-A02C-EE2A4C1F5D0C}"/>
+            </c:ext>
+          </c:extLst>
         </c:ser>
         <c:dLbls>
-          <c:numFmt formatCode="0.0&quot;°&quot;" sourceLinked="0"/>
-          <c:txPr>
-            <a:bodyPr/>
-            <a:lstStyle/>
-            <a:p>
-              <a:pPr>
-                <a:defRPr b="0" i="0" strike="noStrike" sz="1100" u="none">
-                  <a:solidFill>
-                    <a:srgbClr val="FAFAFA"/>
-                  </a:solidFill>
-                  <a:latin typeface="+mn-lt"/>
-                </a:defRPr>
-              </a:pPr>
-            </a:p>
-          </c:txPr>
           <c:showLegendKey val="0"/>
           <c:showVal val="1"/>
           <c:showCatName val="0"/>
           <c:showSerName val="0"/>
           <c:showPercent val="0"/>
           <c:showBubbleSize val="0"/>
-          <c:showLeaderLines val="0"/>
         </c:dLbls>
         <c:gapWidth val="60"/>
-        <c:overlap val="0"/>
         <c:axId val="2094734554"/>
         <c:axId val="2094734552"/>
-        <c:axId val="2094734556"/>
       </c:barChart>
       <c:catAx>
         <c:axId val="2094734554"/>
@@ -723,6 +735,7 @@
         <c:crosses val="autoZero"/>
         <c:auto val="1"/>
         <c:lblAlgn val="ctr"/>
+        <c:lblOffset val="100"/>
         <c:noMultiLvlLbl val="1"/>
       </c:catAx>
       <c:valAx>
@@ -736,30 +749,6 @@
         <c:majorTickMark val="out"/>
         <c:minorTickMark val="none"/>
         <c:tickLblPos val="nextTo"/>
-        <c:spPr>
-          <a:ln w="12700" cap="flat">
-            <a:solidFill>
-              <a:srgbClr val="888888"/>
-            </a:solidFill>
-            <a:prstDash val="solid"/>
-            <a:round/>
-          </a:ln>
-        </c:spPr>
-        <c:txPr>
-          <a:bodyPr/>
-          <a:lstStyle/>
-          <a:p>
-            <a:pPr>
-              <a:defRPr sz="1200" b="0" i="0" u="none" strike="noStrike">
-                <a:solidFill>
-                  <a:srgbClr val="000000"/>
-                </a:solidFill>
-                <a:latin typeface="Arial"/>
-              </a:defRPr>
-            </a:pPr>
-            <a:endParaRPr lang="en-US"/>
-          </a:p>
-        </c:txPr>
         <c:crossAx val="2094734554"/>
         <c:crosses val="autoZero"/>
         <c:crossBetween val="between"/>
@@ -794,6 +783,7 @@
     </c:legend>
     <c:plotVisOnly val="1"/>
     <c:dispBlanksAs val="span"/>
+    <c:showDLblsOverMax val="1"/>
   </c:chart>
   <c:spPr>
     <a:noFill/>
@@ -830,234 +820,10 @@
           <a:chExt cx="0" cy="0"/>
         </a:xfrm>
       </p:grpSpPr>
-      <p:sp>
-        <p:nvSpPr>
-          <p:cNvPr id="2" name="Header Placeholder 1"/>
-          <p:cNvSpPr>
-            <a:spLocks noGrp="1"/>
-          </p:cNvSpPr>
-          <p:nvPr>
-            <p:ph type="hdr" sz="quarter"/>
-          </p:nvPr>
-        </p:nvSpPr>
-        <p:spPr>
-          <a:xfrm>
-            <a:off x="0" y="0"/>
-            <a:ext cx="2971800" cy="458788"/>
-          </a:xfrm>
-          <a:prstGeom prst="rect">
-            <a:avLst/>
-          </a:prstGeom>
-        </p:spPr>
-        <p:txBody>
-          <a:bodyPr vert="horz" lIns="91440" tIns="45720" rIns="91440" bIns="45720" rtlCol="0"/>
-          <a:lstStyle>
-            <a:lvl1pPr algn="l">
-              <a:defRPr sz="1200"/>
-            </a:lvl1pPr>
-          </a:lstStyle>
-          <a:p>
-            <a:endParaRPr lang="en-US"/>
-          </a:p>
-        </p:txBody>
-      </p:sp>
-      <p:sp>
-        <p:nvSpPr>
-          <p:cNvPr id="3" name="Date Placeholder 2"/>
-          <p:cNvSpPr>
-            <a:spLocks noGrp="1"/>
-          </p:cNvSpPr>
-          <p:nvPr>
-            <p:ph type="dt" idx="1"/>
-          </p:nvPr>
-        </p:nvSpPr>
-        <p:spPr>
-          <a:xfrm>
-            <a:off x="3884613" y="0"/>
-            <a:ext cx="2971800" cy="458788"/>
-          </a:xfrm>
-          <a:prstGeom prst="rect">
-            <a:avLst/>
-          </a:prstGeom>
-        </p:spPr>
-        <p:txBody>
-          <a:bodyPr vert="horz" lIns="91440" tIns="45720" rIns="91440" bIns="45720" rtlCol="0"/>
-          <a:lstStyle>
-            <a:lvl1pPr algn="r">
-              <a:defRPr sz="1200"/>
-            </a:lvl1pPr>
-          </a:lstStyle>
-          <a:p>
-            <a:fld id="{5282F153-3F37-0F45-9E97-73ACFA13230C}" type="datetimeFigureOut">
-              <a:rPr lang="en-US"/>
-              <a:t>7/23/19</a:t>
-            </a:fld>
-            <a:endParaRPr lang="en-US"/>
-          </a:p>
-        </p:txBody>
-      </p:sp>
-      <p:sp>
-        <p:nvSpPr>
-          <p:cNvPr id="4" name="Slide Image Placeholder 3"/>
-          <p:cNvSpPr>
-            <a:spLocks noGrp="1" noRot="1" noChangeAspect="1"/>
-          </p:cNvSpPr>
-          <p:nvPr>
-            <p:ph type="sldImg" idx="2"/>
-          </p:nvPr>
-        </p:nvSpPr>
-        <p:spPr>
-          <a:xfrm>
-            <a:off x="685800" y="1143000"/>
-            <a:ext cx="5486400" cy="3086100"/>
-          </a:xfrm>
-          <a:prstGeom prst="rect">
-            <a:avLst/>
-          </a:prstGeom>
-          <a:noFill/>
-          <a:ln w="12700">
-            <a:solidFill>
-              <a:prstClr val="black"/>
-            </a:solidFill>
-          </a:ln>
-        </p:spPr>
-        <p:txBody>
-          <a:bodyPr vert="horz" lIns="91440" tIns="45720" rIns="91440" bIns="45720" rtlCol="0" anchor="ctr"/>
-          <a:lstStyle/>
-          <a:p>
-            <a:endParaRPr lang="en-US"/>
-          </a:p>
-        </p:txBody>
-      </p:sp>
-      <p:sp>
-        <p:nvSpPr>
-          <p:cNvPr id="5" name="Notes Placeholder 4"/>
-          <p:cNvSpPr>
-            <a:spLocks noGrp="1"/>
-          </p:cNvSpPr>
-          <p:nvPr>
-            <p:ph type="body" sz="quarter" idx="3"/>
-          </p:nvPr>
-        </p:nvSpPr>
-        <p:spPr>
-          <a:xfrm>
-            <a:off x="685800" y="4400550"/>
-            <a:ext cx="5486400" cy="3600450"/>
-          </a:xfrm>
-          <a:prstGeom prst="rect">
-            <a:avLst/>
-          </a:prstGeom>
-        </p:spPr>
-        <p:txBody>
-          <a:bodyPr vert="horz" lIns="91440" tIns="45720" rIns="91440" bIns="45720" rtlCol="0"/>
-          <a:lstStyle/>
-          <a:p>
-            <a:pPr lvl="0"/>
-            <a:r>
-              <a:rPr lang="en-US"/>
-              <a:t>Click to edit Master text styles</a:t>
-            </a:r>
-          </a:p>
-          <a:p>
-            <a:pPr lvl="1"/>
-            <a:r>
-              <a:rPr lang="en-US"/>
-              <a:t>Second level</a:t>
-            </a:r>
-          </a:p>
-          <a:p>
-            <a:pPr lvl="2"/>
-            <a:r>
-              <a:rPr lang="en-US"/>
-              <a:t>Third level</a:t>
-            </a:r>
-          </a:p>
-          <a:p>
-            <a:pPr lvl="3"/>
-            <a:r>
-              <a:rPr lang="en-US"/>
-              <a:t>Fourth level</a:t>
-            </a:r>
-          </a:p>
-          <a:p>
-            <a:pPr lvl="4"/>
-            <a:r>
-              <a:rPr lang="en-US"/>
-              <a:t>Fifth level</a:t>
-            </a:r>
-          </a:p>
-        </p:txBody>
-      </p:sp>
-      <p:sp>
-        <p:nvSpPr>
-          <p:cNvPr id="6" name="Footer Placeholder 5"/>
-          <p:cNvSpPr>
-            <a:spLocks noGrp="1"/>
-          </p:cNvSpPr>
-          <p:nvPr>
-            <p:ph type="ftr" sz="quarter" idx="4"/>
-          </p:nvPr>
-        </p:nvSpPr>
-        <p:spPr>
-          <a:xfrm>
-            <a:off x="0" y="8685213"/>
-            <a:ext cx="2971800" cy="458787"/>
-          </a:xfrm>
-          <a:prstGeom prst="rect">
-            <a:avLst/>
-          </a:prstGeom>
-        </p:spPr>
-        <p:txBody>
-          <a:bodyPr vert="horz" lIns="91440" tIns="45720" rIns="91440" bIns="45720" rtlCol="0" anchor="b"/>
-          <a:lstStyle>
-            <a:lvl1pPr algn="l">
-              <a:defRPr sz="1200"/>
-            </a:lvl1pPr>
-          </a:lstStyle>
-          <a:p>
-            <a:endParaRPr lang="en-US"/>
-          </a:p>
-        </p:txBody>
-      </p:sp>
-      <p:sp>
-        <p:nvSpPr>
-          <p:cNvPr id="7" name="Slide Number Placeholder 6"/>
-          <p:cNvSpPr>
-            <a:spLocks noGrp="1"/>
-          </p:cNvSpPr>
-          <p:nvPr>
-            <p:ph type="sldNum" sz="quarter" idx="5"/>
-          </p:nvPr>
-        </p:nvSpPr>
-        <p:spPr>
-          <a:xfrm>
-            <a:off x="3884613" y="8685213"/>
-            <a:ext cx="2971800" cy="458787"/>
-          </a:xfrm>
-          <a:prstGeom prst="rect">
-            <a:avLst/>
-          </a:prstGeom>
-        </p:spPr>
-        <p:txBody>
-          <a:bodyPr vert="horz" lIns="91440" tIns="45720" rIns="91440" bIns="45720" rtlCol="0" anchor="b"/>
-          <a:lstStyle>
-            <a:lvl1pPr algn="r">
-              <a:defRPr sz="1200"/>
-            </a:lvl1pPr>
-          </a:lstStyle>
-          <a:p>
-            <a:fld id="{CE5E9CC1-C706-0F49-92D6-E571CC5EEA8F}" type="slidenum">
-              <a:rPr lang="en-US"/>
-              <a:t>‹#›</a:t>
-            </a:fld>
-            <a:endParaRPr lang="en-US"/>
-          </a:p>
-        </p:txBody>
-      </p:sp>
     </p:spTree>
     <p:extLst>
       <p:ext uri="{BB962C8B-B14F-4D97-AF65-F5344CB8AC3E}">
-        <p14:creationId xmlns:p14="http://schemas.microsoft.com/office/powerpoint/2010/main" val="1024086991"/>
+        <p14:creationId xmlns:p14="http://schemas.microsoft.com/office/powerpoint/2010/main" val="4160350180"/>
       </p:ext>
     </p:extLst>
   </p:cSld>
@@ -1205,7 +971,6 @@
               <a:rPr lang="en-US" dirty="0"/>
               <a:t>NeuroFly: obraz z kamer drona przechodzi przez model oka muszki (FlyVis), potem przez prawdziwy connectome Drosophila (BANC v888, mózg + brzuszny łańcuch nerwowy), a aktywność neuronów lotu steruje dronem w symulatorze. Render: półprzezroczyste ciało NeuroMechFly (FlyGym) z connectomem BANC w środku — dopasowanie ciała ilustracyjne.</a:t>
             </a:r>
-            <a:endParaRPr lang="en-US" dirty="0"/>
           </a:p>
         </p:txBody>
       </p:sp>
@@ -1289,10 +1054,6 @@
           <a:bodyPr/>
           <a:lstStyle/>
           <a:p>
-            <a:r>
-              <a:rPr lang="en-US" dirty="0"/>
-              <a:t/>
-            </a:r>
             <a:endParaRPr lang="en-US" dirty="0"/>
           </a:p>
         </p:txBody>
@@ -1377,10 +1138,6 @@
           <a:bodyPr/>
           <a:lstStyle/>
           <a:p>
-            <a:r>
-              <a:rPr lang="en-US" dirty="0"/>
-              <a:t/>
-            </a:r>
             <a:endParaRPr lang="en-US" dirty="0"/>
           </a:p>
         </p:txBody>
@@ -1465,10 +1222,6 @@
           <a:bodyPr/>
           <a:lstStyle/>
           <a:p>
-            <a:r>
-              <a:rPr lang="en-US" dirty="0"/>
-              <a:t/>
-            </a:r>
             <a:endParaRPr lang="en-US" dirty="0"/>
           </a:p>
         </p:txBody>
@@ -1553,10 +1306,6 @@
           <a:bodyPr/>
           <a:lstStyle/>
           <a:p>
-            <a:r>
-              <a:rPr lang="en-US" dirty="0"/>
-              <a:t/>
-            </a:r>
             <a:endParaRPr lang="en-US" dirty="0"/>
           </a:p>
         </p:txBody>
@@ -1641,10 +1390,6 @@
           <a:bodyPr/>
           <a:lstStyle/>
           <a:p>
-            <a:r>
-              <a:rPr lang="en-US" dirty="0"/>
-              <a:t/>
-            </a:r>
             <a:endParaRPr lang="en-US" dirty="0"/>
           </a:p>
         </p:txBody>
@@ -1729,10 +1474,6 @@
           <a:bodyPr/>
           <a:lstStyle/>
           <a:p>
-            <a:r>
-              <a:rPr lang="en-US" dirty="0"/>
-              <a:t/>
-            </a:r>
             <a:endParaRPr lang="en-US" dirty="0"/>
           </a:p>
         </p:txBody>
@@ -1821,7 +1562,6 @@
               <a:rPr lang="en-US" dirty="0"/>
               <a:t>Każda klatka obrazu przechodzi przez całą pętlę ~30 razy na sekundę. Nic nie jest ręcznie zaprogramowanym regulatorem kursu: kierunek do celu odczytujemy z aktywności neuronów zstępujących (DN) w BANC.</a:t>
             </a:r>
-            <a:endParaRPr lang="en-US" dirty="0"/>
           </a:p>
         </p:txBody>
       </p:sp>
@@ -1909,7 +1649,6 @@
               <a:rPr lang="en-US" dirty="0"/>
               <a:t>Górny rząd: wszystko, co dzieje się przed connectomem. Dolny: connectome, odczyt neuronów lotu, dekoder i dron. Jedna klatka (FlyVis + 4 podkroki dynamiki BANC na GPU) to ~15–20 ms.</a:t>
             </a:r>
-            <a:endParaRPr lang="en-US" dirty="0"/>
           </a:p>
         </p:txBody>
       </p:sp>
@@ -1997,7 +1736,6 @@
               <a:rPr lang="en-US" dirty="0"/>
               <a:t>Cel (czarny słup) jest po prawej stronie: widać go tylko w prawym oku, jako ciemną kolumnę ommatidiów.</a:t>
             </a:r>
-            <a:endParaRPr lang="en-US" dirty="0"/>
           </a:p>
         </p:txBody>
       </p:sp>
@@ -2085,7 +1823,6 @@
               <a:rPr lang="en-US" dirty="0"/>
               <a:t>Oficjalny BANC v888 (Bates et al. 2026, publiczny bucket Lee Lab). Somy z kolumny position; kolory jak w eksploratorze: wzrok teal, interneurony fiolet, DN amber, motoneurony rose. Żadnych syntetycznych grafów.</a:t>
             </a:r>
-            <a:endParaRPr lang="en-US" dirty="0"/>
           </a:p>
         </p:txBody>
       </p:sp>
@@ -2169,10 +1906,6 @@
           <a:bodyPr/>
           <a:lstStyle/>
           <a:p>
-            <a:r>
-              <a:rPr lang="en-US" dirty="0"/>
-              <a:t/>
-            </a:r>
             <a:endParaRPr lang="en-US" dirty="0"/>
           </a:p>
         </p:txBody>
@@ -2257,10 +1990,6 @@
           <a:bodyPr/>
           <a:lstStyle/>
           <a:p>
-            <a:r>
-              <a:rPr lang="en-US" dirty="0"/>
-              <a:t/>
-            </a:r>
             <a:endParaRPr lang="en-US" dirty="0"/>
           </a:p>
         </p:txBody>
@@ -2349,7 +2078,6 @@
               <a:rPr lang="en-US" dirty="0"/>
               <a:t>Regresja grzbietowa kąt ~ aktywność, cel pod kątami −90…+90° w 3 odległościach, walidacja na odległości pominiętej w uczeniu (scripts/check_side_decoding.py).</a:t>
             </a:r>
-            <a:endParaRPr lang="en-US" dirty="0"/>
           </a:p>
         </p:txBody>
       </p:sp>
@@ -2433,10 +2161,6 @@
           <a:bodyPr/>
           <a:lstStyle/>
           <a:p>
-            <a:r>
-              <a:rPr lang="en-US" dirty="0"/>
-              <a:t/>
-            </a:r>
             <a:endParaRPr lang="en-US" dirty="0"/>
           </a:p>
         </p:txBody>
@@ -2515,6 +2239,7 @@
         <a:solidFill>
           <a:srgbClr val="09090B"/>
         </a:solidFill>
+        <a:effectLst/>
       </p:bgPr>
     </p:bg>
     <p:spTree>
@@ -2547,6 +2272,7 @@
         <a:solidFill>
           <a:srgbClr val="09090B"/>
         </a:solidFill>
+        <a:effectLst/>
       </p:bgPr>
     </p:bg>
     <p:spTree>
@@ -2565,14 +2291,14 @@
       </p:grpSpPr>
       <p:pic>
         <p:nvPicPr>
-          <p:cNvPr id="2" name="Image 0" descr="C:\NeuroFly\docs\prezentacja\assets\logo.png">    </p:cNvPr>
+          <p:cNvPr id="2" name="Image 0" descr="C:\NeuroFly\docs\prezentacja\assets\logo.png"/>
           <p:cNvPicPr>
             <a:picLocks noChangeAspect="1"/>
           </p:cNvPicPr>
           <p:nvPr/>
         </p:nvPicPr>
         <p:blipFill>
-          <a:blip r:embed="rId1"/>
+          <a:blip r:embed="rId2"/>
           <a:stretch>
             <a:fillRect/>
           </a:stretch>
@@ -2608,7 +2334,7 @@
           <a:bodyPr wrap="square" lIns="0" tIns="0" rIns="0" bIns="0" rtlCol="0" anchor="ctr"/>
           <a:lstStyle/>
           <a:p>
-            <a:pPr indent="0" marL="0">
+            <a:pPr marL="0" indent="0">
               <a:buNone/>
             </a:pPr>
             <a:r>
@@ -2626,9 +2352,11 @@
       <p:sp>
         <p:nvSpPr>
           <p:cNvPr id="4" name="Text 1"/>
-          <p:cNvSpPr/>
+          <p:cNvSpPr>
+            <a:spLocks noGrp="1"/>
+          </p:cNvSpPr>
           <p:nvPr>
-            <p:ph idx="102" type="title" hasCustomPrompt="1"/>
+            <p:ph type="title" idx="102" hasCustomPrompt="1"/>
           </p:nvPr>
         </p:nvSpPr>
         <p:spPr>
@@ -2645,7 +2373,7 @@
         <p:txBody>
           <a:bodyPr wrap="square" rtlCol="0"/>
           <a:lstStyle>
-            <a:lvl1pPr algn="l" indent="0" marL="0">
+            <a:lvl1pPr marL="0" indent="0" algn="l">
               <a:buNone/>
               <a:defRPr lang="en-US" sz="2800" b="1" dirty="0">
                 <a:solidFill>
@@ -2655,7 +2383,7 @@
             </a:lvl1pPr>
           </a:lstStyle>
           <a:p>
-            <a:pPr algn="l" indent="0" marL="0">
+            <a:pPr marL="0" indent="0" algn="l">
               <a:buNone/>
             </a:pPr>
             <a:endParaRPr lang="en-US" sz="2800" dirty="0"/>
@@ -2682,7 +2410,7 @@
           </a:prstGeom>
           <a:extLst>
             <a:ext uri="{C572A759-6A51-4108-AA02-DFA0A04FC94B}">
-              <ma14:wrappingTextBoxFlag xmlns:ma14="http://schemas.microsoft.com/office/mac/drawingml/2011/main" val="0"/>
+              <ma14:wrappingTextBoxFlag xmlns:ma14="http://schemas.microsoft.com/office/mac/drawingml/2011/main" xmlns="" val="0"/>
             </a:ext>
           </a:extLst>
         </p:spPr>
@@ -2700,8 +2428,8 @@
           <a:p>
             <a:pPr algn="r"/>
             <a:fld id="{F7021451-1387-4CA6-816F-3879F97B5CBC}" type="slidenum">
-              <a:rPr b="0" lang="en-US"/>
-              <a:t>1003</a:t>
+              <a:rPr lang="en-US" b="0"/>
+              <a:t>‹#›</a:t>
             </a:fld>
             <a:endParaRPr lang="en-US"/>
           </a:p>
@@ -2718,6 +2446,11 @@
 <file path=ppt/slideMasters/slideMaster1.xml><?xml version="1.0" encoding="utf-8"?>
 <p:sldMaster xmlns:a="http://schemas.openxmlformats.org/drawingml/2006/main" xmlns:r="http://schemas.openxmlformats.org/officeDocument/2006/relationships" xmlns:p="http://schemas.openxmlformats.org/presentationml/2006/main">
   <p:cSld>
+    <p:bg>
+      <p:bgRef idx="1001">
+        <a:schemeClr val="bg1"/>
+      </p:bgRef>
+    </p:bg>
     <p:spTree>
       <p:nvGrpSpPr>
         <p:cNvPr id="1" name=""/>
@@ -2752,7 +2485,7 @@
           </a:prstGeom>
           <a:extLst>
             <a:ext uri="{C572A759-6A51-4108-AA02-DFA0A04FC94B}">
-              <ma14:wrappingTextBoxFlag xmlns:ma14="http://schemas.microsoft.com/office/mac/drawingml/2011/main" val="0"/>
+              <ma14:wrappingTextBoxFlag xmlns:ma14="http://schemas.microsoft.com/office/mac/drawingml/2011/main" xmlns="" val="0"/>
             </a:ext>
           </a:extLst>
         </p:spPr>
@@ -2770,8 +2503,8 @@
           <a:p>
             <a:pPr algn="r"/>
             <a:fld id="{F7021451-1387-4CA6-816F-3879F97B5CBC}" type="slidenum">
-              <a:rPr b="0" lang="en-US"/>
-              <a:t>null</a:t>
+              <a:rPr lang="en-US" b="0"/>
+              <a:t>‹#›</a:t>
             </a:fld>
             <a:endParaRPr lang="en-US"/>
           </a:p>
@@ -3058,14 +2791,14 @@
       </p:grpSpPr>
       <p:pic>
         <p:nvPicPr>
-          <p:cNvPr id="2" name="render-fly-xray" descr="C:\NeuroFly\docs\prezentacja\assets\fly_xray.jpg">    </p:cNvPr>
+          <p:cNvPr id="2" name="render-fly-xray" descr="C:\NeuroFly\docs\prezentacja\assets\fly_xray.jpg"/>
           <p:cNvPicPr>
             <a:picLocks noChangeAspect="1"/>
           </p:cNvPicPr>
           <p:nvPr/>
         </p:nvPicPr>
         <p:blipFill>
-          <a:blip r:embed="rId1"/>
+          <a:blip r:embed="rId3"/>
           <a:stretch>
             <a:fillRect/>
           </a:stretch>
@@ -3082,14 +2815,14 @@
       </p:pic>
       <p:pic>
         <p:nvPicPr>
-          <p:cNvPr id="3" name="logo" descr="C:\NeuroFly\docs\prezentacja\assets\logo.png">    </p:cNvPr>
+          <p:cNvPr id="3" name="logo" descr="C:\NeuroFly\docs\prezentacja\assets\logo.png"/>
           <p:cNvPicPr>
             <a:picLocks noChangeAspect="1"/>
           </p:cNvPicPr>
           <p:nvPr/>
         </p:nvPicPr>
         <p:blipFill>
-          <a:blip r:embed="rId2"/>
+          <a:blip r:embed="rId4"/>
           <a:stretch>
             <a:fillRect/>
           </a:stretch>
@@ -3125,7 +2858,7 @@
           <a:bodyPr wrap="square" lIns="0" tIns="0" rIns="0" bIns="0" rtlCol="0" anchor="t"/>
           <a:lstStyle/>
           <a:p>
-            <a:pPr indent="0" marL="0">
+            <a:pPr marL="0" indent="0">
               <a:buNone/>
             </a:pPr>
             <a:r>
@@ -3161,7 +2894,7 @@
           <a:bodyPr wrap="square" lIns="0" tIns="0" rIns="0" bIns="0" rtlCol="0" anchor="t"/>
           <a:lstStyle/>
           <a:p>
-            <a:pPr indent="0" marL="0">
+            <a:pPr marL="0" indent="0">
               <a:buNone/>
             </a:pPr>
             <a:r>
@@ -3175,7 +2908,7 @@
             <a:endParaRPr lang="en-US" sz="2000" dirty="0"/>
           </a:p>
           <a:p>
-            <a:pPr indent="0" marL="0">
+            <a:pPr marL="0" indent="0">
               <a:buNone/>
             </a:pPr>
             <a:r>
@@ -3211,7 +2944,7 @@
           <a:bodyPr wrap="square" lIns="0" tIns="0" rIns="0" bIns="0" rtlCol="0" anchor="t"/>
           <a:lstStyle/>
           <a:p>
-            <a:pPr indent="0" marL="0">
+            <a:pPr marL="0" indent="0">
               <a:buNone/>
             </a:pPr>
             <a:r>
@@ -3254,9 +2987,11 @@
       <p:sp>
         <p:nvSpPr>
           <p:cNvPr id="2" name="Text 1"/>
-          <p:cNvSpPr/>
+          <p:cNvSpPr>
+            <a:spLocks noGrp="1"/>
+          </p:cNvSpPr>
           <p:nvPr>
-            <p:ph idx="102" type="title" hasCustomPrompt="1"/>
+            <p:ph type="title" idx="102" hasCustomPrompt="1"/>
           </p:nvPr>
         </p:nvSpPr>
         <p:spPr>
@@ -3274,7 +3009,7 @@
           <a:bodyPr wrap="square" lIns="0" tIns="0" rIns="0" bIns="0" rtlCol="0" anchor="t"/>
           <a:lstStyle/>
           <a:p>
-            <a:pPr algn="l" indent="0" marL="0">
+            <a:pPr marL="0" indent="0" algn="l">
               <a:buNone/>
             </a:pPr>
             <a:r>
@@ -3291,14 +3026,14 @@
       </p:sp>
       <p:pic>
         <p:nvPicPr>
-          <p:cNvPr id="3" name="img-drone" descr="C:\NeuroFly\docs\prezentacja\assets\drone_chase.jpg">    </p:cNvPr>
+          <p:cNvPr id="3" name="img-drone" descr="C:\NeuroFly\docs\prezentacja\assets\drone_chase.jpg"/>
           <p:cNvPicPr>
             <a:picLocks noChangeAspect="1"/>
           </p:cNvPicPr>
           <p:nvPr/>
         </p:nvPicPr>
         <p:blipFill>
-          <a:blip r:embed="rId1"/>
+          <a:blip r:embed="rId3"/>
           <a:stretch>
             <a:fillRect/>
           </a:stretch>
@@ -3312,7 +3047,7 @@
             <a:avLst/>
           </a:prstGeom>
           <a:effectLst>
-            <a:outerShdw sx="100000" sy="100000" kx="0" ky="0" algn="bl" rotWithShape="0" blurRad="228600" dist="76200" dir="5400000">
+            <a:outerShdw blurRad="228600" dist="76200" dir="5400000" algn="bl" rotWithShape="0">
               <a:srgbClr val="000000">
                 <a:alpha val="55000"/>
               </a:srgbClr>
@@ -3322,14 +3057,14 @@
       </p:pic>
       <p:pic>
         <p:nvPicPr>
-          <p:cNvPr id="4" name="img-world" descr="C:\NeuroFly\docs\prezentacja\assets\world.jpg">    </p:cNvPr>
+          <p:cNvPr id="4" name="img-world" descr="C:\NeuroFly\docs\prezentacja\assets\world.jpg"/>
           <p:cNvPicPr>
             <a:picLocks noChangeAspect="1"/>
           </p:cNvPicPr>
           <p:nvPr/>
         </p:nvPicPr>
         <p:blipFill>
-          <a:blip r:embed="rId2"/>
+          <a:blip r:embed="rId4"/>
           <a:stretch>
             <a:fillRect/>
           </a:stretch>
@@ -3343,7 +3078,7 @@
             <a:avLst/>
           </a:prstGeom>
           <a:effectLst>
-            <a:outerShdw sx="100000" sy="100000" kx="0" ky="0" algn="bl" rotWithShape="0" blurRad="228600" dist="76200" dir="5400000">
+            <a:outerShdw blurRad="228600" dist="76200" dir="5400000" algn="bl" rotWithShape="0">
               <a:srgbClr val="000000">
                 <a:alpha val="55000"/>
               </a:srgbClr>
@@ -3372,7 +3107,7 @@
           <a:bodyPr wrap="square" lIns="0" tIns="0" rIns="0" bIns="0" rtlCol="0" anchor="t"/>
           <a:lstStyle/>
           <a:p>
-            <a:pPr indent="0" marL="0">
+            <a:pPr marL="0" indent="0">
               <a:buNone/>
             </a:pPr>
             <a:r>
@@ -3408,7 +3143,7 @@
           <a:bodyPr wrap="square" lIns="0" tIns="0" rIns="0" bIns="0" rtlCol="0" anchor="t"/>
           <a:lstStyle/>
           <a:p>
-            <a:pPr indent="0" marL="0">
+            <a:pPr marL="0" indent="0">
               <a:buNone/>
             </a:pPr>
             <a:r>
@@ -3443,7 +3178,7 @@
           </a:prstGeom>
           <a:extLst>
             <a:ext uri="{C572A759-6A51-4108-AA02-DFA0A04FC94B}">
-              <ma14:wrappingTextBoxFlag xmlns:ma14="http://schemas.microsoft.com/office/mac/drawingml/2011/main" val="0"/>
+              <ma14:wrappingTextBoxFlag xmlns:ma14="http://schemas.microsoft.com/office/mac/drawingml/2011/main" xmlns="" val="0"/>
             </a:ext>
           </a:extLst>
         </p:spPr>
@@ -3461,7 +3196,7 @@
           <a:p>
             <a:pPr algn="r"/>
             <a:fld id="{F7021451-1387-4CA6-816F-3879F97B5CBC}" type="slidenum">
-              <a:rPr b="0" lang="en-US"/>
+              <a:rPr lang="en-US" b="0"/>
               <a:t>10</a:t>
             </a:fld>
             <a:endParaRPr lang="en-US"/>
@@ -3496,9 +3231,11 @@
       <p:sp>
         <p:nvSpPr>
           <p:cNvPr id="2" name="Text 1"/>
-          <p:cNvSpPr/>
+          <p:cNvSpPr>
+            <a:spLocks noGrp="1"/>
+          </p:cNvSpPr>
           <p:nvPr>
-            <p:ph idx="102" type="title" hasCustomPrompt="1"/>
+            <p:ph type="title" idx="102" hasCustomPrompt="1"/>
           </p:nvPr>
         </p:nvSpPr>
         <p:spPr>
@@ -3516,7 +3253,7 @@
           <a:bodyPr wrap="square" lIns="0" tIns="0" rIns="0" bIns="0" rtlCol="0" anchor="t"/>
           <a:lstStyle/>
           <a:p>
-            <a:pPr algn="l" indent="0" marL="0">
+            <a:pPr marL="0" indent="0" algn="l">
               <a:buNone/>
             </a:pPr>
             <a:r>
@@ -3557,7 +3294,7 @@
             <a:prstDash val="solid"/>
           </a:ln>
           <a:effectLst>
-            <a:outerShdw sx="100000" sy="100000" kx="0" ky="0" algn="bl" rotWithShape="0" blurRad="228600" dist="76200" dir="5400000">
+            <a:outerShdw blurRad="228600" dist="76200" dir="5400000" algn="bl" rotWithShape="0">
               <a:srgbClr val="000000">
                 <a:alpha val="55000"/>
               </a:srgbClr>
@@ -3586,7 +3323,7 @@
           <a:bodyPr wrap="square" lIns="0" tIns="0" rIns="0" bIns="0" rtlCol="0" anchor="t"/>
           <a:lstStyle/>
           <a:p>
-            <a:pPr indent="0" marL="0">
+            <a:pPr marL="0" indent="0">
               <a:buNone/>
             </a:pPr>
             <a:r>
@@ -3622,7 +3359,7 @@
           <a:bodyPr wrap="square" lIns="0" tIns="0" rIns="0" bIns="0" rtlCol="0" anchor="t"/>
           <a:lstStyle/>
           <a:p>
-            <a:pPr indent="0" marL="0">
+            <a:pPr marL="0" indent="0">
               <a:buNone/>
             </a:pPr>
             <a:r>
@@ -3658,7 +3395,7 @@
           <a:bodyPr wrap="square" lIns="0" tIns="0" rIns="0" bIns="0" rtlCol="0" anchor="t"/>
           <a:lstStyle/>
           <a:p>
-            <a:pPr indent="0" marL="0">
+            <a:pPr marL="0" indent="0">
               <a:buNone/>
             </a:pPr>
             <a:r>
@@ -3699,7 +3436,7 @@
             <a:prstDash val="solid"/>
           </a:ln>
           <a:effectLst>
-            <a:outerShdw sx="100000" sy="100000" kx="0" ky="0" algn="bl" rotWithShape="0" blurRad="228600" dist="76200" dir="5400000">
+            <a:outerShdw blurRad="228600" dist="76200" dir="5400000" algn="bl" rotWithShape="0">
               <a:srgbClr val="000000">
                 <a:alpha val="55000"/>
               </a:srgbClr>
@@ -3728,7 +3465,7 @@
           <a:bodyPr wrap="square" lIns="0" tIns="0" rIns="0" bIns="0" rtlCol="0" anchor="t"/>
           <a:lstStyle/>
           <a:p>
-            <a:pPr indent="0" marL="0">
+            <a:pPr marL="0" indent="0">
               <a:buNone/>
             </a:pPr>
             <a:r>
@@ -3764,7 +3501,7 @@
           <a:bodyPr wrap="square" lIns="0" tIns="0" rIns="0" bIns="0" rtlCol="0" anchor="t"/>
           <a:lstStyle/>
           <a:p>
-            <a:pPr indent="0" marL="0">
+            <a:pPr marL="0" indent="0">
               <a:buNone/>
             </a:pPr>
             <a:r>
@@ -3800,7 +3537,7 @@
           <a:bodyPr wrap="square" lIns="0" tIns="0" rIns="0" bIns="0" rtlCol="0" anchor="t"/>
           <a:lstStyle/>
           <a:p>
-            <a:pPr indent="0" marL="0">
+            <a:pPr marL="0" indent="0">
               <a:buNone/>
             </a:pPr>
             <a:r>
@@ -3841,7 +3578,7 @@
             <a:prstDash val="solid"/>
           </a:ln>
           <a:effectLst>
-            <a:outerShdw sx="100000" sy="100000" kx="0" ky="0" algn="bl" rotWithShape="0" blurRad="228600" dist="76200" dir="5400000">
+            <a:outerShdw blurRad="228600" dist="76200" dir="5400000" algn="bl" rotWithShape="0">
               <a:srgbClr val="000000">
                 <a:alpha val="55000"/>
               </a:srgbClr>
@@ -3870,7 +3607,7 @@
           <a:bodyPr wrap="square" lIns="0" tIns="0" rIns="0" bIns="0" rtlCol="0" anchor="t"/>
           <a:lstStyle/>
           <a:p>
-            <a:pPr indent="0" marL="0">
+            <a:pPr marL="0" indent="0">
               <a:buNone/>
             </a:pPr>
             <a:r>
@@ -3906,7 +3643,7 @@
           <a:bodyPr wrap="square" lIns="0" tIns="0" rIns="0" bIns="0" rtlCol="0" anchor="t"/>
           <a:lstStyle/>
           <a:p>
-            <a:pPr indent="0" marL="0">
+            <a:pPr marL="0" indent="0">
               <a:buNone/>
             </a:pPr>
             <a:r>
@@ -3942,7 +3679,7 @@
           <a:bodyPr wrap="square" lIns="0" tIns="0" rIns="0" bIns="0" rtlCol="0" anchor="t"/>
           <a:lstStyle/>
           <a:p>
-            <a:pPr indent="0" marL="0">
+            <a:pPr marL="0" indent="0">
               <a:buNone/>
             </a:pPr>
             <a:r>
@@ -3983,7 +3720,7 @@
             <a:prstDash val="solid"/>
           </a:ln>
           <a:effectLst>
-            <a:outerShdw sx="100000" sy="100000" kx="0" ky="0" algn="bl" rotWithShape="0" blurRad="228600" dist="76200" dir="5400000">
+            <a:outerShdw blurRad="228600" dist="76200" dir="5400000" algn="bl" rotWithShape="0">
               <a:srgbClr val="000000">
                 <a:alpha val="55000"/>
               </a:srgbClr>
@@ -4012,7 +3749,7 @@
           <a:bodyPr wrap="square" lIns="0" tIns="0" rIns="0" bIns="0" rtlCol="0" anchor="t"/>
           <a:lstStyle/>
           <a:p>
-            <a:pPr indent="0" marL="0">
+            <a:pPr marL="0" indent="0">
               <a:buNone/>
             </a:pPr>
             <a:r>
@@ -4048,7 +3785,7 @@
           <a:bodyPr wrap="square" lIns="0" tIns="0" rIns="0" bIns="0" rtlCol="0" anchor="t"/>
           <a:lstStyle/>
           <a:p>
-            <a:pPr indent="0" marL="0">
+            <a:pPr marL="0" indent="0">
               <a:buNone/>
             </a:pPr>
             <a:r>
@@ -4084,7 +3821,7 @@
           <a:bodyPr wrap="square" lIns="0" tIns="0" rIns="0" bIns="0" rtlCol="0" anchor="t"/>
           <a:lstStyle/>
           <a:p>
-            <a:pPr indent="0" marL="0">
+            <a:pPr marL="0" indent="0">
               <a:buNone/>
             </a:pPr>
             <a:r>
@@ -4125,7 +3862,7 @@
             <a:prstDash val="solid"/>
           </a:ln>
           <a:effectLst>
-            <a:outerShdw sx="100000" sy="100000" kx="0" ky="0" algn="bl" rotWithShape="0" blurRad="228600" dist="76200" dir="5400000">
+            <a:outerShdw blurRad="228600" dist="76200" dir="5400000" algn="bl" rotWithShape="0">
               <a:srgbClr val="000000">
                 <a:alpha val="55000"/>
               </a:srgbClr>
@@ -4154,7 +3891,7 @@
           <a:bodyPr wrap="square" lIns="0" tIns="0" rIns="0" bIns="0" rtlCol="0" anchor="t"/>
           <a:lstStyle/>
           <a:p>
-            <a:pPr indent="0" marL="0">
+            <a:pPr marL="0" indent="0">
               <a:buNone/>
             </a:pPr>
             <a:r>
@@ -4215,7 +3952,7 @@
           <a:bodyPr wrap="square" lIns="0" tIns="0" rIns="0" bIns="0" rtlCol="0" anchor="t"/>
           <a:lstStyle/>
           <a:p>
-            <a:pPr indent="0" marL="0">
+            <a:pPr marL="0" indent="0">
               <a:buNone/>
             </a:pPr>
             <a:r>
@@ -4276,7 +4013,7 @@
           <a:bodyPr wrap="square" lIns="0" tIns="0" rIns="0" bIns="0" rtlCol="0" anchor="t"/>
           <a:lstStyle/>
           <a:p>
-            <a:pPr indent="0" marL="0">
+            <a:pPr marL="0" indent="0">
               <a:buNone/>
             </a:pPr>
             <a:r>
@@ -4317,7 +4054,7 @@
             <a:prstDash val="solid"/>
           </a:ln>
           <a:effectLst>
-            <a:outerShdw sx="100000" sy="100000" kx="0" ky="0" algn="bl" rotWithShape="0" blurRad="228600" dist="76200" dir="5400000">
+            <a:outerShdw blurRad="228600" dist="76200" dir="5400000" algn="bl" rotWithShape="0">
               <a:srgbClr val="000000">
                 <a:alpha val="55000"/>
               </a:srgbClr>
@@ -4346,7 +4083,7 @@
           <a:bodyPr wrap="square" lIns="0" tIns="0" rIns="0" bIns="0" rtlCol="0" anchor="t"/>
           <a:lstStyle/>
           <a:p>
-            <a:pPr indent="0" marL="0">
+            <a:pPr marL="0" indent="0">
               <a:buNone/>
             </a:pPr>
             <a:r>
@@ -4382,7 +4119,7 @@
           <a:bodyPr wrap="square" lIns="0" tIns="0" rIns="0" bIns="0" rtlCol="0" anchor="t"/>
           <a:lstStyle/>
           <a:p>
-            <a:pPr indent="0" marL="0">
+            <a:pPr marL="0" indent="0">
               <a:buNone/>
             </a:pPr>
             <a:r>
@@ -4399,7 +4136,7 @@
       </p:sp>
       <p:sp>
         <p:nvSpPr>
-          <p:cNvPr id="25" name="Slide Number Placeholder 0"/>
+          <p:cNvPr id="28" name="Slide Number Placeholder 0"/>
           <p:cNvSpPr>
             <a:spLocks noGrp="1"/>
           </p:cNvSpPr>
@@ -4417,7 +4154,7 @@
           </a:prstGeom>
           <a:extLst>
             <a:ext uri="{C572A759-6A51-4108-AA02-DFA0A04FC94B}">
-              <ma14:wrappingTextBoxFlag xmlns:ma14="http://schemas.microsoft.com/office/mac/drawingml/2011/main" val="0"/>
+              <ma14:wrappingTextBoxFlag xmlns:ma14="http://schemas.microsoft.com/office/mac/drawingml/2011/main" xmlns="" val="0"/>
             </a:ext>
           </a:extLst>
         </p:spPr>
@@ -4435,7 +4172,7 @@
           <a:p>
             <a:pPr algn="r"/>
             <a:fld id="{F7021451-1387-4CA6-816F-3879F97B5CBC}" type="slidenum">
-              <a:rPr b="0" lang="en-US"/>
+              <a:rPr lang="en-US" b="0"/>
               <a:t>11</a:t>
             </a:fld>
             <a:endParaRPr lang="en-US"/>
@@ -4470,9 +4207,11 @@
       <p:sp>
         <p:nvSpPr>
           <p:cNvPr id="2" name="Text 1"/>
-          <p:cNvSpPr/>
+          <p:cNvSpPr>
+            <a:spLocks noGrp="1"/>
+          </p:cNvSpPr>
           <p:nvPr>
-            <p:ph idx="102" type="title" hasCustomPrompt="1"/>
+            <p:ph type="title" idx="102" hasCustomPrompt="1"/>
           </p:nvPr>
         </p:nvSpPr>
         <p:spPr>
@@ -4490,7 +4229,7 @@
           <a:bodyPr wrap="square" lIns="0" tIns="0" rIns="0" bIns="0" rtlCol="0" anchor="t"/>
           <a:lstStyle/>
           <a:p>
-            <a:pPr algn="l" indent="0" marL="0">
+            <a:pPr marL="0" indent="0" algn="l">
               <a:buNone/>
             </a:pPr>
             <a:r>
@@ -4507,7 +4246,7 @@
       </p:sp>
       <p:graphicFrame>
         <p:nvGraphicFramePr>
-          <p:cNvPr id="3" name="chart-eval" descr=""/>
+          <p:cNvPr id="3" name="chart-eval"/>
           <p:cNvGraphicFramePr/>
           <p:nvPr/>
         </p:nvGraphicFramePr>
@@ -4515,9 +4254,9 @@
           <a:off x="457200" y="1097280"/>
           <a:ext cx="5303520" cy="3383280"/>
         </p:xfrm>
-        <a:graphic xmlns:a="http://schemas.openxmlformats.org/drawingml/2006/main">
+        <a:graphic>
           <a:graphicData uri="http://schemas.openxmlformats.org/drawingml/2006/chart">
-            <c:chart xmlns:c="http://schemas.openxmlformats.org/drawingml/2006/chart" r:id="rId1"/>
+            <c:chart xmlns:c="http://schemas.openxmlformats.org/drawingml/2006/chart" xmlns:r="http://schemas.openxmlformats.org/officeDocument/2006/relationships" r:id="rId3"/>
           </a:graphicData>
         </a:graphic>
       </p:graphicFrame>
@@ -4542,7 +4281,7 @@
           <a:bodyPr wrap="square" lIns="0" tIns="0" rIns="0" bIns="0" rtlCol="0" anchor="t"/>
           <a:lstStyle/>
           <a:p>
-            <a:pPr indent="0" marL="0">
+            <a:pPr marL="0" indent="0">
               <a:buNone/>
             </a:pPr>
             <a:r>
@@ -4578,7 +4317,7 @@
           <a:bodyPr wrap="square" lIns="0" tIns="0" rIns="0" bIns="0" rtlCol="0" anchor="t"/>
           <a:lstStyle/>
           <a:p>
-            <a:pPr indent="0" marL="0">
+            <a:pPr marL="0" indent="0">
               <a:buNone/>
             </a:pPr>
             <a:r>
@@ -4614,7 +4353,7 @@
           <a:bodyPr wrap="square" lIns="0" tIns="0" rIns="0" bIns="0" rtlCol="0" anchor="t"/>
           <a:lstStyle/>
           <a:p>
-            <a:pPr indent="0" marL="0">
+            <a:pPr marL="0" indent="0">
               <a:buNone/>
             </a:pPr>
             <a:r>
@@ -4650,7 +4389,7 @@
           <a:bodyPr wrap="square" lIns="0" tIns="0" rIns="0" bIns="0" rtlCol="0" anchor="t"/>
           <a:lstStyle/>
           <a:p>
-            <a:pPr indent="0" marL="0">
+            <a:pPr marL="0" indent="0">
               <a:buNone/>
             </a:pPr>
             <a:r>
@@ -4686,7 +4425,7 @@
           <a:bodyPr wrap="square" lIns="0" tIns="0" rIns="0" bIns="0" rtlCol="0" anchor="t"/>
           <a:lstStyle/>
           <a:p>
-            <a:pPr indent="0" marL="0">
+            <a:pPr marL="0" indent="0">
               <a:buNone/>
             </a:pPr>
             <a:r>
@@ -4721,7 +4460,7 @@
           </a:prstGeom>
           <a:extLst>
             <a:ext uri="{C572A759-6A51-4108-AA02-DFA0A04FC94B}">
-              <ma14:wrappingTextBoxFlag xmlns:ma14="http://schemas.microsoft.com/office/mac/drawingml/2011/main" val="0"/>
+              <ma14:wrappingTextBoxFlag xmlns:ma14="http://schemas.microsoft.com/office/mac/drawingml/2011/main" xmlns="" val="0"/>
             </a:ext>
           </a:extLst>
         </p:spPr>
@@ -4739,7 +4478,7 @@
           <a:p>
             <a:pPr algn="r"/>
             <a:fld id="{F7021451-1387-4CA6-816F-3879F97B5CBC}" type="slidenum">
-              <a:rPr b="0" lang="en-US"/>
+              <a:rPr lang="en-US" b="0"/>
               <a:t>12</a:t>
             </a:fld>
             <a:endParaRPr lang="en-US"/>
@@ -4774,9 +4513,11 @@
       <p:sp>
         <p:nvSpPr>
           <p:cNvPr id="2" name="Text 1"/>
-          <p:cNvSpPr/>
+          <p:cNvSpPr>
+            <a:spLocks noGrp="1"/>
+          </p:cNvSpPr>
           <p:nvPr>
-            <p:ph idx="102" type="title" hasCustomPrompt="1"/>
+            <p:ph type="title" idx="102" hasCustomPrompt="1"/>
           </p:nvPr>
         </p:nvSpPr>
         <p:spPr>
@@ -4794,7 +4535,7 @@
           <a:bodyPr wrap="square" lIns="0" tIns="0" rIns="0" bIns="0" rtlCol="0" anchor="t"/>
           <a:lstStyle/>
           <a:p>
-            <a:pPr algn="l" indent="0" marL="0">
+            <a:pPr marL="0" indent="0" algn="l">
               <a:buNone/>
             </a:pPr>
             <a:r>
@@ -4835,7 +4576,7 @@
             <a:prstDash val="solid"/>
           </a:ln>
           <a:effectLst>
-            <a:outerShdw sx="100000" sy="100000" kx="0" ky="0" algn="bl" rotWithShape="0" blurRad="228600" dist="76200" dir="5400000">
+            <a:outerShdw blurRad="228600" dist="76200" dir="5400000" algn="bl" rotWithShape="0">
               <a:srgbClr val="000000">
                 <a:alpha val="55000"/>
               </a:srgbClr>
@@ -4869,7 +4610,7 @@
             <a:prstDash val="solid"/>
           </a:ln>
           <a:effectLst>
-            <a:outerShdw sx="100000" sy="100000" kx="0" ky="0" algn="bl" rotWithShape="0" blurRad="228600" dist="76200" dir="5400000">
+            <a:outerShdw blurRad="228600" dist="76200" dir="5400000" algn="bl" rotWithShape="0">
               <a:srgbClr val="000000">
                 <a:alpha val="55000"/>
               </a:srgbClr>
@@ -4903,7 +4644,7 @@
             <a:prstDash val="solid"/>
           </a:ln>
           <a:effectLst>
-            <a:outerShdw sx="100000" sy="100000" kx="0" ky="0" algn="bl" rotWithShape="0" blurRad="228600" dist="76200" dir="5400000">
+            <a:outerShdw blurRad="228600" dist="76200" dir="5400000" algn="bl" rotWithShape="0">
               <a:srgbClr val="000000">
                 <a:alpha val="55000"/>
               </a:srgbClr>
@@ -4932,7 +4673,7 @@
           <a:bodyPr wrap="square" lIns="0" tIns="0" rIns="0" bIns="0" rtlCol="0" anchor="t"/>
           <a:lstStyle/>
           <a:p>
-            <a:pPr indent="0" marL="0">
+            <a:pPr marL="0" indent="0">
               <a:buNone/>
             </a:pPr>
             <a:r>
@@ -4968,7 +4709,7 @@
           <a:bodyPr wrap="square" lIns="0" tIns="0" rIns="0" bIns="0" rtlCol="0" anchor="t"/>
           <a:lstStyle/>
           <a:p>
-            <a:pPr indent="0" marL="0">
+            <a:pPr marL="0" indent="0">
               <a:buNone/>
             </a:pPr>
             <a:r>
@@ -5004,7 +4745,7 @@
           <a:bodyPr wrap="square" lIns="0" tIns="0" rIns="0" bIns="0" rtlCol="0" anchor="t"/>
           <a:lstStyle/>
           <a:p>
-            <a:pPr indent="0" marL="0">
+            <a:pPr marL="0" indent="0">
               <a:buNone/>
             </a:pPr>
             <a:r>
@@ -5040,7 +4781,7 @@
           <a:bodyPr wrap="square" lIns="0" tIns="0" rIns="0" bIns="0" rtlCol="0" anchor="t"/>
           <a:lstStyle/>
           <a:p>
-            <a:pPr indent="0" marL="0">
+            <a:pPr marL="0" indent="0">
               <a:buNone/>
             </a:pPr>
             <a:r>
@@ -5076,7 +4817,7 @@
           <a:bodyPr wrap="square" lIns="0" tIns="0" rIns="0" bIns="0" rtlCol="0" anchor="t"/>
           <a:lstStyle/>
           <a:p>
-            <a:pPr indent="0" marL="0">
+            <a:pPr marL="0" indent="0">
               <a:buNone/>
             </a:pPr>
             <a:r>
@@ -5112,7 +4853,7 @@
           <a:bodyPr wrap="square" lIns="0" tIns="0" rIns="0" bIns="0" rtlCol="0" anchor="t"/>
           <a:lstStyle/>
           <a:p>
-            <a:pPr indent="0" marL="0">
+            <a:pPr marL="0" indent="0">
               <a:buNone/>
             </a:pPr>
             <a:r>
@@ -5148,7 +4889,7 @@
           <a:bodyPr wrap="square" lIns="0" tIns="0" rIns="0" bIns="0" rtlCol="0" anchor="t"/>
           <a:lstStyle/>
           <a:p>
-            <a:pPr indent="0" marL="0">
+            <a:pPr marL="0" indent="0">
               <a:buNone/>
             </a:pPr>
             <a:r>
@@ -5183,7 +4924,7 @@
           </a:prstGeom>
           <a:extLst>
             <a:ext uri="{C572A759-6A51-4108-AA02-DFA0A04FC94B}">
-              <ma14:wrappingTextBoxFlag xmlns:ma14="http://schemas.microsoft.com/office/mac/drawingml/2011/main" val="0"/>
+              <ma14:wrappingTextBoxFlag xmlns:ma14="http://schemas.microsoft.com/office/mac/drawingml/2011/main" xmlns="" val="0"/>
             </a:ext>
           </a:extLst>
         </p:spPr>
@@ -5201,7 +4942,7 @@
           <a:p>
             <a:pPr algn="r"/>
             <a:fld id="{F7021451-1387-4CA6-816F-3879F97B5CBC}" type="slidenum">
-              <a:rPr b="0" lang="en-US"/>
+              <a:rPr lang="en-US" b="0"/>
               <a:t>13</a:t>
             </a:fld>
             <a:endParaRPr lang="en-US"/>
@@ -5236,9 +4977,11 @@
       <p:sp>
         <p:nvSpPr>
           <p:cNvPr id="2" name="Text 1"/>
-          <p:cNvSpPr/>
+          <p:cNvSpPr>
+            <a:spLocks noGrp="1"/>
+          </p:cNvSpPr>
           <p:nvPr>
-            <p:ph idx="102" type="title" hasCustomPrompt="1"/>
+            <p:ph type="title" idx="102" hasCustomPrompt="1"/>
           </p:nvPr>
         </p:nvSpPr>
         <p:spPr>
@@ -5256,7 +4999,7 @@
           <a:bodyPr wrap="square" lIns="0" tIns="0" rIns="0" bIns="0" rtlCol="0" anchor="t"/>
           <a:lstStyle/>
           <a:p>
-            <a:pPr algn="l" indent="0" marL="0">
+            <a:pPr marL="0" indent="0" algn="l">
               <a:buNone/>
             </a:pPr>
             <a:r>
@@ -5297,7 +5040,7 @@
             <a:prstDash val="solid"/>
           </a:ln>
           <a:effectLst>
-            <a:outerShdw sx="100000" sy="100000" kx="0" ky="0" algn="bl" rotWithShape="0" blurRad="228600" dist="76200" dir="5400000">
+            <a:outerShdw blurRad="228600" dist="76200" dir="5400000" algn="bl" rotWithShape="0">
               <a:srgbClr val="000000">
                 <a:alpha val="55000"/>
               </a:srgbClr>
@@ -5331,7 +5074,7 @@
             <a:prstDash val="solid"/>
           </a:ln>
           <a:effectLst>
-            <a:outerShdw sx="100000" sy="100000" kx="0" ky="0" algn="bl" rotWithShape="0" blurRad="228600" dist="76200" dir="5400000">
+            <a:outerShdw blurRad="228600" dist="76200" dir="5400000" algn="bl" rotWithShape="0">
               <a:srgbClr val="000000">
                 <a:alpha val="55000"/>
               </a:srgbClr>
@@ -5385,7 +5128,7 @@
           <a:bodyPr wrap="square" lIns="0" tIns="0" rIns="0" bIns="0" rtlCol="0" anchor="t"/>
           <a:lstStyle/>
           <a:p>
-            <a:pPr indent="0" marL="0">
+            <a:pPr marL="0" indent="0">
               <a:buNone/>
             </a:pPr>
             <a:r>
@@ -5446,7 +5189,7 @@
           <a:bodyPr wrap="square" lIns="0" tIns="0" rIns="0" bIns="0" rtlCol="0" anchor="t"/>
           <a:lstStyle/>
           <a:p>
-            <a:pPr indent="0" marL="0">
+            <a:pPr marL="0" indent="0">
               <a:buNone/>
             </a:pPr>
             <a:r>
@@ -5687,7 +5430,7 @@
           </a:prstGeom>
           <a:extLst>
             <a:ext uri="{C572A759-6A51-4108-AA02-DFA0A04FC94B}">
-              <ma14:wrappingTextBoxFlag xmlns:ma14="http://schemas.microsoft.com/office/mac/drawingml/2011/main" val="0"/>
+              <ma14:wrappingTextBoxFlag xmlns:ma14="http://schemas.microsoft.com/office/mac/drawingml/2011/main" xmlns="" val="0"/>
             </a:ext>
           </a:extLst>
         </p:spPr>
@@ -5705,7 +5448,7 @@
           <a:p>
             <a:pPr algn="r"/>
             <a:fld id="{F7021451-1387-4CA6-816F-3879F97B5CBC}" type="slidenum">
-              <a:rPr b="0" lang="en-US"/>
+              <a:rPr lang="en-US" b="0"/>
               <a:t>14</a:t>
             </a:fld>
             <a:endParaRPr lang="en-US"/>
@@ -5739,14 +5482,14 @@
       </p:grpSpPr>
       <p:pic>
         <p:nvPicPr>
-          <p:cNvPr id="2" name="render-bg" descr="C:\NeuroFly\docs\prezentacja\assets\connectome_wide.jpg">    </p:cNvPr>
+          <p:cNvPr id="2" name="render-bg" descr="C:\NeuroFly\docs\prezentacja\assets\connectome_wide.jpg"/>
           <p:cNvPicPr>
             <a:picLocks noChangeAspect="1"/>
           </p:cNvPicPr>
           <p:nvPr/>
         </p:nvPicPr>
         <p:blipFill>
-          <a:blip r:embed="rId1">
+          <a:blip r:embed="rId3">
             <a:alphaModFix amt="65000"/>
           </a:blip>
           <a:stretch>
@@ -5765,14 +5508,14 @@
       </p:pic>
       <p:pic>
         <p:nvPicPr>
-          <p:cNvPr id="3" name="logo" descr="C:\NeuroFly\docs\prezentacja\assets\logo.png">    </p:cNvPr>
+          <p:cNvPr id="3" name="logo" descr="C:\NeuroFly\docs\prezentacja\assets\logo.png"/>
           <p:cNvPicPr>
             <a:picLocks noChangeAspect="1"/>
           </p:cNvPicPr>
           <p:nvPr/>
         </p:nvPicPr>
         <p:blipFill>
-          <a:blip r:embed="rId2"/>
+          <a:blip r:embed="rId4"/>
           <a:stretch>
             <a:fillRect/>
           </a:stretch>
@@ -5808,7 +5551,7 @@
           <a:bodyPr wrap="square" lIns="0" tIns="0" rIns="0" bIns="0" rtlCol="0" anchor="t"/>
           <a:lstStyle/>
           <a:p>
-            <a:pPr indent="0" marL="0">
+            <a:pPr marL="0" indent="0">
               <a:buNone/>
             </a:pPr>
             <a:r>
@@ -5844,7 +5587,7 @@
           <a:bodyPr wrap="square" lIns="0" tIns="0" rIns="0" bIns="0" rtlCol="0" anchor="t"/>
           <a:lstStyle/>
           <a:p>
-            <a:pPr indent="0" marL="0">
+            <a:pPr marL="0" indent="0">
               <a:buNone/>
             </a:pPr>
             <a:r>
@@ -5858,7 +5601,7 @@
             <a:endParaRPr lang="en-US" sz="1600" dirty="0"/>
           </a:p>
           <a:p>
-            <a:pPr indent="0" marL="0">
+            <a:pPr marL="0" indent="0">
               <a:buNone/>
             </a:pPr>
             <a:r>
@@ -5894,7 +5637,7 @@
           <a:bodyPr wrap="square" lIns="0" tIns="0" rIns="0" bIns="0" rtlCol="0" anchor="t"/>
           <a:lstStyle/>
           <a:p>
-            <a:pPr indent="0" marL="0">
+            <a:pPr marL="0" indent="0">
               <a:buNone/>
             </a:pPr>
             <a:r>
@@ -5937,9 +5680,11 @@
       <p:sp>
         <p:nvSpPr>
           <p:cNvPr id="2" name="Text 1"/>
-          <p:cNvSpPr/>
+          <p:cNvSpPr>
+            <a:spLocks noGrp="1"/>
+          </p:cNvSpPr>
           <p:nvPr>
-            <p:ph idx="102" type="title" hasCustomPrompt="1"/>
+            <p:ph type="title" idx="102" hasCustomPrompt="1"/>
           </p:nvPr>
         </p:nvSpPr>
         <p:spPr>
@@ -5957,7 +5702,7 @@
           <a:bodyPr wrap="square" lIns="0" tIns="0" rIns="0" bIns="0" rtlCol="0" anchor="t"/>
           <a:lstStyle/>
           <a:p>
-            <a:pPr algn="l" indent="0" marL="0">
+            <a:pPr marL="0" indent="0" algn="l">
               <a:buNone/>
             </a:pPr>
             <a:r>
@@ -5998,7 +5743,7 @@
             <a:prstDash val="solid"/>
           </a:ln>
           <a:effectLst>
-            <a:outerShdw sx="100000" sy="100000" kx="0" ky="0" algn="bl" rotWithShape="0" blurRad="228600" dist="76200" dir="5400000">
+            <a:outerShdw blurRad="228600" dist="76200" dir="5400000" algn="bl" rotWithShape="0">
               <a:srgbClr val="000000">
                 <a:alpha val="55000"/>
               </a:srgbClr>
@@ -6052,7 +5797,7 @@
           <a:bodyPr wrap="square" lIns="0" tIns="0" rIns="0" bIns="0" rtlCol="0" anchor="t"/>
           <a:lstStyle/>
           <a:p>
-            <a:pPr indent="0" marL="0">
+            <a:pPr marL="0" indent="0">
               <a:buNone/>
             </a:pPr>
             <a:r>
@@ -6088,7 +5833,7 @@
           <a:bodyPr wrap="square" lIns="0" tIns="0" rIns="0" bIns="0" rtlCol="0" anchor="t"/>
           <a:lstStyle/>
           <a:p>
-            <a:pPr indent="0" marL="0">
+            <a:pPr marL="0" indent="0">
               <a:buNone/>
             </a:pPr>
             <a:r>
@@ -6129,7 +5874,7 @@
             <a:prstDash val="solid"/>
           </a:ln>
           <a:effectLst>
-            <a:outerShdw sx="100000" sy="100000" kx="0" ky="0" algn="bl" rotWithShape="0" blurRad="228600" dist="76200" dir="5400000">
+            <a:outerShdw blurRad="228600" dist="76200" dir="5400000" algn="bl" rotWithShape="0">
               <a:srgbClr val="000000">
                 <a:alpha val="55000"/>
               </a:srgbClr>
@@ -6183,7 +5928,7 @@
           <a:bodyPr wrap="square" lIns="0" tIns="0" rIns="0" bIns="0" rtlCol="0" anchor="t"/>
           <a:lstStyle/>
           <a:p>
-            <a:pPr indent="0" marL="0">
+            <a:pPr marL="0" indent="0">
               <a:buNone/>
             </a:pPr>
             <a:r>
@@ -6219,7 +5964,7 @@
           <a:bodyPr wrap="square" lIns="0" tIns="0" rIns="0" bIns="0" rtlCol="0" anchor="t"/>
           <a:lstStyle/>
           <a:p>
-            <a:pPr indent="0" marL="0">
+            <a:pPr marL="0" indent="0">
               <a:buNone/>
             </a:pPr>
             <a:r>
@@ -6260,7 +6005,7 @@
             <a:prstDash val="solid"/>
           </a:ln>
           <a:effectLst>
-            <a:outerShdw sx="100000" sy="100000" kx="0" ky="0" algn="bl" rotWithShape="0" blurRad="228600" dist="76200" dir="5400000">
+            <a:outerShdw blurRad="228600" dist="76200" dir="5400000" algn="bl" rotWithShape="0">
               <a:srgbClr val="000000">
                 <a:alpha val="55000"/>
               </a:srgbClr>
@@ -6314,7 +6059,7 @@
           <a:bodyPr wrap="square" lIns="0" tIns="0" rIns="0" bIns="0" rtlCol="0" anchor="t"/>
           <a:lstStyle/>
           <a:p>
-            <a:pPr indent="0" marL="0">
+            <a:pPr marL="0" indent="0">
               <a:buNone/>
             </a:pPr>
             <a:r>
@@ -6350,7 +6095,7 @@
           <a:bodyPr wrap="square" lIns="0" tIns="0" rIns="0" bIns="0" rtlCol="0" anchor="t"/>
           <a:lstStyle/>
           <a:p>
-            <a:pPr indent="0" marL="0">
+            <a:pPr marL="0" indent="0">
               <a:buNone/>
             </a:pPr>
             <a:r>
@@ -6391,7 +6136,7 @@
             <a:prstDash val="solid"/>
           </a:ln>
           <a:effectLst>
-            <a:outerShdw sx="100000" sy="100000" kx="0" ky="0" algn="bl" rotWithShape="0" blurRad="228600" dist="76200" dir="5400000">
+            <a:outerShdw blurRad="228600" dist="76200" dir="5400000" algn="bl" rotWithShape="0">
               <a:srgbClr val="000000">
                 <a:alpha val="55000"/>
               </a:srgbClr>
@@ -6445,7 +6190,7 @@
           <a:bodyPr wrap="square" lIns="0" tIns="0" rIns="0" bIns="0" rtlCol="0" anchor="t"/>
           <a:lstStyle/>
           <a:p>
-            <a:pPr indent="0" marL="0">
+            <a:pPr marL="0" indent="0">
               <a:buNone/>
             </a:pPr>
             <a:r>
@@ -6481,7 +6226,7 @@
           <a:bodyPr wrap="square" lIns="0" tIns="0" rIns="0" bIns="0" rtlCol="0" anchor="t"/>
           <a:lstStyle/>
           <a:p>
-            <a:pPr indent="0" marL="0">
+            <a:pPr marL="0" indent="0">
               <a:buNone/>
             </a:pPr>
             <a:r>
@@ -6498,14 +6243,14 @@
       </p:sp>
       <p:pic>
         <p:nvPicPr>
-          <p:cNvPr id="19" name="logo-center" descr="C:\NeuroFly\docs\prezentacja\assets\logo.png">    </p:cNvPr>
+          <p:cNvPr id="19" name="logo-center" descr="C:\NeuroFly\docs\prezentacja\assets\logo.png"/>
           <p:cNvPicPr>
             <a:picLocks noChangeAspect="1"/>
           </p:cNvPicPr>
           <p:nvPr/>
         </p:nvPicPr>
         <p:blipFill>
-          <a:blip r:embed="rId1"/>
+          <a:blip r:embed="rId3"/>
           <a:stretch>
             <a:fillRect/>
           </a:stretch>
@@ -6540,7 +6285,7 @@
           </a:prstGeom>
           <a:extLst>
             <a:ext uri="{C572A759-6A51-4108-AA02-DFA0A04FC94B}">
-              <ma14:wrappingTextBoxFlag xmlns:ma14="http://schemas.microsoft.com/office/mac/drawingml/2011/main" val="0"/>
+              <ma14:wrappingTextBoxFlag xmlns:ma14="http://schemas.microsoft.com/office/mac/drawingml/2011/main" xmlns="" val="0"/>
             </a:ext>
           </a:extLst>
         </p:spPr>
@@ -6558,7 +6303,7 @@
           <a:p>
             <a:pPr algn="r"/>
             <a:fld id="{F7021451-1387-4CA6-816F-3879F97B5CBC}" type="slidenum">
-              <a:rPr b="0" lang="en-US"/>
+              <a:rPr lang="en-US" b="0"/>
               <a:t>2</a:t>
             </a:fld>
             <a:endParaRPr lang="en-US"/>
@@ -6593,9 +6338,11 @@
       <p:sp>
         <p:nvSpPr>
           <p:cNvPr id="2" name="Text 1"/>
-          <p:cNvSpPr/>
+          <p:cNvSpPr>
+            <a:spLocks noGrp="1"/>
+          </p:cNvSpPr>
           <p:nvPr>
-            <p:ph idx="102" type="title" hasCustomPrompt="1"/>
+            <p:ph type="title" idx="102" hasCustomPrompt="1"/>
           </p:nvPr>
         </p:nvSpPr>
         <p:spPr>
@@ -6613,7 +6360,7 @@
           <a:bodyPr wrap="square" lIns="0" tIns="0" rIns="0" bIns="0" rtlCol="0" anchor="t"/>
           <a:lstStyle/>
           <a:p>
-            <a:pPr algn="l" indent="0" marL="0">
+            <a:pPr marL="0" indent="0" algn="l">
               <a:buNone/>
             </a:pPr>
             <a:r>
@@ -6654,7 +6401,7 @@
             <a:prstDash val="solid"/>
           </a:ln>
           <a:effectLst>
-            <a:outerShdw sx="100000" sy="100000" kx="0" ky="0" algn="bl" rotWithShape="0" blurRad="228600" dist="76200" dir="5400000">
+            <a:outerShdw blurRad="228600" dist="76200" dir="5400000" algn="bl" rotWithShape="0">
               <a:srgbClr val="000000">
                 <a:alpha val="55000"/>
               </a:srgbClr>
@@ -6708,7 +6455,7 @@
           <a:bodyPr wrap="square" lIns="0" tIns="0" rIns="0" bIns="0" rtlCol="0" anchor="t"/>
           <a:lstStyle/>
           <a:p>
-            <a:pPr indent="0" marL="0">
+            <a:pPr marL="0" indent="0">
               <a:buNone/>
             </a:pPr>
             <a:r>
@@ -6744,7 +6491,7 @@
           <a:bodyPr wrap="square" lIns="0" tIns="0" rIns="0" bIns="0" rtlCol="0" anchor="t"/>
           <a:lstStyle/>
           <a:p>
-            <a:pPr indent="0" marL="0">
+            <a:pPr marL="0" indent="0">
               <a:buNone/>
             </a:pPr>
             <a:r>
@@ -6809,7 +6556,7 @@
             <a:prstDash val="solid"/>
           </a:ln>
           <a:effectLst>
-            <a:outerShdw sx="100000" sy="100000" kx="0" ky="0" algn="bl" rotWithShape="0" blurRad="228600" dist="76200" dir="5400000">
+            <a:outerShdw blurRad="228600" dist="76200" dir="5400000" algn="bl" rotWithShape="0">
               <a:srgbClr val="000000">
                 <a:alpha val="55000"/>
               </a:srgbClr>
@@ -6863,7 +6610,7 @@
           <a:bodyPr wrap="square" lIns="0" tIns="0" rIns="0" bIns="0" rtlCol="0" anchor="t"/>
           <a:lstStyle/>
           <a:p>
-            <a:pPr indent="0" marL="0">
+            <a:pPr marL="0" indent="0">
               <a:buNone/>
             </a:pPr>
             <a:r>
@@ -6899,7 +6646,7 @@
           <a:bodyPr wrap="square" lIns="0" tIns="0" rIns="0" bIns="0" rtlCol="0" anchor="t"/>
           <a:lstStyle/>
           <a:p>
-            <a:pPr indent="0" marL="0">
+            <a:pPr marL="0" indent="0">
               <a:buNone/>
             </a:pPr>
             <a:r>
@@ -6964,7 +6711,7 @@
             <a:prstDash val="solid"/>
           </a:ln>
           <a:effectLst>
-            <a:outerShdw sx="100000" sy="100000" kx="0" ky="0" algn="bl" rotWithShape="0" blurRad="228600" dist="76200" dir="5400000">
+            <a:outerShdw blurRad="228600" dist="76200" dir="5400000" algn="bl" rotWithShape="0">
               <a:srgbClr val="000000">
                 <a:alpha val="55000"/>
               </a:srgbClr>
@@ -7018,7 +6765,7 @@
           <a:bodyPr wrap="square" lIns="0" tIns="0" rIns="0" bIns="0" rtlCol="0" anchor="t"/>
           <a:lstStyle/>
           <a:p>
-            <a:pPr indent="0" marL="0">
+            <a:pPr marL="0" indent="0">
               <a:buNone/>
             </a:pPr>
             <a:r>
@@ -7054,7 +6801,7 @@
           <a:bodyPr wrap="square" lIns="0" tIns="0" rIns="0" bIns="0" rtlCol="0" anchor="t"/>
           <a:lstStyle/>
           <a:p>
-            <a:pPr indent="0" marL="0">
+            <a:pPr marL="0" indent="0">
               <a:buNone/>
             </a:pPr>
             <a:r>
@@ -7119,7 +6866,7 @@
             <a:prstDash val="solid"/>
           </a:ln>
           <a:effectLst>
-            <a:outerShdw sx="100000" sy="100000" kx="0" ky="0" algn="bl" rotWithShape="0" blurRad="228600" dist="76200" dir="5400000">
+            <a:outerShdw blurRad="228600" dist="76200" dir="5400000" algn="bl" rotWithShape="0">
               <a:srgbClr val="000000">
                 <a:alpha val="55000"/>
               </a:srgbClr>
@@ -7173,7 +6920,7 @@
           <a:bodyPr wrap="square" lIns="0" tIns="0" rIns="0" bIns="0" rtlCol="0" anchor="t"/>
           <a:lstStyle/>
           <a:p>
-            <a:pPr indent="0" marL="0">
+            <a:pPr marL="0" indent="0">
               <a:buNone/>
             </a:pPr>
             <a:r>
@@ -7209,7 +6956,7 @@
           <a:bodyPr wrap="square" lIns="0" tIns="0" rIns="0" bIns="0" rtlCol="0" anchor="t"/>
           <a:lstStyle/>
           <a:p>
-            <a:pPr indent="0" marL="0">
+            <a:pPr marL="0" indent="0">
               <a:buNone/>
             </a:pPr>
             <a:r>
@@ -7250,7 +6997,7 @@
             <a:prstDash val="solid"/>
           </a:ln>
           <a:effectLst>
-            <a:outerShdw sx="100000" sy="100000" kx="0" ky="0" algn="bl" rotWithShape="0" blurRad="228600" dist="76200" dir="5400000">
+            <a:outerShdw blurRad="228600" dist="76200" dir="5400000" algn="bl" rotWithShape="0">
               <a:srgbClr val="000000">
                 <a:alpha val="55000"/>
               </a:srgbClr>
@@ -7304,7 +7051,7 @@
           <a:bodyPr wrap="square" lIns="0" tIns="0" rIns="0" bIns="0" rtlCol="0" anchor="t"/>
           <a:lstStyle/>
           <a:p>
-            <a:pPr indent="0" marL="0">
+            <a:pPr marL="0" indent="0">
               <a:buNone/>
             </a:pPr>
             <a:r>
@@ -7340,7 +7087,7 @@
           <a:bodyPr wrap="square" lIns="0" tIns="0" rIns="0" bIns="0" rtlCol="0" anchor="t"/>
           <a:lstStyle/>
           <a:p>
-            <a:pPr indent="0" marL="0">
+            <a:pPr marL="0" indent="0">
               <a:buNone/>
             </a:pPr>
             <a:r>
@@ -7405,7 +7152,7 @@
             <a:prstDash val="solid"/>
           </a:ln>
           <a:effectLst>
-            <a:outerShdw sx="100000" sy="100000" kx="0" ky="0" algn="bl" rotWithShape="0" blurRad="228600" dist="76200" dir="5400000">
+            <a:outerShdw blurRad="228600" dist="76200" dir="5400000" algn="bl" rotWithShape="0">
               <a:srgbClr val="000000">
                 <a:alpha val="55000"/>
               </a:srgbClr>
@@ -7459,7 +7206,7 @@
           <a:bodyPr wrap="square" lIns="0" tIns="0" rIns="0" bIns="0" rtlCol="0" anchor="t"/>
           <a:lstStyle/>
           <a:p>
-            <a:pPr indent="0" marL="0">
+            <a:pPr marL="0" indent="0">
               <a:buNone/>
             </a:pPr>
             <a:r>
@@ -7495,7 +7242,7 @@
           <a:bodyPr wrap="square" lIns="0" tIns="0" rIns="0" bIns="0" rtlCol="0" anchor="t"/>
           <a:lstStyle/>
           <a:p>
-            <a:pPr indent="0" marL="0">
+            <a:pPr marL="0" indent="0">
               <a:buNone/>
             </a:pPr>
             <a:r>
@@ -7560,7 +7307,7 @@
             <a:prstDash val="solid"/>
           </a:ln>
           <a:effectLst>
-            <a:outerShdw sx="100000" sy="100000" kx="0" ky="0" algn="bl" rotWithShape="0" blurRad="228600" dist="76200" dir="5400000">
+            <a:outerShdw blurRad="228600" dist="76200" dir="5400000" algn="bl" rotWithShape="0">
               <a:srgbClr val="000000">
                 <a:alpha val="55000"/>
               </a:srgbClr>
@@ -7614,7 +7361,7 @@
           <a:bodyPr wrap="square" lIns="0" tIns="0" rIns="0" bIns="0" rtlCol="0" anchor="t"/>
           <a:lstStyle/>
           <a:p>
-            <a:pPr indent="0" marL="0">
+            <a:pPr marL="0" indent="0">
               <a:buNone/>
             </a:pPr>
             <a:r>
@@ -7650,7 +7397,7 @@
           <a:bodyPr wrap="square" lIns="0" tIns="0" rIns="0" bIns="0" rtlCol="0" anchor="t"/>
           <a:lstStyle/>
           <a:p>
-            <a:pPr indent="0" marL="0">
+            <a:pPr marL="0" indent="0">
               <a:buNone/>
             </a:pPr>
             <a:r>
@@ -7715,7 +7462,7 @@
             <a:prstDash val="solid"/>
           </a:ln>
           <a:effectLst>
-            <a:outerShdw sx="100000" sy="100000" kx="0" ky="0" algn="bl" rotWithShape="0" blurRad="228600" dist="76200" dir="5400000">
+            <a:outerShdw blurRad="228600" dist="76200" dir="5400000" algn="bl" rotWithShape="0">
               <a:srgbClr val="000000">
                 <a:alpha val="55000"/>
               </a:srgbClr>
@@ -7769,7 +7516,7 @@
           <a:bodyPr wrap="square" lIns="0" tIns="0" rIns="0" bIns="0" rtlCol="0" anchor="t"/>
           <a:lstStyle/>
           <a:p>
-            <a:pPr indent="0" marL="0">
+            <a:pPr marL="0" indent="0">
               <a:buNone/>
             </a:pPr>
             <a:r>
@@ -7805,7 +7552,7 @@
           <a:bodyPr wrap="square" lIns="0" tIns="0" rIns="0" bIns="0" rtlCol="0" anchor="t"/>
           <a:lstStyle/>
           <a:p>
-            <a:pPr indent="0" marL="0">
+            <a:pPr marL="0" indent="0">
               <a:buNone/>
             </a:pPr>
             <a:r>
@@ -7865,7 +7612,7 @@
           <a:bodyPr wrap="square" lIns="0" tIns="0" rIns="0" bIns="0" rtlCol="0" anchor="t"/>
           <a:lstStyle/>
           <a:p>
-            <a:pPr indent="0" marL="0">
+            <a:pPr marL="0" indent="0">
               <a:buNone/>
             </a:pPr>
             <a:r>
@@ -7882,7 +7629,7 @@
       </p:sp>
       <p:sp>
         <p:nvSpPr>
-          <p:cNvPr id="25" name="Slide Number Placeholder 0"/>
+          <p:cNvPr id="43" name="Slide Number Placeholder 0"/>
           <p:cNvSpPr>
             <a:spLocks noGrp="1"/>
           </p:cNvSpPr>
@@ -7900,7 +7647,7 @@
           </a:prstGeom>
           <a:extLst>
             <a:ext uri="{C572A759-6A51-4108-AA02-DFA0A04FC94B}">
-              <ma14:wrappingTextBoxFlag xmlns:ma14="http://schemas.microsoft.com/office/mac/drawingml/2011/main" val="0"/>
+              <ma14:wrappingTextBoxFlag xmlns:ma14="http://schemas.microsoft.com/office/mac/drawingml/2011/main" xmlns="" val="0"/>
             </a:ext>
           </a:extLst>
         </p:spPr>
@@ -7918,7 +7665,7 @@
           <a:p>
             <a:pPr algn="r"/>
             <a:fld id="{F7021451-1387-4CA6-816F-3879F97B5CBC}" type="slidenum">
-              <a:rPr b="0" lang="en-US"/>
+              <a:rPr lang="en-US" b="0"/>
               <a:t>3</a:t>
             </a:fld>
             <a:endParaRPr lang="en-US"/>
@@ -7953,9 +7700,11 @@
       <p:sp>
         <p:nvSpPr>
           <p:cNvPr id="2" name="Text 1"/>
-          <p:cNvSpPr/>
+          <p:cNvSpPr>
+            <a:spLocks noGrp="1"/>
+          </p:cNvSpPr>
           <p:nvPr>
-            <p:ph idx="102" type="title" hasCustomPrompt="1"/>
+            <p:ph type="title" idx="102" hasCustomPrompt="1"/>
           </p:nvPr>
         </p:nvSpPr>
         <p:spPr>
@@ -7973,7 +7722,7 @@
           <a:bodyPr wrap="square" lIns="0" tIns="0" rIns="0" bIns="0" rtlCol="0" anchor="t"/>
           <a:lstStyle/>
           <a:p>
-            <a:pPr algn="l" indent="0" marL="0">
+            <a:pPr marL="0" indent="0" algn="l">
               <a:buNone/>
             </a:pPr>
             <a:r>
@@ -7990,141 +7739,7 @@
       </p:sp>
       <p:pic>
         <p:nvPicPr>
-          <p:cNvPr id="3" name="img-0" descr="C:\NeuroFly\docs\prezentacja\assets\eye_left.jpg">    </p:cNvPr>
-          <p:cNvPicPr>
-            <a:picLocks noChangeAspect="1"/>
-          </p:cNvPicPr>
-          <p:nvPr/>
-        </p:nvPicPr>
-        <p:blipFill>
-          <a:blip r:embed="rId1"/>
-          <a:stretch>
-            <a:fillRect/>
-          </a:stretch>
-        </p:blipFill>
-        <p:spPr>
-          <a:xfrm>
-            <a:off x="457200" y="1188720"/>
-            <a:ext cx="1828800" cy="2084832"/>
-          </a:xfrm>
-          <a:prstGeom prst="rect">
-            <a:avLst/>
-          </a:prstGeom>
-          <a:effectLst>
-            <a:outerShdw sx="100000" sy="100000" kx="0" ky="0" algn="bl" rotWithShape="0" blurRad="228600" dist="76200" dir="5400000">
-              <a:srgbClr val="000000">
-                <a:alpha val="55000"/>
-              </a:srgbClr>
-            </a:outerShdw>
-          </a:effectLst>
-        </p:spPr>
-      </p:pic>
-      <p:sp>
-        <p:nvSpPr>
-          <p:cNvPr id="4" name="cap-0"/>
-          <p:cNvSpPr txBox="1"/>
-          <p:nvPr/>
-        </p:nvSpPr>
-        <p:spPr>
-          <a:xfrm>
-            <a:off x="457200" y="3346704"/>
-            <a:ext cx="1828800" cy="256032"/>
-          </a:xfrm>
-          <a:prstGeom prst="rect">
-            <a:avLst/>
-          </a:prstGeom>
-          <a:noFill/>
-          <a:ln/>
-        </p:spPr>
-        <p:txBody>
-          <a:bodyPr wrap="square" lIns="0" tIns="0" rIns="0" bIns="0" rtlCol="0" anchor="t"/>
-          <a:lstStyle/>
-          <a:p>
-            <a:pPr indent="0" marL="0">
-              <a:buNone/>
-            </a:pPr>
-            <a:r>
-              <a:rPr lang="en-US" sz="1100" dirty="0">
-                <a:solidFill>
-                  <a:srgbClr val="A1A1AA"/>
-                </a:solidFill>
-              </a:rPr>
-              <a:t>Kamera lewa</a:t>
-            </a:r>
-            <a:endParaRPr lang="en-US" sz="1100" dirty="0"/>
-          </a:p>
-        </p:txBody>
-      </p:sp>
-      <p:pic>
-        <p:nvPicPr>
-          <p:cNvPr id="5" name="img-1" descr="C:\NeuroFly\docs\prezentacja\assets\retina_left.jpg">    </p:cNvPr>
-          <p:cNvPicPr>
-            <a:picLocks noChangeAspect="1"/>
-          </p:cNvPicPr>
-          <p:nvPr/>
-        </p:nvPicPr>
-        <p:blipFill>
-          <a:blip r:embed="rId2"/>
-          <a:stretch>
-            <a:fillRect/>
-          </a:stretch>
-        </p:blipFill>
-        <p:spPr>
-          <a:xfrm>
-            <a:off x="2532888" y="1188720"/>
-            <a:ext cx="1828800" cy="2084832"/>
-          </a:xfrm>
-          <a:prstGeom prst="rect">
-            <a:avLst/>
-          </a:prstGeom>
-          <a:effectLst>
-            <a:outerShdw sx="100000" sy="100000" kx="0" ky="0" algn="bl" rotWithShape="0" blurRad="228600" dist="76200" dir="5400000">
-              <a:srgbClr val="000000">
-                <a:alpha val="55000"/>
-              </a:srgbClr>
-            </a:outerShdw>
-          </a:effectLst>
-        </p:spPr>
-      </p:pic>
-      <p:sp>
-        <p:nvSpPr>
-          <p:cNvPr id="6" name="cap-1"/>
-          <p:cNvSpPr txBox="1"/>
-          <p:nvPr/>
-        </p:nvSpPr>
-        <p:spPr>
-          <a:xfrm>
-            <a:off x="2532888" y="3346704"/>
-            <a:ext cx="1828800" cy="256032"/>
-          </a:xfrm>
-          <a:prstGeom prst="rect">
-            <a:avLst/>
-          </a:prstGeom>
-          <a:noFill/>
-          <a:ln/>
-        </p:spPr>
-        <p:txBody>
-          <a:bodyPr wrap="square" lIns="0" tIns="0" rIns="0" bIns="0" rtlCol="0" anchor="t"/>
-          <a:lstStyle/>
-          <a:p>
-            <a:pPr indent="0" marL="0">
-              <a:buNone/>
-            </a:pPr>
-            <a:r>
-              <a:rPr lang="en-US" sz="1100" dirty="0">
-                <a:solidFill>
-                  <a:srgbClr val="A1A1AA"/>
-                </a:solidFill>
-              </a:rPr>
-              <a:t>Siatkówka lewa</a:t>
-            </a:r>
-            <a:endParaRPr lang="en-US" sz="1100" dirty="0"/>
-          </a:p>
-        </p:txBody>
-      </p:sp>
-      <p:pic>
-        <p:nvPicPr>
-          <p:cNvPr id="7" name="img-2" descr="C:\NeuroFly\docs\prezentacja\assets\eye_right.jpg">    </p:cNvPr>
+          <p:cNvPr id="3" name="img-0" descr="C:\NeuroFly\docs\prezentacja\assets\eye_left.jpg"/>
           <p:cNvPicPr>
             <a:picLocks noChangeAspect="1"/>
           </p:cNvPicPr>
@@ -8138,14 +7753,14 @@
         </p:blipFill>
         <p:spPr>
           <a:xfrm>
-            <a:off x="4608576" y="1188720"/>
+            <a:off x="457200" y="1188720"/>
             <a:ext cx="1828800" cy="2084832"/>
           </a:xfrm>
           <a:prstGeom prst="rect">
             <a:avLst/>
           </a:prstGeom>
           <a:effectLst>
-            <a:outerShdw sx="100000" sy="100000" kx="0" ky="0" algn="bl" rotWithShape="0" blurRad="228600" dist="76200" dir="5400000">
+            <a:outerShdw blurRad="228600" dist="76200" dir="5400000" algn="bl" rotWithShape="0">
               <a:srgbClr val="000000">
                 <a:alpha val="55000"/>
               </a:srgbClr>
@@ -8155,13 +7770,13 @@
       </p:pic>
       <p:sp>
         <p:nvSpPr>
-          <p:cNvPr id="8" name="cap-2"/>
-          <p:cNvSpPr txBox="1"/>
-          <p:nvPr/>
-        </p:nvSpPr>
-        <p:spPr>
-          <a:xfrm>
-            <a:off x="4608576" y="3346704"/>
+          <p:cNvPr id="4" name="cap-0"/>
+          <p:cNvSpPr txBox="1"/>
+          <p:nvPr/>
+        </p:nvSpPr>
+        <p:spPr>
+          <a:xfrm>
+            <a:off x="457200" y="3346704"/>
             <a:ext cx="1828800" cy="256032"/>
           </a:xfrm>
           <a:prstGeom prst="rect">
@@ -8174,7 +7789,7 @@
           <a:bodyPr wrap="square" lIns="0" tIns="0" rIns="0" bIns="0" rtlCol="0" anchor="t"/>
           <a:lstStyle/>
           <a:p>
-            <a:pPr indent="0" marL="0">
+            <a:pPr marL="0" indent="0">
               <a:buNone/>
             </a:pPr>
             <a:r>
@@ -8183,7 +7798,7 @@
                   <a:srgbClr val="A1A1AA"/>
                 </a:solidFill>
               </a:rPr>
-              <a:t>Kamera prawa</a:t>
+              <a:t>Kamera lewa</a:t>
             </a:r>
             <a:endParaRPr lang="en-US" sz="1100" dirty="0"/>
           </a:p>
@@ -8191,7 +7806,7 @@
       </p:sp>
       <p:pic>
         <p:nvPicPr>
-          <p:cNvPr id="9" name="img-3" descr="C:\NeuroFly\docs\prezentacja\assets\retina_right.jpg">    </p:cNvPr>
+          <p:cNvPr id="5" name="img-1" descr="C:\NeuroFly\docs\prezentacja\assets\retina_left.jpg"/>
           <p:cNvPicPr>
             <a:picLocks noChangeAspect="1"/>
           </p:cNvPicPr>
@@ -8205,14 +7820,14 @@
         </p:blipFill>
         <p:spPr>
           <a:xfrm>
-            <a:off x="6684264" y="1188720"/>
+            <a:off x="2532888" y="1188720"/>
             <a:ext cx="1828800" cy="2084832"/>
           </a:xfrm>
           <a:prstGeom prst="rect">
             <a:avLst/>
           </a:prstGeom>
           <a:effectLst>
-            <a:outerShdw sx="100000" sy="100000" kx="0" ky="0" algn="bl" rotWithShape="0" blurRad="228600" dist="76200" dir="5400000">
+            <a:outerShdw blurRad="228600" dist="76200" dir="5400000" algn="bl" rotWithShape="0">
               <a:srgbClr val="000000">
                 <a:alpha val="55000"/>
               </a:srgbClr>
@@ -8222,6 +7837,140 @@
       </p:pic>
       <p:sp>
         <p:nvSpPr>
+          <p:cNvPr id="6" name="cap-1"/>
+          <p:cNvSpPr txBox="1"/>
+          <p:nvPr/>
+        </p:nvSpPr>
+        <p:spPr>
+          <a:xfrm>
+            <a:off x="2532888" y="3346704"/>
+            <a:ext cx="1828800" cy="256032"/>
+          </a:xfrm>
+          <a:prstGeom prst="rect">
+            <a:avLst/>
+          </a:prstGeom>
+          <a:noFill/>
+          <a:ln/>
+        </p:spPr>
+        <p:txBody>
+          <a:bodyPr wrap="square" lIns="0" tIns="0" rIns="0" bIns="0" rtlCol="0" anchor="t"/>
+          <a:lstStyle/>
+          <a:p>
+            <a:pPr marL="0" indent="0">
+              <a:buNone/>
+            </a:pPr>
+            <a:r>
+              <a:rPr lang="en-US" sz="1100" dirty="0">
+                <a:solidFill>
+                  <a:srgbClr val="A1A1AA"/>
+                </a:solidFill>
+              </a:rPr>
+              <a:t>Siatkówka lewa</a:t>
+            </a:r>
+            <a:endParaRPr lang="en-US" sz="1100" dirty="0"/>
+          </a:p>
+        </p:txBody>
+      </p:sp>
+      <p:pic>
+        <p:nvPicPr>
+          <p:cNvPr id="7" name="img-2" descr="C:\NeuroFly\docs\prezentacja\assets\eye_right.jpg"/>
+          <p:cNvPicPr>
+            <a:picLocks noChangeAspect="1"/>
+          </p:cNvPicPr>
+          <p:nvPr/>
+        </p:nvPicPr>
+        <p:blipFill>
+          <a:blip r:embed="rId5"/>
+          <a:stretch>
+            <a:fillRect/>
+          </a:stretch>
+        </p:blipFill>
+        <p:spPr>
+          <a:xfrm>
+            <a:off x="4608576" y="1188720"/>
+            <a:ext cx="1828800" cy="2084832"/>
+          </a:xfrm>
+          <a:prstGeom prst="rect">
+            <a:avLst/>
+          </a:prstGeom>
+          <a:effectLst>
+            <a:outerShdw blurRad="228600" dist="76200" dir="5400000" algn="bl" rotWithShape="0">
+              <a:srgbClr val="000000">
+                <a:alpha val="55000"/>
+              </a:srgbClr>
+            </a:outerShdw>
+          </a:effectLst>
+        </p:spPr>
+      </p:pic>
+      <p:sp>
+        <p:nvSpPr>
+          <p:cNvPr id="8" name="cap-2"/>
+          <p:cNvSpPr txBox="1"/>
+          <p:nvPr/>
+        </p:nvSpPr>
+        <p:spPr>
+          <a:xfrm>
+            <a:off x="4608576" y="3346704"/>
+            <a:ext cx="1828800" cy="256032"/>
+          </a:xfrm>
+          <a:prstGeom prst="rect">
+            <a:avLst/>
+          </a:prstGeom>
+          <a:noFill/>
+          <a:ln/>
+        </p:spPr>
+        <p:txBody>
+          <a:bodyPr wrap="square" lIns="0" tIns="0" rIns="0" bIns="0" rtlCol="0" anchor="t"/>
+          <a:lstStyle/>
+          <a:p>
+            <a:pPr marL="0" indent="0">
+              <a:buNone/>
+            </a:pPr>
+            <a:r>
+              <a:rPr lang="en-US" sz="1100" dirty="0">
+                <a:solidFill>
+                  <a:srgbClr val="A1A1AA"/>
+                </a:solidFill>
+              </a:rPr>
+              <a:t>Kamera prawa</a:t>
+            </a:r>
+            <a:endParaRPr lang="en-US" sz="1100" dirty="0"/>
+          </a:p>
+        </p:txBody>
+      </p:sp>
+      <p:pic>
+        <p:nvPicPr>
+          <p:cNvPr id="9" name="img-3" descr="C:\NeuroFly\docs\prezentacja\assets\retina_right.jpg"/>
+          <p:cNvPicPr>
+            <a:picLocks noChangeAspect="1"/>
+          </p:cNvPicPr>
+          <p:nvPr/>
+        </p:nvPicPr>
+        <p:blipFill>
+          <a:blip r:embed="rId6"/>
+          <a:stretch>
+            <a:fillRect/>
+          </a:stretch>
+        </p:blipFill>
+        <p:spPr>
+          <a:xfrm>
+            <a:off x="6684264" y="1188720"/>
+            <a:ext cx="1828800" cy="2084832"/>
+          </a:xfrm>
+          <a:prstGeom prst="rect">
+            <a:avLst/>
+          </a:prstGeom>
+          <a:effectLst>
+            <a:outerShdw blurRad="228600" dist="76200" dir="5400000" algn="bl" rotWithShape="0">
+              <a:srgbClr val="000000">
+                <a:alpha val="55000"/>
+              </a:srgbClr>
+            </a:outerShdw>
+          </a:effectLst>
+        </p:spPr>
+      </p:pic>
+      <p:sp>
+        <p:nvSpPr>
           <p:cNvPr id="10" name="cap-3"/>
           <p:cNvSpPr txBox="1"/>
           <p:nvPr/>
@@ -8241,7 +7990,7 @@
           <a:bodyPr wrap="square" lIns="0" tIns="0" rIns="0" bIns="0" rtlCol="0" anchor="t"/>
           <a:lstStyle/>
           <a:p>
-            <a:pPr indent="0" marL="0">
+            <a:pPr marL="0" indent="0">
               <a:buNone/>
             </a:pPr>
             <a:r>
@@ -8277,7 +8026,7 @@
           <a:bodyPr wrap="square" lIns="0" tIns="0" rIns="0" bIns="0" rtlCol="0" anchor="t"/>
           <a:lstStyle/>
           <a:p>
-            <a:pPr indent="0" marL="0">
+            <a:pPr marL="0" indent="0">
               <a:buNone/>
             </a:pPr>
             <a:r>
@@ -8312,7 +8061,7 @@
           </a:prstGeom>
           <a:extLst>
             <a:ext uri="{C572A759-6A51-4108-AA02-DFA0A04FC94B}">
-              <ma14:wrappingTextBoxFlag xmlns:ma14="http://schemas.microsoft.com/office/mac/drawingml/2011/main" val="0"/>
+              <ma14:wrappingTextBoxFlag xmlns:ma14="http://schemas.microsoft.com/office/mac/drawingml/2011/main" xmlns="" val="0"/>
             </a:ext>
           </a:extLst>
         </p:spPr>
@@ -8330,7 +8079,7 @@
           <a:p>
             <a:pPr algn="r"/>
             <a:fld id="{F7021451-1387-4CA6-816F-3879F97B5CBC}" type="slidenum">
-              <a:rPr b="0" lang="en-US"/>
+              <a:rPr lang="en-US" b="0"/>
               <a:t>4</a:t>
             </a:fld>
             <a:endParaRPr lang="en-US"/>
@@ -8365,9 +8114,11 @@
       <p:sp>
         <p:nvSpPr>
           <p:cNvPr id="2" name="Text 1"/>
-          <p:cNvSpPr/>
+          <p:cNvSpPr>
+            <a:spLocks noGrp="1"/>
+          </p:cNvSpPr>
           <p:nvPr>
-            <p:ph idx="102" type="title" hasCustomPrompt="1"/>
+            <p:ph type="title" idx="102" hasCustomPrompt="1"/>
           </p:nvPr>
         </p:nvSpPr>
         <p:spPr>
@@ -8385,7 +8136,7 @@
           <a:bodyPr wrap="square" lIns="0" tIns="0" rIns="0" bIns="0" rtlCol="0" anchor="t"/>
           <a:lstStyle/>
           <a:p>
-            <a:pPr algn="l" indent="0" marL="0">
+            <a:pPr marL="0" indent="0" algn="l">
               <a:buNone/>
             </a:pPr>
             <a:r>
@@ -8402,14 +8153,14 @@
       </p:sp>
       <p:pic>
         <p:nvPicPr>
-          <p:cNvPr id="3" name="render-3d" descr="C:\NeuroFly\docs\prezentacja\assets\connectome_3d.jpg">    </p:cNvPr>
+          <p:cNvPr id="3" name="render-3d" descr="C:\NeuroFly\docs\prezentacja\assets\connectome_3d.jpg"/>
           <p:cNvPicPr>
             <a:picLocks noChangeAspect="1"/>
           </p:cNvPicPr>
           <p:nvPr/>
         </p:nvPicPr>
         <p:blipFill>
-          <a:blip r:embed="rId1"/>
+          <a:blip r:embed="rId3"/>
           <a:stretch>
             <a:fillRect/>
           </a:stretch>
@@ -8445,7 +8196,7 @@
           <a:bodyPr wrap="square" lIns="0" tIns="0" rIns="0" bIns="0" rtlCol="0" anchor="t"/>
           <a:lstStyle/>
           <a:p>
-            <a:pPr indent="0" marL="0">
+            <a:pPr marL="0" indent="0">
               <a:buNone/>
             </a:pPr>
             <a:r>
@@ -8481,7 +8232,7 @@
           <a:bodyPr wrap="square" lIns="0" tIns="0" rIns="0" bIns="0" rtlCol="0" anchor="t"/>
           <a:lstStyle/>
           <a:p>
-            <a:pPr indent="0" marL="0">
+            <a:pPr marL="0" indent="0">
               <a:buNone/>
             </a:pPr>
             <a:r>
@@ -8517,7 +8268,7 @@
           <a:bodyPr wrap="square" lIns="0" tIns="0" rIns="0" bIns="0" rtlCol="0" anchor="t"/>
           <a:lstStyle/>
           <a:p>
-            <a:pPr indent="0" marL="0">
+            <a:pPr marL="0" indent="0">
               <a:buNone/>
             </a:pPr>
             <a:r>
@@ -8553,7 +8304,7 @@
           <a:bodyPr wrap="square" lIns="0" tIns="0" rIns="0" bIns="0" rtlCol="0" anchor="t"/>
           <a:lstStyle/>
           <a:p>
-            <a:pPr indent="0" marL="0">
+            <a:pPr marL="0" indent="0">
               <a:buNone/>
             </a:pPr>
             <a:r>
@@ -8589,7 +8340,7 @@
           <a:bodyPr wrap="square" lIns="0" tIns="0" rIns="0" bIns="0" rtlCol="0" anchor="t"/>
           <a:lstStyle/>
           <a:p>
-            <a:pPr indent="0" marL="0">
+            <a:pPr marL="0" indent="0">
               <a:buNone/>
             </a:pPr>
             <a:r>
@@ -8625,7 +8376,7 @@
           <a:bodyPr wrap="square" lIns="0" tIns="0" rIns="0" bIns="0" rtlCol="0" anchor="t"/>
           <a:lstStyle/>
           <a:p>
-            <a:pPr indent="0" marL="0">
+            <a:pPr marL="0" indent="0">
               <a:buNone/>
             </a:pPr>
             <a:r>
@@ -8661,7 +8412,7 @@
           <a:bodyPr wrap="square" lIns="0" tIns="0" rIns="0" bIns="0" rtlCol="0" anchor="t"/>
           <a:lstStyle/>
           <a:p>
-            <a:pPr indent="0" marL="0">
+            <a:pPr marL="0" indent="0">
               <a:buNone/>
             </a:pPr>
             <a:r>
@@ -8697,7 +8448,7 @@
           <a:bodyPr wrap="square" lIns="0" tIns="0" rIns="0" bIns="0" rtlCol="0" anchor="t"/>
           <a:lstStyle/>
           <a:p>
-            <a:pPr indent="0" marL="0">
+            <a:pPr marL="0" indent="0">
               <a:buNone/>
             </a:pPr>
             <a:r>
@@ -8758,7 +8509,7 @@
           <a:bodyPr wrap="square" lIns="0" tIns="0" rIns="0" bIns="0" rtlCol="0" anchor="t"/>
           <a:lstStyle/>
           <a:p>
-            <a:pPr indent="0" marL="0">
+            <a:pPr marL="0" indent="0">
               <a:buNone/>
             </a:pPr>
             <a:r>
@@ -8819,7 +8570,7 @@
           <a:bodyPr wrap="square" lIns="0" tIns="0" rIns="0" bIns="0" rtlCol="0" anchor="t"/>
           <a:lstStyle/>
           <a:p>
-            <a:pPr indent="0" marL="0">
+            <a:pPr marL="0" indent="0">
               <a:buNone/>
             </a:pPr>
             <a:r>
@@ -8880,7 +8631,7 @@
           <a:bodyPr wrap="square" lIns="0" tIns="0" rIns="0" bIns="0" rtlCol="0" anchor="t"/>
           <a:lstStyle/>
           <a:p>
-            <a:pPr indent="0" marL="0">
+            <a:pPr marL="0" indent="0">
               <a:buNone/>
             </a:pPr>
             <a:r>
@@ -8941,7 +8692,7 @@
           <a:bodyPr wrap="square" lIns="0" tIns="0" rIns="0" bIns="0" rtlCol="0" anchor="t"/>
           <a:lstStyle/>
           <a:p>
-            <a:pPr indent="0" marL="0">
+            <a:pPr marL="0" indent="0">
               <a:buNone/>
             </a:pPr>
             <a:r>
@@ -8976,7 +8727,7 @@
           </a:prstGeom>
           <a:extLst>
             <a:ext uri="{C572A759-6A51-4108-AA02-DFA0A04FC94B}">
-              <ma14:wrappingTextBoxFlag xmlns:ma14="http://schemas.microsoft.com/office/mac/drawingml/2011/main" val="0"/>
+              <ma14:wrappingTextBoxFlag xmlns:ma14="http://schemas.microsoft.com/office/mac/drawingml/2011/main" xmlns="" val="0"/>
             </a:ext>
           </a:extLst>
         </p:spPr>
@@ -8994,7 +8745,7 @@
           <a:p>
             <a:pPr algn="r"/>
             <a:fld id="{F7021451-1387-4CA6-816F-3879F97B5CBC}" type="slidenum">
-              <a:rPr b="0" lang="en-US"/>
+              <a:rPr lang="en-US" b="0"/>
               <a:t>5</a:t>
             </a:fld>
             <a:endParaRPr lang="en-US"/>
@@ -9029,9 +8780,11 @@
       <p:sp>
         <p:nvSpPr>
           <p:cNvPr id="2" name="Text 1"/>
-          <p:cNvSpPr/>
+          <p:cNvSpPr>
+            <a:spLocks noGrp="1"/>
+          </p:cNvSpPr>
           <p:nvPr>
-            <p:ph idx="102" type="title" hasCustomPrompt="1"/>
+            <p:ph type="title" idx="102" hasCustomPrompt="1"/>
           </p:nvPr>
         </p:nvSpPr>
         <p:spPr>
@@ -9049,7 +8802,7 @@
           <a:bodyPr wrap="square" lIns="0" tIns="0" rIns="0" bIns="0" rtlCol="0" anchor="t"/>
           <a:lstStyle/>
           <a:p>
-            <a:pPr algn="l" indent="0" marL="0">
+            <a:pPr marL="0" indent="0" algn="l">
               <a:buNone/>
             </a:pPr>
             <a:r>
@@ -9090,7 +8843,7 @@
             <a:prstDash val="solid"/>
           </a:ln>
           <a:effectLst>
-            <a:outerShdw sx="100000" sy="100000" kx="0" ky="0" algn="bl" rotWithShape="0" blurRad="228600" dist="76200" dir="5400000">
+            <a:outerShdw blurRad="228600" dist="76200" dir="5400000" algn="bl" rotWithShape="0">
               <a:srgbClr val="000000">
                 <a:alpha val="55000"/>
               </a:srgbClr>
@@ -9119,7 +8872,7 @@
           <a:bodyPr wrap="square" lIns="0" tIns="0" rIns="0" bIns="0" rtlCol="0" anchor="t"/>
           <a:lstStyle/>
           <a:p>
-            <a:pPr indent="0" marL="0">
+            <a:pPr marL="0" indent="0">
               <a:buNone/>
             </a:pPr>
             <a:r>
@@ -9158,7 +8911,7 @@
           <a:bodyPr wrap="square" lIns="0" tIns="0" rIns="0" bIns="0" rtlCol="0" anchor="t"/>
           <a:lstStyle/>
           <a:p>
-            <a:pPr indent="0" marL="0">
+            <a:pPr marL="0" indent="0">
               <a:buNone/>
             </a:pPr>
             <a:r>
@@ -9194,7 +8947,7 @@
           <a:bodyPr wrap="square" lIns="0" tIns="0" rIns="0" bIns="0" rtlCol="0" anchor="t"/>
           <a:lstStyle/>
           <a:p>
-            <a:pPr indent="0" marL="0">
+            <a:pPr marL="0" indent="0">
               <a:buNone/>
             </a:pPr>
             <a:r>
@@ -9230,7 +8983,7 @@
           <a:bodyPr wrap="square" lIns="0" tIns="0" rIns="0" bIns="0" rtlCol="0" anchor="t"/>
           <a:lstStyle/>
           <a:p>
-            <a:pPr indent="0" marL="0">
+            <a:pPr marL="0" indent="0">
               <a:buNone/>
             </a:pPr>
             <a:r>
@@ -9266,7 +9019,7 @@
           <a:bodyPr wrap="square" lIns="0" tIns="0" rIns="0" bIns="0" rtlCol="0" anchor="t"/>
           <a:lstStyle/>
           <a:p>
-            <a:pPr indent="0" marL="0">
+            <a:pPr marL="0" indent="0">
               <a:buNone/>
             </a:pPr>
             <a:r>
@@ -9302,7 +9055,7 @@
           <a:bodyPr wrap="square" lIns="0" tIns="0" rIns="0" bIns="0" rtlCol="0" anchor="t"/>
           <a:lstStyle/>
           <a:p>
-            <a:pPr indent="0" marL="0">
+            <a:pPr marL="0" indent="0">
               <a:buNone/>
             </a:pPr>
             <a:r>
@@ -9338,7 +9091,7 @@
           <a:bodyPr wrap="square" lIns="0" tIns="0" rIns="0" bIns="0" rtlCol="0" anchor="t"/>
           <a:lstStyle/>
           <a:p>
-            <a:pPr indent="0" marL="0">
+            <a:pPr marL="0" indent="0">
               <a:buNone/>
             </a:pPr>
             <a:r>
@@ -9374,7 +9127,7 @@
           <a:bodyPr wrap="square" lIns="0" tIns="0" rIns="0" bIns="0" rtlCol="0" anchor="t"/>
           <a:lstStyle/>
           <a:p>
-            <a:pPr indent="0" marL="0">
+            <a:pPr marL="0" indent="0">
               <a:buNone/>
             </a:pPr>
             <a:r>
@@ -9410,7 +9163,7 @@
           <a:bodyPr wrap="square" lIns="0" tIns="0" rIns="0" bIns="0" rtlCol="0" anchor="t"/>
           <a:lstStyle/>
           <a:p>
-            <a:pPr indent="0" marL="0">
+            <a:pPr marL="0" indent="0">
               <a:buNone/>
             </a:pPr>
             <a:r>
@@ -9451,7 +9204,7 @@
             <a:prstDash val="solid"/>
           </a:ln>
           <a:effectLst>
-            <a:outerShdw sx="100000" sy="100000" kx="0" ky="0" algn="bl" rotWithShape="0" blurRad="228600" dist="76200" dir="5400000">
+            <a:outerShdw blurRad="228600" dist="76200" dir="5400000" algn="bl" rotWithShape="0">
               <a:srgbClr val="000000">
                 <a:alpha val="55000"/>
               </a:srgbClr>
@@ -9480,7 +9233,7 @@
           <a:bodyPr wrap="square" lIns="0" tIns="0" rIns="0" bIns="0" rtlCol="0" anchor="t"/>
           <a:lstStyle/>
           <a:p>
-            <a:pPr indent="0" marL="0">
+            <a:pPr marL="0" indent="0">
               <a:buNone/>
             </a:pPr>
             <a:r>
@@ -9541,7 +9294,7 @@
           <a:bodyPr wrap="square" lIns="0" tIns="0" rIns="0" bIns="0" rtlCol="0" anchor="t"/>
           <a:lstStyle/>
           <a:p>
-            <a:pPr indent="0" marL="0">
+            <a:pPr marL="0" indent="0">
               <a:buNone/>
             </a:pPr>
             <a:r>
@@ -9602,7 +9355,7 @@
           <a:bodyPr wrap="square" lIns="0" tIns="0" rIns="0" bIns="0" rtlCol="0" anchor="t"/>
           <a:lstStyle/>
           <a:p>
-            <a:pPr indent="0" marL="0">
+            <a:pPr marL="0" indent="0">
               <a:buNone/>
             </a:pPr>
             <a:r>
@@ -9663,7 +9416,7 @@
           <a:bodyPr wrap="square" lIns="0" tIns="0" rIns="0" bIns="0" rtlCol="0" anchor="t"/>
           <a:lstStyle/>
           <a:p>
-            <a:pPr indent="0" marL="0">
+            <a:pPr marL="0" indent="0">
               <a:buNone/>
             </a:pPr>
             <a:r>
@@ -9724,7 +9477,7 @@
           <a:bodyPr wrap="square" lIns="0" tIns="0" rIns="0" bIns="0" rtlCol="0" anchor="t"/>
           <a:lstStyle/>
           <a:p>
-            <a:pPr indent="0" marL="0">
+            <a:pPr marL="0" indent="0">
               <a:buNone/>
             </a:pPr>
             <a:r>
@@ -9760,7 +9513,7 @@
           <a:bodyPr wrap="square" lIns="0" tIns="0" rIns="0" bIns="0" rtlCol="0" anchor="t"/>
           <a:lstStyle/>
           <a:p>
-            <a:pPr indent="0" marL="0">
+            <a:pPr marL="0" indent="0">
               <a:buNone/>
             </a:pPr>
             <a:r>
@@ -9795,7 +9548,7 @@
           </a:prstGeom>
           <a:extLst>
             <a:ext uri="{C572A759-6A51-4108-AA02-DFA0A04FC94B}">
-              <ma14:wrappingTextBoxFlag xmlns:ma14="http://schemas.microsoft.com/office/mac/drawingml/2011/main" val="0"/>
+              <ma14:wrappingTextBoxFlag xmlns:ma14="http://schemas.microsoft.com/office/mac/drawingml/2011/main" xmlns="" val="0"/>
             </a:ext>
           </a:extLst>
         </p:spPr>
@@ -9813,7 +9566,7 @@
           <a:p>
             <a:pPr algn="r"/>
             <a:fld id="{F7021451-1387-4CA6-816F-3879F97B5CBC}" type="slidenum">
-              <a:rPr b="0" lang="en-US"/>
+              <a:rPr lang="en-US" b="0"/>
               <a:t>6</a:t>
             </a:fld>
             <a:endParaRPr lang="en-US"/>
@@ -9848,9 +9601,11 @@
       <p:sp>
         <p:nvSpPr>
           <p:cNvPr id="2" name="Text 1"/>
-          <p:cNvSpPr/>
+          <p:cNvSpPr>
+            <a:spLocks noGrp="1"/>
+          </p:cNvSpPr>
           <p:nvPr>
-            <p:ph idx="102" type="title" hasCustomPrompt="1"/>
+            <p:ph type="title" idx="102" hasCustomPrompt="1"/>
           </p:nvPr>
         </p:nvSpPr>
         <p:spPr>
@@ -9868,7 +9623,7 @@
           <a:bodyPr wrap="square" lIns="0" tIns="0" rIns="0" bIns="0" rtlCol="0" anchor="t"/>
           <a:lstStyle/>
           <a:p>
-            <a:pPr algn="l" indent="0" marL="0">
+            <a:pPr marL="0" indent="0" algn="l">
               <a:buNone/>
             </a:pPr>
             <a:r>
@@ -9885,14 +9640,14 @@
       </p:sp>
       <p:pic>
         <p:nvPicPr>
-          <p:cNvPr id="3" name="render-circuit" descr="C:\NeuroFly\docs\prezentacja\assets\circuit_3d.jpg">    </p:cNvPr>
+          <p:cNvPr id="3" name="render-circuit" descr="C:\NeuroFly\docs\prezentacja\assets\circuit_3d.jpg"/>
           <p:cNvPicPr>
             <a:picLocks noChangeAspect="1"/>
           </p:cNvPicPr>
           <p:nvPr/>
         </p:nvPicPr>
         <p:blipFill>
-          <a:blip r:embed="rId1"/>
+          <a:blip r:embed="rId3"/>
           <a:stretch>
             <a:fillRect/>
           </a:stretch>
@@ -9953,7 +9708,7 @@
           <a:bodyPr wrap="square" lIns="0" tIns="0" rIns="0" bIns="0" rtlCol="0" anchor="t"/>
           <a:lstStyle/>
           <a:p>
-            <a:pPr indent="0" marL="0">
+            <a:pPr marL="0" indent="0">
               <a:buNone/>
             </a:pPr>
             <a:r>
@@ -9989,7 +9744,7 @@
           <a:bodyPr wrap="square" lIns="0" tIns="0" rIns="0" bIns="0" rtlCol="0" anchor="t"/>
           <a:lstStyle/>
           <a:p>
-            <a:pPr indent="0" marL="0">
+            <a:pPr marL="0" indent="0">
               <a:buNone/>
             </a:pPr>
             <a:r>
@@ -10025,7 +9780,7 @@
           <a:bodyPr wrap="square" lIns="0" tIns="0" rIns="0" bIns="0" rtlCol="0" anchor="t"/>
           <a:lstStyle/>
           <a:p>
-            <a:pPr algn="r" indent="0" marL="0">
+            <a:pPr marL="0" indent="0" algn="r">
               <a:buNone/>
             </a:pPr>
             <a:r>
@@ -10086,7 +9841,7 @@
           <a:bodyPr wrap="square" lIns="0" tIns="0" rIns="0" bIns="0" rtlCol="0" anchor="t"/>
           <a:lstStyle/>
           <a:p>
-            <a:pPr indent="0" marL="0">
+            <a:pPr marL="0" indent="0">
               <a:buNone/>
             </a:pPr>
             <a:r>
@@ -10122,7 +9877,7 @@
           <a:bodyPr wrap="square" lIns="0" tIns="0" rIns="0" bIns="0" rtlCol="0" anchor="t"/>
           <a:lstStyle/>
           <a:p>
-            <a:pPr indent="0" marL="0">
+            <a:pPr marL="0" indent="0">
               <a:buNone/>
             </a:pPr>
             <a:r>
@@ -10158,7 +9913,7 @@
           <a:bodyPr wrap="square" lIns="0" tIns="0" rIns="0" bIns="0" rtlCol="0" anchor="t"/>
           <a:lstStyle/>
           <a:p>
-            <a:pPr algn="r" indent="0" marL="0">
+            <a:pPr marL="0" indent="0" algn="r">
               <a:buNone/>
             </a:pPr>
             <a:r>
@@ -10219,7 +9974,7 @@
           <a:bodyPr wrap="square" lIns="0" tIns="0" rIns="0" bIns="0" rtlCol="0" anchor="t"/>
           <a:lstStyle/>
           <a:p>
-            <a:pPr indent="0" marL="0">
+            <a:pPr marL="0" indent="0">
               <a:buNone/>
             </a:pPr>
             <a:r>
@@ -10255,7 +10010,7 @@
           <a:bodyPr wrap="square" lIns="0" tIns="0" rIns="0" bIns="0" rtlCol="0" anchor="t"/>
           <a:lstStyle/>
           <a:p>
-            <a:pPr indent="0" marL="0">
+            <a:pPr marL="0" indent="0">
               <a:buNone/>
             </a:pPr>
             <a:r>
@@ -10291,7 +10046,7 @@
           <a:bodyPr wrap="square" lIns="0" tIns="0" rIns="0" bIns="0" rtlCol="0" anchor="t"/>
           <a:lstStyle/>
           <a:p>
-            <a:pPr algn="r" indent="0" marL="0">
+            <a:pPr marL="0" indent="0" algn="r">
               <a:buNone/>
             </a:pPr>
             <a:r>
@@ -10352,7 +10107,7 @@
           <a:bodyPr wrap="square" lIns="0" tIns="0" rIns="0" bIns="0" rtlCol="0" anchor="t"/>
           <a:lstStyle/>
           <a:p>
-            <a:pPr indent="0" marL="0">
+            <a:pPr marL="0" indent="0">
               <a:buNone/>
             </a:pPr>
             <a:r>
@@ -10388,7 +10143,7 @@
           <a:bodyPr wrap="square" lIns="0" tIns="0" rIns="0" bIns="0" rtlCol="0" anchor="t"/>
           <a:lstStyle/>
           <a:p>
-            <a:pPr indent="0" marL="0">
+            <a:pPr marL="0" indent="0">
               <a:buNone/>
             </a:pPr>
             <a:r>
@@ -10424,7 +10179,7 @@
           <a:bodyPr wrap="square" lIns="0" tIns="0" rIns="0" bIns="0" rtlCol="0" anchor="t"/>
           <a:lstStyle/>
           <a:p>
-            <a:pPr algn="r" indent="0" marL="0">
+            <a:pPr marL="0" indent="0" algn="r">
               <a:buNone/>
             </a:pPr>
             <a:r>
@@ -10485,7 +10240,7 @@
           <a:bodyPr wrap="square" lIns="0" tIns="0" rIns="0" bIns="0" rtlCol="0" anchor="t"/>
           <a:lstStyle/>
           <a:p>
-            <a:pPr indent="0" marL="0">
+            <a:pPr marL="0" indent="0">
               <a:buNone/>
             </a:pPr>
             <a:r>
@@ -10521,7 +10276,7 @@
           <a:bodyPr wrap="square" lIns="0" tIns="0" rIns="0" bIns="0" rtlCol="0" anchor="t"/>
           <a:lstStyle/>
           <a:p>
-            <a:pPr indent="0" marL="0">
+            <a:pPr marL="0" indent="0">
               <a:buNone/>
             </a:pPr>
             <a:r>
@@ -10557,7 +10312,7 @@
           <a:bodyPr wrap="square" lIns="0" tIns="0" rIns="0" bIns="0" rtlCol="0" anchor="t"/>
           <a:lstStyle/>
           <a:p>
-            <a:pPr algn="r" indent="0" marL="0">
+            <a:pPr marL="0" indent="0" algn="r">
               <a:buNone/>
             </a:pPr>
             <a:r>
@@ -10618,7 +10373,7 @@
           <a:bodyPr wrap="square" lIns="0" tIns="0" rIns="0" bIns="0" rtlCol="0" anchor="t"/>
           <a:lstStyle/>
           <a:p>
-            <a:pPr indent="0" marL="0">
+            <a:pPr marL="0" indent="0">
               <a:buNone/>
             </a:pPr>
             <a:r>
@@ -10654,7 +10409,7 @@
           <a:bodyPr wrap="square" lIns="0" tIns="0" rIns="0" bIns="0" rtlCol="0" anchor="t"/>
           <a:lstStyle/>
           <a:p>
-            <a:pPr indent="0" marL="0">
+            <a:pPr marL="0" indent="0">
               <a:buNone/>
             </a:pPr>
             <a:r>
@@ -10690,7 +10445,7 @@
           <a:bodyPr wrap="square" lIns="0" tIns="0" rIns="0" bIns="0" rtlCol="0" anchor="t"/>
           <a:lstStyle/>
           <a:p>
-            <a:pPr algn="r" indent="0" marL="0">
+            <a:pPr marL="0" indent="0" algn="r">
               <a:buNone/>
             </a:pPr>
             <a:r>
@@ -10707,7 +10462,7 @@
       </p:sp>
       <p:sp>
         <p:nvSpPr>
-          <p:cNvPr id="25" name="Slide Number Placeholder 0"/>
+          <p:cNvPr id="28" name="Slide Number Placeholder 0"/>
           <p:cNvSpPr>
             <a:spLocks noGrp="1"/>
           </p:cNvSpPr>
@@ -10725,7 +10480,7 @@
           </a:prstGeom>
           <a:extLst>
             <a:ext uri="{C572A759-6A51-4108-AA02-DFA0A04FC94B}">
-              <ma14:wrappingTextBoxFlag xmlns:ma14="http://schemas.microsoft.com/office/mac/drawingml/2011/main" val="0"/>
+              <ma14:wrappingTextBoxFlag xmlns:ma14="http://schemas.microsoft.com/office/mac/drawingml/2011/main" xmlns="" val="0"/>
             </a:ext>
           </a:extLst>
         </p:spPr>
@@ -10743,7 +10498,7 @@
           <a:p>
             <a:pPr algn="r"/>
             <a:fld id="{F7021451-1387-4CA6-816F-3879F97B5CBC}" type="slidenum">
-              <a:rPr b="0" lang="en-US"/>
+              <a:rPr lang="en-US" b="0"/>
               <a:t>7</a:t>
             </a:fld>
             <a:endParaRPr lang="en-US"/>
@@ -10778,9 +10533,11 @@
       <p:sp>
         <p:nvSpPr>
           <p:cNvPr id="2" name="Text 1"/>
-          <p:cNvSpPr/>
+          <p:cNvSpPr>
+            <a:spLocks noGrp="1"/>
+          </p:cNvSpPr>
           <p:nvPr>
-            <p:ph idx="102" type="title" hasCustomPrompt="1"/>
+            <p:ph type="title" idx="102" hasCustomPrompt="1"/>
           </p:nvPr>
         </p:nvSpPr>
         <p:spPr>
@@ -10798,7 +10555,7 @@
           <a:bodyPr wrap="square" lIns="0" tIns="0" rIns="0" bIns="0" rtlCol="0" anchor="t"/>
           <a:lstStyle/>
           <a:p>
-            <a:pPr algn="l" indent="0" marL="0">
+            <a:pPr marL="0" indent="0" algn="l">
               <a:buNone/>
             </a:pPr>
             <a:r>
@@ -10815,7 +10572,7 @@
       </p:sp>
       <p:graphicFrame>
         <p:nvGraphicFramePr>
-          <p:cNvPr id="3" name="chart-side" descr=""/>
+          <p:cNvPr id="3" name="chart-side"/>
           <p:cNvGraphicFramePr/>
           <p:nvPr/>
         </p:nvGraphicFramePr>
@@ -10823,9 +10580,9 @@
           <a:off x="457200" y="1097280"/>
           <a:ext cx="5120640" cy="3291840"/>
         </p:xfrm>
-        <a:graphic xmlns:a="http://schemas.openxmlformats.org/drawingml/2006/main">
+        <a:graphic>
           <a:graphicData uri="http://schemas.openxmlformats.org/drawingml/2006/chart">
-            <c:chart xmlns:c="http://schemas.openxmlformats.org/drawingml/2006/chart" r:id="rId1"/>
+            <c:chart xmlns:c="http://schemas.openxmlformats.org/drawingml/2006/chart" xmlns:r="http://schemas.openxmlformats.org/officeDocument/2006/relationships" r:id="rId3"/>
           </a:graphicData>
         </a:graphic>
       </p:graphicFrame>
@@ -10850,7 +10607,7 @@
           <a:bodyPr wrap="square" lIns="0" tIns="0" rIns="0" bIns="0" rtlCol="0" anchor="t"/>
           <a:lstStyle/>
           <a:p>
-            <a:pPr indent="0" marL="0">
+            <a:pPr marL="0" indent="0">
               <a:buNone/>
             </a:pPr>
             <a:r>
@@ -10886,7 +10643,7 @@
           <a:bodyPr wrap="square" lIns="0" tIns="0" rIns="0" bIns="0" rtlCol="0" anchor="t"/>
           <a:lstStyle/>
           <a:p>
-            <a:pPr indent="0" marL="0">
+            <a:pPr marL="0" indent="0">
               <a:buNone/>
             </a:pPr>
             <a:r>
@@ -10922,7 +10679,7 @@
           <a:bodyPr wrap="square" lIns="0" tIns="0" rIns="0" bIns="0" rtlCol="0" anchor="t"/>
           <a:lstStyle/>
           <a:p>
-            <a:pPr indent="0" marL="0">
+            <a:pPr marL="0" indent="0">
               <a:buNone/>
             </a:pPr>
             <a:r>
@@ -10958,7 +10715,7 @@
           <a:bodyPr wrap="square" lIns="0" tIns="0" rIns="0" bIns="0" rtlCol="0" anchor="t"/>
           <a:lstStyle/>
           <a:p>
-            <a:pPr indent="0" marL="0">
+            <a:pPr marL="0" indent="0">
               <a:buNone/>
             </a:pPr>
             <a:r>
@@ -10993,7 +10750,7 @@
           </a:prstGeom>
           <a:extLst>
             <a:ext uri="{C572A759-6A51-4108-AA02-DFA0A04FC94B}">
-              <ma14:wrappingTextBoxFlag xmlns:ma14="http://schemas.microsoft.com/office/mac/drawingml/2011/main" val="0"/>
+              <ma14:wrappingTextBoxFlag xmlns:ma14="http://schemas.microsoft.com/office/mac/drawingml/2011/main" xmlns="" val="0"/>
             </a:ext>
           </a:extLst>
         </p:spPr>
@@ -11011,7 +10768,7 @@
           <a:p>
             <a:pPr algn="r"/>
             <a:fld id="{F7021451-1387-4CA6-816F-3879F97B5CBC}" type="slidenum">
-              <a:rPr b="0" lang="en-US"/>
+              <a:rPr lang="en-US" b="0"/>
               <a:t>8</a:t>
             </a:fld>
             <a:endParaRPr lang="en-US"/>
@@ -11046,9 +10803,11 @@
       <p:sp>
         <p:nvSpPr>
           <p:cNvPr id="2" name="Text 1"/>
-          <p:cNvSpPr/>
+          <p:cNvSpPr>
+            <a:spLocks noGrp="1"/>
+          </p:cNvSpPr>
           <p:nvPr>
-            <p:ph idx="102" type="title" hasCustomPrompt="1"/>
+            <p:ph type="title" idx="102" hasCustomPrompt="1"/>
           </p:nvPr>
         </p:nvSpPr>
         <p:spPr>
@@ -11066,7 +10825,7 @@
           <a:bodyPr wrap="square" lIns="0" tIns="0" rIns="0" bIns="0" rtlCol="0" anchor="t"/>
           <a:lstStyle/>
           <a:p>
-            <a:pPr algn="l" indent="0" marL="0">
+            <a:pPr marL="0" indent="0" algn="l">
               <a:buNone/>
             </a:pPr>
             <a:r>
@@ -11107,7 +10866,7 @@
             <a:prstDash val="solid"/>
           </a:ln>
           <a:effectLst>
-            <a:outerShdw sx="100000" sy="100000" kx="0" ky="0" algn="bl" rotWithShape="0" blurRad="228600" dist="76200" dir="5400000">
+            <a:outerShdw blurRad="228600" dist="76200" dir="5400000" algn="bl" rotWithShape="0">
               <a:srgbClr val="000000">
                 <a:alpha val="55000"/>
               </a:srgbClr>
@@ -11141,7 +10900,7 @@
             <a:prstDash val="solid"/>
           </a:ln>
           <a:effectLst>
-            <a:outerShdw sx="100000" sy="100000" kx="0" ky="0" algn="bl" rotWithShape="0" blurRad="228600" dist="76200" dir="5400000">
+            <a:outerShdw blurRad="228600" dist="76200" dir="5400000" algn="bl" rotWithShape="0">
               <a:srgbClr val="000000">
                 <a:alpha val="55000"/>
               </a:srgbClr>
@@ -11170,7 +10929,7 @@
           <a:bodyPr wrap="square" lIns="0" tIns="0" rIns="0" bIns="0" rtlCol="0" anchor="t"/>
           <a:lstStyle/>
           <a:p>
-            <a:pPr indent="0" marL="0">
+            <a:pPr marL="0" indent="0">
               <a:buNone/>
             </a:pPr>
             <a:r>
@@ -11206,7 +10965,7 @@
           <a:bodyPr wrap="square" lIns="0" tIns="0" rIns="0" bIns="0" rtlCol="0" anchor="t"/>
           <a:lstStyle/>
           <a:p>
-            <a:pPr indent="0" marL="0">
+            <a:pPr marL="0" indent="0">
               <a:buNone/>
             </a:pPr>
             <a:r>
@@ -11242,7 +11001,7 @@
           <a:bodyPr wrap="square" lIns="0" tIns="0" rIns="0" bIns="0" rtlCol="0" anchor="t"/>
           <a:lstStyle/>
           <a:p>
-            <a:pPr indent="0" marL="0">
+            <a:pPr marL="0" indent="0">
               <a:buNone/>
             </a:pPr>
             <a:r>
@@ -11278,7 +11037,7 @@
           <a:bodyPr wrap="square" lIns="0" tIns="0" rIns="0" bIns="0" rtlCol="0" anchor="t"/>
           <a:lstStyle/>
           <a:p>
-            <a:pPr indent="0" marL="0">
+            <a:pPr marL="0" indent="0">
               <a:buNone/>
             </a:pPr>
             <a:r>
@@ -11314,7 +11073,7 @@
           <a:bodyPr wrap="square" lIns="0" tIns="0" rIns="0" bIns="0" rtlCol="0" anchor="t"/>
           <a:lstStyle/>
           <a:p>
-            <a:pPr indent="0" marL="0">
+            <a:pPr marL="0" indent="0">
               <a:buNone/>
             </a:pPr>
             <a:r>
@@ -11350,7 +11109,7 @@
           <a:bodyPr wrap="square" lIns="0" tIns="0" rIns="0" bIns="0" rtlCol="0" anchor="t"/>
           <a:lstStyle/>
           <a:p>
-            <a:pPr indent="0" marL="0">
+            <a:pPr marL="0" indent="0">
               <a:buNone/>
             </a:pPr>
             <a:r>
@@ -11386,7 +11145,7 @@
           <a:bodyPr wrap="square" lIns="0" tIns="0" rIns="0" bIns="0" rtlCol="0" anchor="t"/>
           <a:lstStyle/>
           <a:p>
-            <a:pPr indent="0" marL="0">
+            <a:pPr marL="0" indent="0">
               <a:buNone/>
             </a:pPr>
             <a:r>
@@ -11422,7 +11181,7 @@
           <a:bodyPr wrap="square" lIns="0" tIns="0" rIns="0" bIns="0" rtlCol="0" anchor="t"/>
           <a:lstStyle/>
           <a:p>
-            <a:pPr indent="0" marL="0">
+            <a:pPr marL="0" indent="0">
               <a:buNone/>
             </a:pPr>
             <a:r>
@@ -11458,7 +11217,7 @@
           <a:bodyPr wrap="square" lIns="0" tIns="0" rIns="0" bIns="0" rtlCol="0" anchor="t"/>
           <a:lstStyle/>
           <a:p>
-            <a:pPr indent="0" marL="0">
+            <a:pPr marL="0" indent="0">
               <a:buNone/>
             </a:pPr>
             <a:r>
@@ -11493,7 +11252,7 @@
           </a:prstGeom>
           <a:extLst>
             <a:ext uri="{C572A759-6A51-4108-AA02-DFA0A04FC94B}">
-              <ma14:wrappingTextBoxFlag xmlns:ma14="http://schemas.microsoft.com/office/mac/drawingml/2011/main" val="0"/>
+              <ma14:wrappingTextBoxFlag xmlns:ma14="http://schemas.microsoft.com/office/mac/drawingml/2011/main" xmlns="" val="0"/>
             </a:ext>
           </a:extLst>
         </p:spPr>
@@ -11511,7 +11270,7 @@
           <a:p>
             <a:pPr algn="r"/>
             <a:fld id="{F7021451-1387-4CA6-816F-3879F97B5CBC}" type="slidenum">
-              <a:rPr b="0" lang="en-US"/>
+              <a:rPr lang="en-US" b="0"/>
               <a:t>9</a:t>
             </a:fld>
             <a:endParaRPr lang="en-US"/>
@@ -11569,7 +11328,7 @@
     </a:clrScheme>
     <a:fontScheme name="NeuroFly">
       <a:majorFont>
-        <a:latin typeface="Segoe UI"/>
+        <a:latin typeface="Roboto"/>
         <a:ea typeface=""/>
         <a:cs typeface=""/>
         <a:font script="Jpan" typeface="游ゴシック Light"/>
@@ -11621,7 +11380,7 @@
         <a:font script="Tfng" typeface="Ebrima"/>
       </a:majorFont>
       <a:minorFont>
-        <a:latin typeface="Segoe UI"/>
+        <a:latin typeface="Roboto"/>
         <a:ea typeface=""/>
         <a:cs typeface=""/>
         <a:font script="Jpan" typeface="游ゴシック"/>
@@ -11819,4 +11578,319 @@
     </a:ext>
   </a:extLst>
 </a:theme>
+</file>
+
+<file path=ppt/theme/theme2.xml><?xml version="1.0" encoding="utf-8"?>
+<a:theme xmlns:a="http://schemas.openxmlformats.org/drawingml/2006/main" name="Office Theme">
+  <a:themeElements>
+    <a:clrScheme name="Office">
+      <a:dk1>
+        <a:sysClr val="windowText" lastClr="000000"/>
+      </a:dk1>
+      <a:lt1>
+        <a:sysClr val="window" lastClr="FFFFFF"/>
+      </a:lt1>
+      <a:dk2>
+        <a:srgbClr val="0E2841"/>
+      </a:dk2>
+      <a:lt2>
+        <a:srgbClr val="E8E8E8"/>
+      </a:lt2>
+      <a:accent1>
+        <a:srgbClr val="156082"/>
+      </a:accent1>
+      <a:accent2>
+        <a:srgbClr val="E97132"/>
+      </a:accent2>
+      <a:accent3>
+        <a:srgbClr val="196B24"/>
+      </a:accent3>
+      <a:accent4>
+        <a:srgbClr val="0F9ED5"/>
+      </a:accent4>
+      <a:accent5>
+        <a:srgbClr val="A02B93"/>
+      </a:accent5>
+      <a:accent6>
+        <a:srgbClr val="4EA72E"/>
+      </a:accent6>
+      <a:hlink>
+        <a:srgbClr val="467886"/>
+      </a:hlink>
+      <a:folHlink>
+        <a:srgbClr val="96607D"/>
+      </a:folHlink>
+    </a:clrScheme>
+    <a:fontScheme name="Office">
+      <a:majorFont>
+        <a:latin typeface="Aptos Display" panose="02110004020202020204"/>
+        <a:ea typeface=""/>
+        <a:cs typeface=""/>
+        <a:font script="Jpan" typeface="游ゴシック Light"/>
+        <a:font script="Hang" typeface="맑은 고딕"/>
+        <a:font script="Hans" typeface="等线 Light"/>
+        <a:font script="Hant" typeface="新細明體"/>
+        <a:font script="Arab" typeface="Times New Roman"/>
+        <a:font script="Hebr" typeface="Times New Roman"/>
+        <a:font script="Thai" typeface="Angsana New"/>
+        <a:font script="Ethi" typeface="Nyala"/>
+        <a:font script="Beng" typeface="Vrinda"/>
+        <a:font script="Gujr" typeface="Shruti"/>
+        <a:font script="Khmr" typeface="MoolBoran"/>
+        <a:font script="Knda" typeface="Tunga"/>
+        <a:font script="Guru" typeface="Raavi"/>
+        <a:font script="Cans" typeface="Euphemia"/>
+        <a:font script="Cher" typeface="Plantagenet Cherokee"/>
+        <a:font script="Yiii" typeface="Microsoft Yi Baiti"/>
+        <a:font script="Tibt" typeface="Microsoft Himalaya"/>
+        <a:font script="Thaa" typeface="MV Boli"/>
+        <a:font script="Deva" typeface="Mangal"/>
+        <a:font script="Telu" typeface="Gautami"/>
+        <a:font script="Taml" typeface="Latha"/>
+        <a:font script="Syrc" typeface="Estrangelo Edessa"/>
+        <a:font script="Orya" typeface="Kalinga"/>
+        <a:font script="Mlym" typeface="Kartika"/>
+        <a:font script="Laoo" typeface="DokChampa"/>
+        <a:font script="Sinh" typeface="Iskoola Pota"/>
+        <a:font script="Mong" typeface="Mongolian Baiti"/>
+        <a:font script="Viet" typeface="Times New Roman"/>
+        <a:font script="Uigh" typeface="Microsoft Uighur"/>
+        <a:font script="Geor" typeface="Sylfaen"/>
+        <a:font script="Armn" typeface="Arial"/>
+        <a:font script="Bugi" typeface="Leelawadee UI"/>
+        <a:font script="Bopo" typeface="Microsoft JhengHei"/>
+        <a:font script="Java" typeface="Javanese Text"/>
+        <a:font script="Lisu" typeface="Segoe UI"/>
+        <a:font script="Mymr" typeface="Myanmar Text"/>
+        <a:font script="Nkoo" typeface="Ebrima"/>
+        <a:font script="Olck" typeface="Nirmala UI"/>
+        <a:font script="Osma" typeface="Ebrima"/>
+        <a:font script="Phag" typeface="Phagspa"/>
+        <a:font script="Syrn" typeface="Estrangelo Edessa"/>
+        <a:font script="Syrj" typeface="Estrangelo Edessa"/>
+        <a:font script="Syre" typeface="Estrangelo Edessa"/>
+        <a:font script="Sora" typeface="Nirmala UI"/>
+        <a:font script="Tale" typeface="Microsoft Tai Le"/>
+        <a:font script="Talu" typeface="Microsoft New Tai Lue"/>
+        <a:font script="Tfng" typeface="Ebrima"/>
+      </a:majorFont>
+      <a:minorFont>
+        <a:latin typeface="Aptos" panose="02110004020202020204"/>
+        <a:ea typeface=""/>
+        <a:cs typeface=""/>
+        <a:font script="Jpan" typeface="游ゴシック"/>
+        <a:font script="Hang" typeface="맑은 고딕"/>
+        <a:font script="Hans" typeface="等线"/>
+        <a:font script="Hant" typeface="新細明體"/>
+        <a:font script="Arab" typeface="Arial"/>
+        <a:font script="Hebr" typeface="Arial"/>
+        <a:font script="Thai" typeface="Cordia New"/>
+        <a:font script="Ethi" typeface="Nyala"/>
+        <a:font script="Beng" typeface="Vrinda"/>
+        <a:font script="Gujr" typeface="Shruti"/>
+        <a:font script="Khmr" typeface="DaunPenh"/>
+        <a:font script="Knda" typeface="Tunga"/>
+        <a:font script="Guru" typeface="Raavi"/>
+        <a:font script="Cans" typeface="Euphemia"/>
+        <a:font script="Cher" typeface="Plantagenet Cherokee"/>
+        <a:font script="Yiii" typeface="Microsoft Yi Baiti"/>
+        <a:font script="Tibt" typeface="Microsoft Himalaya"/>
+        <a:font script="Thaa" typeface="MV Boli"/>
+        <a:font script="Deva" typeface="Mangal"/>
+        <a:font script="Telu" typeface="Gautami"/>
+        <a:font script="Taml" typeface="Latha"/>
+        <a:font script="Syrc" typeface="Estrangelo Edessa"/>
+        <a:font script="Orya" typeface="Kalinga"/>
+        <a:font script="Mlym" typeface="Kartika"/>
+        <a:font script="Laoo" typeface="DokChampa"/>
+        <a:font script="Sinh" typeface="Iskoola Pota"/>
+        <a:font script="Mong" typeface="Mongolian Baiti"/>
+        <a:font script="Viet" typeface="Arial"/>
+        <a:font script="Uigh" typeface="Microsoft Uighur"/>
+        <a:font script="Geor" typeface="Sylfaen"/>
+        <a:font script="Armn" typeface="Arial"/>
+        <a:font script="Bugi" typeface="Leelawadee UI"/>
+        <a:font script="Bopo" typeface="Microsoft JhengHei"/>
+        <a:font script="Java" typeface="Javanese Text"/>
+        <a:font script="Lisu" typeface="Segoe UI"/>
+        <a:font script="Mymr" typeface="Myanmar Text"/>
+        <a:font script="Nkoo" typeface="Ebrima"/>
+        <a:font script="Olck" typeface="Nirmala UI"/>
+        <a:font script="Osma" typeface="Ebrima"/>
+        <a:font script="Phag" typeface="Phagspa"/>
+        <a:font script="Syrn" typeface="Estrangelo Edessa"/>
+        <a:font script="Syrj" typeface="Estrangelo Edessa"/>
+        <a:font script="Syre" typeface="Estrangelo Edessa"/>
+        <a:font script="Sora" typeface="Nirmala UI"/>
+        <a:font script="Tale" typeface="Microsoft Tai Le"/>
+        <a:font script="Talu" typeface="Microsoft New Tai Lue"/>
+        <a:font script="Tfng" typeface="Ebrima"/>
+      </a:minorFont>
+    </a:fontScheme>
+    <a:fmtScheme name="Office">
+      <a:fillStyleLst>
+        <a:solidFill>
+          <a:schemeClr val="phClr"/>
+        </a:solidFill>
+        <a:gradFill rotWithShape="1">
+          <a:gsLst>
+            <a:gs pos="0">
+              <a:schemeClr val="phClr">
+                <a:lumMod val="110000"/>
+                <a:satMod val="105000"/>
+                <a:tint val="67000"/>
+              </a:schemeClr>
+            </a:gs>
+            <a:gs pos="50000">
+              <a:schemeClr val="phClr">
+                <a:lumMod val="105000"/>
+                <a:satMod val="103000"/>
+                <a:tint val="73000"/>
+              </a:schemeClr>
+            </a:gs>
+            <a:gs pos="100000">
+              <a:schemeClr val="phClr">
+                <a:lumMod val="105000"/>
+                <a:satMod val="109000"/>
+                <a:tint val="81000"/>
+              </a:schemeClr>
+            </a:gs>
+          </a:gsLst>
+          <a:lin ang="5400000" scaled="0"/>
+        </a:gradFill>
+        <a:gradFill rotWithShape="1">
+          <a:gsLst>
+            <a:gs pos="0">
+              <a:schemeClr val="phClr">
+                <a:satMod val="103000"/>
+                <a:lumMod val="102000"/>
+                <a:tint val="94000"/>
+              </a:schemeClr>
+            </a:gs>
+            <a:gs pos="50000">
+              <a:schemeClr val="phClr">
+                <a:satMod val="110000"/>
+                <a:lumMod val="100000"/>
+                <a:shade val="100000"/>
+              </a:schemeClr>
+            </a:gs>
+            <a:gs pos="100000">
+              <a:schemeClr val="phClr">
+                <a:lumMod val="99000"/>
+                <a:satMod val="120000"/>
+                <a:shade val="78000"/>
+              </a:schemeClr>
+            </a:gs>
+          </a:gsLst>
+          <a:lin ang="5400000" scaled="0"/>
+        </a:gradFill>
+      </a:fillStyleLst>
+      <a:lnStyleLst>
+        <a:ln w="12700" cap="flat" cmpd="sng" algn="ctr">
+          <a:solidFill>
+            <a:schemeClr val="phClr"/>
+          </a:solidFill>
+          <a:prstDash val="solid"/>
+          <a:miter lim="800000"/>
+        </a:ln>
+        <a:ln w="19050" cap="flat" cmpd="sng" algn="ctr">
+          <a:solidFill>
+            <a:schemeClr val="phClr"/>
+          </a:solidFill>
+          <a:prstDash val="solid"/>
+          <a:miter lim="800000"/>
+        </a:ln>
+        <a:ln w="25400" cap="flat" cmpd="sng" algn="ctr">
+          <a:solidFill>
+            <a:schemeClr val="phClr"/>
+          </a:solidFill>
+          <a:prstDash val="solid"/>
+          <a:miter lim="800000"/>
+        </a:ln>
+      </a:lnStyleLst>
+      <a:effectStyleLst>
+        <a:effectStyle>
+          <a:effectLst/>
+        </a:effectStyle>
+        <a:effectStyle>
+          <a:effectLst/>
+        </a:effectStyle>
+        <a:effectStyle>
+          <a:effectLst>
+            <a:outerShdw blurRad="57150" dist="19050" dir="5400000" algn="ctr" rotWithShape="0">
+              <a:srgbClr val="000000">
+                <a:alpha val="63000"/>
+              </a:srgbClr>
+            </a:outerShdw>
+          </a:effectLst>
+        </a:effectStyle>
+      </a:effectStyleLst>
+      <a:bgFillStyleLst>
+        <a:solidFill>
+          <a:schemeClr val="phClr"/>
+        </a:solidFill>
+        <a:solidFill>
+          <a:schemeClr val="phClr">
+            <a:tint val="95000"/>
+            <a:satMod val="170000"/>
+          </a:schemeClr>
+        </a:solidFill>
+        <a:gradFill rotWithShape="1">
+          <a:gsLst>
+            <a:gs pos="0">
+              <a:schemeClr val="phClr">
+                <a:tint val="93000"/>
+                <a:satMod val="150000"/>
+                <a:shade val="98000"/>
+                <a:lumMod val="102000"/>
+              </a:schemeClr>
+            </a:gs>
+            <a:gs pos="50000">
+              <a:schemeClr val="phClr">
+                <a:tint val="98000"/>
+                <a:satMod val="130000"/>
+                <a:shade val="90000"/>
+                <a:lumMod val="103000"/>
+              </a:schemeClr>
+            </a:gs>
+            <a:gs pos="100000">
+              <a:schemeClr val="phClr">
+                <a:shade val="63000"/>
+                <a:satMod val="120000"/>
+              </a:schemeClr>
+            </a:gs>
+          </a:gsLst>
+          <a:lin ang="5400000" scaled="0"/>
+        </a:gradFill>
+      </a:bgFillStyleLst>
+    </a:fmtScheme>
+  </a:themeElements>
+  <a:objectDefaults>
+    <a:lnDef>
+      <a:spPr/>
+      <a:bodyPr/>
+      <a:lstStyle/>
+      <a:style>
+        <a:lnRef idx="2">
+          <a:schemeClr val="accent1"/>
+        </a:lnRef>
+        <a:fillRef idx="0">
+          <a:schemeClr val="accent1"/>
+        </a:fillRef>
+        <a:effectRef idx="1">
+          <a:schemeClr val="accent1"/>
+        </a:effectRef>
+        <a:fontRef idx="minor">
+          <a:schemeClr val="tx1"/>
+        </a:fontRef>
+      </a:style>
+    </a:lnDef>
+  </a:objectDefaults>
+  <a:extraClrSchemeLst/>
+  <a:extLst>
+    <a:ext uri="{05A4C25C-085E-4340-85A3-A5531E510DB2}">
+      <thm15:themeFamily xmlns:thm15="http://schemas.microsoft.com/office/thememl/2012/main" name="Office Theme" id="{2E142A2C-CD16-42D6-873A-C26D2A0506FA}" vid="{1BDDFF52-6CD6-40A5-AB3C-68EB2F1E4D0A}"/>
+    </a:ext>
+  </a:extLst>
+</a:theme>
 </file>
</xml_diff>

<commit_message>
Presentation fully in English (slides, charts, speaker notes, sections, render labels)
Co-Authored-By: Claude Opus 5.5 <noreply@anthropic.com>
Claude-Session: https://claude.ai/code/session_01SiWtycbk3CawaRuqShhbfb
</commit_message>
<xml_diff>
--- a/docs/prezentacja/NeuroFly.pptx
+++ b/docs/prezentacja/NeuroFly.pptx
@@ -137,57 +137,57 @@
   <p:extLst>
     <p:ext uri="{521415D9-36F7-43E2-AB2F-B90AF26B5E84}">
       <p14:sectionLst xmlns:p14="http://schemas.microsoft.com/office/powerpoint/2010/main">
-        <p14:section name="Start" id="{B4698A53-E9A4-8FD9-8FC2-901CD3FD4E30}">
+        <p14:section name="Start" id="{FB6E13BF-C035-7F55-0696-FD610149666C}">
           <p14:sldIdLst>
             <p14:sldId id="256"/>
           </p14:sldIdLst>
         </p14:section>
-        <p14:section name="Idea" id="{EDA2C285-5694-0EFE-3381-A1E089D14F59}">
+        <p14:section name="Idea" id="{250CF0A0-E863-AA9C-2BFF-BCCE433E0432}">
           <p14:sldIdLst>
             <p14:sldId id="257"/>
           </p14:sldIdLst>
         </p14:section>
-        <p14:section name="Pipeline" id="{44615E25-F902-9F94-1659-411A0A0C7B93}">
+        <p14:section name="Pipeline" id="{91F7B295-DEDC-B4E1-26EF-C614C8A84199}">
           <p14:sldIdLst>
             <p14:sldId id="258"/>
             <p14:sldId id="259"/>
           </p14:sldIdLst>
         </p14:section>
-        <p14:section name="Connectome" id="{D0FE2DD8-74B5-E6CB-9E3E-FDB74A4FB596}">
+        <p14:section name="Connectome" id="{F60BEFC2-1409-8BBF-7704-1D356BA5F608}">
           <p14:sldIdLst>
             <p14:sldId id="260"/>
             <p14:sldId id="261"/>
             <p14:sldId id="262"/>
           </p14:sldIdLst>
         </p14:section>
-        <p14:section name="Odczyt" id="{BA5F89ED-B7BD-DDBF-DF30-7E47CCDB5436}">
+        <p14:section name="Readout" id="{4A1CC517-49B9-48E8-7CD4-D730C728C284}">
           <p14:sldIdLst>
             <p14:sldId id="263"/>
             <p14:sldId id="264"/>
           </p14:sldIdLst>
         </p14:section>
-        <p14:section name="Symulator" id="{F566EDF2-687A-617E-1963-1E0420337780}">
+        <p14:section name="Simulator" id="{61234118-9B33-CBD5-528B-5D124120798B}">
           <p14:sldIdLst>
             <p14:sldId id="265"/>
           </p14:sldIdLst>
         </p14:section>
-        <p14:section name="Trening" id="{598CE636-DD19-9F8D-342D-8DBD0D818BBD}">
+        <p14:section name="Training" id="{BF38974E-F903-03AB-67F8-EC176AC089FE}">
           <p14:sldIdLst>
             <p14:sldId id="266"/>
           </p14:sldIdLst>
         </p14:section>
-        <p14:section name="Wyniki" id="{FB0ACF77-609E-78ED-E52B-E60492E9D717}">
+        <p14:section name="Results" id="{539F093A-199C-5001-78F4-FB654C5A7769}">
           <p14:sldIdLst>
             <p14:sldId id="267"/>
             <p14:sldId id="268"/>
           </p14:sldIdLst>
         </p14:section>
-        <p14:section name="Uczciwość" id="{25EEECC2-9FB7-E063-D2D3-812D36142CA7}">
+        <p14:section name="Honesty" id="{DBA1D4B3-EF38-2B65-9D72-1D2EF0526B37}">
           <p14:sldIdLst>
             <p14:sldId id="269"/>
           </p14:sldIdLst>
         </p14:section>
-        <p14:section name="Koniec" id="{A1EE520F-96A5-284E-F29C-70F4011ACE7F}">
+        <p14:section name="End" id="{53C82087-E89F-5EC5-F4F3-B161D8E954E3}">
           <p14:sldIdLst>
             <p14:sldId id="270"/>
           </p14:sldIdLst>
@@ -224,7 +224,7 @@
               <c:strCache>
                 <c:ptCount val="1"/>
                 <c:pt idx="0">
-                  <c:v>Trafność strony celu</c:v>
+                  <c:v>Target-side accuracy</c:v>
                 </c:pt>
               </c:strCache>
             </c:strRef>
@@ -242,7 +242,7 @@
             <c:bubble3D val="0"/>
             <c:extLst>
               <c:ext xmlns:c16="http://schemas.microsoft.com/office/drawing/2014/chart" uri="{C3380CC4-5D6E-409C-BE32-E72D297353CC}">
-                <c16:uniqueId val="{00000001-1A1B-4A1A-A048-583FEE77A83A}"/>
+                <c16:uniqueId val="{00000001-EC20-4BF7-826F-282EDA49CD58}"/>
               </c:ext>
             </c:extLst>
           </c:dPt>
@@ -252,7 +252,7 @@
             <c:bubble3D val="0"/>
             <c:extLst>
               <c:ext xmlns:c16="http://schemas.microsoft.com/office/drawing/2014/chart" uri="{C3380CC4-5D6E-409C-BE32-E72D297353CC}">
-                <c16:uniqueId val="{00000003-1A1B-4A1A-A048-583FEE77A83A}"/>
+                <c16:uniqueId val="{00000003-EC20-4BF7-826F-282EDA49CD58}"/>
               </c:ext>
             </c:extLst>
           </c:dPt>
@@ -262,7 +262,7 @@
             <c:bubble3D val="0"/>
             <c:extLst>
               <c:ext xmlns:c16="http://schemas.microsoft.com/office/drawing/2014/chart" uri="{C3380CC4-5D6E-409C-BE32-E72D297353CC}">
-                <c16:uniqueId val="{00000005-1A1B-4A1A-A048-583FEE77A83A}"/>
+                <c16:uniqueId val="{00000005-EC20-4BF7-826F-282EDA49CD58}"/>
               </c:ext>
             </c:extLst>
           </c:dPt>
@@ -278,7 +278,7 @@
             </c:spPr>
             <c:extLst>
               <c:ext xmlns:c16="http://schemas.microsoft.com/office/drawing/2014/chart" uri="{C3380CC4-5D6E-409C-BE32-E72D297353CC}">
-                <c16:uniqueId val="{00000007-1A1B-4A1A-A048-583FEE77A83A}"/>
+                <c16:uniqueId val="{00000007-EC20-4BF7-826F-282EDA49CD58}"/>
               </c:ext>
             </c:extLst>
           </c:dPt>
@@ -325,16 +325,16 @@
               <c:strCache>
                 <c:ptCount val="4"/>
                 <c:pt idx="0">
-                  <c:v>6 średnich MN</c:v>
+                  <c:v>6 MN averages</c:v>
                 </c:pt>
                 <c:pt idx="1">
-                  <c:v>MN pojedynczo</c:v>
+                  <c:v>single MNs</c:v>
                 </c:pt>
                 <c:pt idx="2">
-                  <c:v>wzrok (VPN)</c:v>
+                  <c:v>vision (VPN)</c:v>
                 </c:pt>
                 <c:pt idx="3">
-                  <c:v>DN lotu pojedynczo</c:v>
+                  <c:v>single flight DNs</c:v>
                 </c:pt>
               </c:strCache>
             </c:strRef>
@@ -362,7 +362,7 @@
           </c:val>
           <c:extLst>
             <c:ext xmlns:c16="http://schemas.microsoft.com/office/drawing/2014/chart" uri="{C3380CC4-5D6E-409C-BE32-E72D297353CC}">
-              <c16:uniqueId val="{00000008-1A1B-4A1A-A048-583FEE77A83A}"/>
+              <c16:uniqueId val="{00000008-EC20-4BF7-826F-282EDA49CD58}"/>
             </c:ext>
           </c:extLst>
         </c:ser>
@@ -483,7 +483,7 @@
               <c:strCache>
                 <c:ptCount val="1"/>
                 <c:pt idx="0">
-                  <c:v>przed treningiem</c:v>
+                  <c:v>before training</c:v>
                 </c:pt>
               </c:strCache>
             </c:strRef>
@@ -538,16 +538,16 @@
               <c:strCache>
                 <c:ptCount val="4"/>
                 <c:pt idx="0">
-                  <c:v>cel −60°</c:v>
+                  <c:v>target −60°</c:v>
                 </c:pt>
                 <c:pt idx="1">
-                  <c:v>cel −30°</c:v>
+                  <c:v>target −30°</c:v>
                 </c:pt>
                 <c:pt idx="2">
-                  <c:v>cel +30°</c:v>
+                  <c:v>target +30°</c:v>
                 </c:pt>
                 <c:pt idx="3">
-                  <c:v>cel +60°</c:v>
+                  <c:v>target +60°</c:v>
                 </c:pt>
               </c:strCache>
             </c:strRef>
@@ -575,7 +575,7 @@
           </c:val>
           <c:extLst>
             <c:ext xmlns:c16="http://schemas.microsoft.com/office/drawing/2014/chart" uri="{C3380CC4-5D6E-409C-BE32-E72D297353CC}">
-              <c16:uniqueId val="{00000000-176B-410A-A02C-EE2A4C1F5D0C}"/>
+              <c16:uniqueId val="{00000000-1943-421B-85CC-D31D27965D66}"/>
             </c:ext>
           </c:extLst>
         </c:ser>
@@ -588,7 +588,7 @@
               <c:strCache>
                 <c:ptCount val="1"/>
                 <c:pt idx="0">
-                  <c:v>po treningu</c:v>
+                  <c:v>after training</c:v>
                 </c:pt>
               </c:strCache>
             </c:strRef>
@@ -643,16 +643,16 @@
               <c:strCache>
                 <c:ptCount val="4"/>
                 <c:pt idx="0">
-                  <c:v>cel −60°</c:v>
+                  <c:v>target −60°</c:v>
                 </c:pt>
                 <c:pt idx="1">
-                  <c:v>cel −30°</c:v>
+                  <c:v>target −30°</c:v>
                 </c:pt>
                 <c:pt idx="2">
-                  <c:v>cel +30°</c:v>
+                  <c:v>target +30°</c:v>
                 </c:pt>
                 <c:pt idx="3">
-                  <c:v>cel +60°</c:v>
+                  <c:v>target +60°</c:v>
                 </c:pt>
               </c:strCache>
             </c:strRef>
@@ -680,7 +680,7 @@
           </c:val>
           <c:extLst>
             <c:ext xmlns:c16="http://schemas.microsoft.com/office/drawing/2014/chart" uri="{C3380CC4-5D6E-409C-BE32-E72D297353CC}">
-              <c16:uniqueId val="{00000001-176B-410A-A02C-EE2A4C1F5D0C}"/>
+              <c16:uniqueId val="{00000001-1943-421B-85CC-D31D27965D66}"/>
             </c:ext>
           </c:extLst>
         </c:ser>
@@ -823,7 +823,7 @@
     </p:spTree>
     <p:extLst>
       <p:ext uri="{BB962C8B-B14F-4D97-AF65-F5344CB8AC3E}">
-        <p14:creationId xmlns:p14="http://schemas.microsoft.com/office/powerpoint/2010/main" val="4160350180"/>
+        <p14:creationId xmlns:p14="http://schemas.microsoft.com/office/powerpoint/2010/main" val="3818031567"/>
       </p:ext>
     </p:extLst>
   </p:cSld>
@@ -969,7 +969,7 @@
           <a:p>
             <a:r>
               <a:rPr lang="en-US" dirty="0"/>
-              <a:t>NeuroFly: obraz z kamer drona przechodzi przez model oka muszki (FlyVis), potem przez prawdziwy connectome Drosophila (BANC v888, mózg + brzuszny łańcuch nerwowy), a aktywność neuronów lotu steruje dronem w symulatorze. Render: półprzezroczyste ciało NeuroMechFly (FlyGym) z connectomem BANC w środku — dopasowanie ciała ilustracyjne.</a:t>
+              <a:t>NeuroFly: the drone camera image goes through a model of the fly eye (FlyVis), then through the real Drosophila connectome (BANC v888, brain + ventral nerve cord), and flight-neuron activity steers the drone in simulation. Render: semi-transparent NeuroMechFly body (FlyGym) with the BANC connectome inside — body alignment is illustrative.</a:t>
             </a:r>
           </a:p>
         </p:txBody>
@@ -1560,7 +1560,7 @@
           <a:p>
             <a:r>
               <a:rPr lang="en-US" dirty="0"/>
-              <a:t>Każda klatka obrazu przechodzi przez całą pętlę ~30 razy na sekundę. Nic nie jest ręcznie zaprogramowanym regulatorem kursu: kierunek do celu odczytujemy z aktywności neuronów zstępujących (DN) w BANC.</a:t>
+              <a:t>Every camera frame goes through the whole loop ~30 times per second. There is no hand-coded heading controller: the direction to the target is read out from descending-neuron (DN) activity in BANC.</a:t>
             </a:r>
           </a:p>
         </p:txBody>
@@ -1647,7 +1647,7 @@
           <a:p>
             <a:r>
               <a:rPr lang="en-US" dirty="0"/>
-              <a:t>Górny rząd: wszystko, co dzieje się przed connectomem. Dolny: connectome, odczyt neuronów lotu, dekoder i dron. Jedna klatka (FlyVis + 4 podkroki dynamiki BANC na GPU) to ~15–20 ms.</a:t>
+              <a:t>Top row: everything that happens before the connectome. Bottom row: connectome, flight-neuron readout, decoder and drone. One frame (FlyVis + 4 BANC dynamics substeps on the GPU) takes ~15–20 ms.</a:t>
             </a:r>
           </a:p>
         </p:txBody>
@@ -1734,7 +1734,7 @@
           <a:p>
             <a:r>
               <a:rPr lang="en-US" dirty="0"/>
-              <a:t>Cel (czarny słup) jest po prawej stronie: widać go tylko w prawym oku, jako ciemną kolumnę ommatidiów.</a:t>
+              <a:t>The target (dark pole) is on the right: only the right eye sees it, as a dark column of ommatidia.</a:t>
             </a:r>
           </a:p>
         </p:txBody>
@@ -1821,7 +1821,7 @@
           <a:p>
             <a:r>
               <a:rPr lang="en-US" dirty="0"/>
-              <a:t>Oficjalny BANC v888 (Bates et al. 2026, publiczny bucket Lee Lab). Somy z kolumny position; kolory jak w eksploratorze: wzrok teal, interneurony fiolet, DN amber, motoneurony rose. Żadnych syntetycznych grafów.</a:t>
+              <a:t>Official BANC v888 (Bates et al. 2026, public Lee Lab bucket). Somas from the position column; colors as in the explorer: vision teal, interneurons violet, DNs amber, motor neurons rose. No synthetic graphs.</a:t>
             </a:r>
           </a:p>
         </p:txBody>
@@ -2076,7 +2076,7 @@
           <a:p>
             <a:r>
               <a:rPr lang="en-US" dirty="0"/>
-              <a:t>Regresja grzbietowa kąt ~ aktywność, cel pod kątami −90…+90° w 3 odległościach, walidacja na odległości pominiętej w uczeniu (scripts/check_side_decoding.py).</a:t>
+              <a:t>Ridge regression angle ~ activity, target at −90…+90° at 3 distances, validated on the distance left out of training (scripts/check_side_decoding.py).</a:t>
             </a:r>
           </a:p>
         </p:txBody>
@@ -2903,7 +2903,7 @@
                   <a:srgbClr val="A1A1AA"/>
                 </a:solidFill>
               </a:rPr>
-              <a:t>Mózg muszki owocowej</a:t>
+              <a:t>A fruit-fly brain</a:t>
             </a:r>
             <a:endParaRPr lang="en-US" sz="2000" dirty="0"/>
           </a:p>
@@ -2917,7 +2917,7 @@
                   <a:srgbClr val="A1A1AA"/>
                 </a:solidFill>
               </a:rPr>
-              <a:t>pilotuje drona</a:t>
+              <a:t>flies a drone</a:t>
             </a:r>
             <a:endParaRPr lang="en-US" sz="2000" dirty="0"/>
           </a:p>
@@ -2953,7 +2953,7 @@
                   <a:srgbClr val="52525B"/>
                 </a:solidFill>
               </a:rPr>
-              <a:t>Pełny connectome BANC v888 · 175 401 neuronów · pętla zamknięta w MuJoCo</a:t>
+              <a:t>Full BANC v888 connectome · 175,401 neurons · closed loop in MuJoCo</a:t>
             </a:r>
             <a:endParaRPr lang="en-US" sz="1200" dirty="0"/>
           </a:p>
@@ -3018,7 +3018,7 @@
                   <a:srgbClr val="FAFAFA"/>
                 </a:solidFill>
               </a:rPr>
-              <a:t>Symulator: dron X2 w MuJoCo</a:t>
+              <a:t>Simulator: X2 drone in MuJoCo</a:t>
             </a:r>
             <a:endParaRPr lang="en-US" sz="2800" dirty="0"/>
           </a:p>
@@ -3116,7 +3116,7 @@
                   <a:srgbClr val="A1A1AA"/>
                 </a:solidFill>
               </a:rPr>
-              <a:t>Skydio X2 (MuJoCo Menagerie) z oczami na nosie · zawis i obrót na płaskiej scenie</a:t>
+              <a:t>Skydio X2 (MuJoCo Menagerie) with eyes on the nose · hover and turn on a flat scene</a:t>
             </a:r>
             <a:endParaRPr lang="en-US" sz="1100" dirty="0"/>
           </a:p>
@@ -3152,7 +3152,7 @@
                   <a:srgbClr val="A1A1AA"/>
                 </a:solidFill>
               </a:rPr>
-              <a:t>Losowy teren 60 × 60 m, bloki, cel z masztem · tryb angle: symulator utrzymuje zadany przechył</a:t>
+              <a:t>Random 60 × 60 m terrain, blocks, target · angle mode: the simulator holds the commanded tilt</a:t>
             </a:r>
             <a:endParaRPr lang="en-US" sz="1100" dirty="0"/>
           </a:p>
@@ -3262,7 +3262,7 @@
                   <a:srgbClr val="FAFAFA"/>
                 </a:solidFill>
               </a:rPr>
-              <a:t>Trening: uczy się tylko dekoder, BANC się nie zmienia</a:t>
+              <a:t>Training: only the decoder learns, BANC stays fixed</a:t>
             </a:r>
             <a:endParaRPr lang="en-US" sz="2800" dirty="0"/>
           </a:p>
@@ -3368,7 +3368,7 @@
                   <a:srgbClr val="FAFAFA"/>
                 </a:solidFill>
               </a:rPr>
-              <a:t>Nauczyciel</a:t>
+              <a:t>Teacher</a:t>
             </a:r>
             <a:endParaRPr lang="en-US" sz="1400" dirty="0"/>
           </a:p>
@@ -3404,7 +3404,7 @@
                   <a:srgbClr val="A1A1AA"/>
                 </a:solidFill>
               </a:rPr>
-              <a:t>zna prawdziwy stan: kąt do celu, wysokość, prędkość</a:t>
+              <a:t>knows the true state: target bearing, height, speed</a:t>
             </a:r>
             <a:endParaRPr lang="en-US" sz="1100" dirty="0"/>
           </a:p>
@@ -3510,7 +3510,7 @@
                   <a:srgbClr val="FAFAFA"/>
                 </a:solidFill>
               </a:rPr>
-              <a:t>Lot mieszany</a:t>
+              <a:t>Mixed flight</a:t>
             </a:r>
             <a:endParaRPr lang="en-US" sz="1400" dirty="0"/>
           </a:p>
@@ -3546,7 +3546,7 @@
                   <a:srgbClr val="A1A1AA"/>
                 </a:solidFill>
               </a:rPr>
-              <a:t>z prawdopodobieństwem β steruje nauczyciel, β: 1 → 0</a:t>
+              <a:t>the teacher flies with probability β, β: 1 → 0</a:t>
             </a:r>
             <a:endParaRPr lang="en-US" sz="1100" dirty="0"/>
           </a:p>
@@ -3652,7 +3652,7 @@
                   <a:srgbClr val="FAFAFA"/>
                 </a:solidFill>
               </a:rPr>
-              <a:t>Dane</a:t>
+              <a:t>Data</a:t>
             </a:r>
             <a:endParaRPr lang="en-US" sz="1400" dirty="0"/>
           </a:p>
@@ -3688,7 +3688,7 @@
                   <a:srgbClr val="A1A1AA"/>
                 </a:solidFill>
               </a:rPr>
-              <a:t>pary (cechy, komenda nauczyciela); trudne próbki ×3–7</a:t>
+              <a:t>pairs (features, teacher command); hard samples ×3–7</a:t>
             </a:r>
             <a:endParaRPr lang="en-US" sz="1100" dirty="0"/>
           </a:p>
@@ -3794,7 +3794,7 @@
                   <a:srgbClr val="FAFAFA"/>
                 </a:solidFill>
               </a:rPr>
-              <a:t>Regresja</a:t>
+              <a:t>Regression</a:t>
             </a:r>
             <a:endParaRPr lang="en-US" sz="1400" dirty="0"/>
           </a:p>
@@ -3830,7 +3830,7 @@
                   <a:srgbClr val="A1A1AA"/>
                 </a:solidFill>
               </a:rPr>
-              <a:t>wagi od nowa na wszystkich danych (DAgger + ridge)</a:t>
+              <a:t>weights refit on all data (DAgger + ridge)</a:t>
             </a:r>
             <a:endParaRPr lang="en-US" sz="1100" dirty="0"/>
           </a:p>
@@ -3900,7 +3900,7 @@
                   <a:srgbClr val="FAFAFA"/>
                 </a:solidFill>
               </a:rPr>
-              <a:t>Podział osi</a:t>
+              <a:t>Axis split</a:t>
             </a:r>
             <a:endParaRPr lang="en-US" sz="1400" dirty="0"/>
           </a:p>
@@ -3961,7 +3961,7 @@
                   <a:srgbClr val="A1A1AA"/>
                 </a:solidFill>
               </a:rPr>
-              <a:t>yaw ← tylko BANC (DN)</a:t>
+              <a:t>yaw ← BANC only (DNs)</a:t>
             </a:r>
             <a:endParaRPr lang="en-US" sz="1100" dirty="0"/>
           </a:p>
@@ -4022,7 +4022,7 @@
                   <a:srgbClr val="A1A1AA"/>
                 </a:solidFill>
               </a:rPr>
-              <a:t>thrust/roll/pitch ← BANC + czujniki</a:t>
+              <a:t>thrust/roll/pitch ← BANC + sensors</a:t>
             </a:r>
             <a:endParaRPr lang="en-US" sz="1100" dirty="0"/>
           </a:p>
@@ -4092,7 +4092,7 @@
                   <a:srgbClr val="FAFAFA"/>
                 </a:solidFill>
               </a:rPr>
-              <a:t>2 GPU w LAN</a:t>
+              <a:t>2 GPUs over LAN</a:t>
             </a:r>
             <a:endParaRPr lang="en-US" sz="1400" dirty="0"/>
           </a:p>
@@ -4128,7 +4128,7 @@
                   <a:srgbClr val="A1A1AA"/>
                 </a:solidFill>
               </a:rPr>
-              <a:t>Master rozdaje światy, workerzy (RTX 4060, RTX 3070 Ti) liczą epizody i odsyłają tylko statystyki XᵀX, Xᵀy — bez klatek wideo.</a:t>
+              <a:t>The master hands out worlds, workers (RTX 4060, RTX 3070 Ti) run episodes and send back only the XᵀX, Xᵀy statistics — no video frames.</a:t>
             </a:r>
             <a:endParaRPr lang="en-US" sz="1100" dirty="0"/>
           </a:p>
@@ -4238,7 +4238,7 @@
                   <a:srgbClr val="FAFAFA"/>
                 </a:solidFill>
               </a:rPr>
-              <a:t>Wynik: skręt do celu z BANC</a:t>
+              <a:t>Result: turning toward the target with BANC</a:t>
             </a:r>
             <a:endParaRPr lang="en-US" sz="2800" dirty="0"/>
           </a:p>
@@ -4290,7 +4290,7 @@
                   <a:srgbClr val="2FD3C4"/>
                 </a:solidFill>
               </a:rPr>
-              <a:t>2,65°</a:t>
+              <a:t>2.65°</a:t>
             </a:r>
             <a:endParaRPr lang="en-US" sz="3600" dirty="0"/>
           </a:p>
@@ -4326,7 +4326,7 @@
                   <a:srgbClr val="A1A1AA"/>
                 </a:solidFill>
               </a:rPr>
-              <a:t>średni końcowy błąd kursu bez nauczyciela (przed treningiem 25,1°)</a:t>
+              <a:t>mean final heading error without the teacher (25.1° before training)</a:t>
             </a:r>
             <a:endParaRPr lang="en-US" sz="1200" dirty="0"/>
           </a:p>
@@ -4362,7 +4362,7 @@
                   <a:srgbClr val="FAFAFA"/>
                 </a:solidFill>
               </a:rPr>
-              <a:t>1000</a:t>
+              <a:t>1,000</a:t>
             </a:r>
             <a:endParaRPr lang="en-US" sz="3600" dirty="0"/>
           </a:p>
@@ -4398,7 +4398,7 @@
                   <a:srgbClr val="A1A1AA"/>
                 </a:solidFill>
               </a:rPr>
-              <a:t>epizodów na 2 GPU: 672 + 328</a:t>
+              <a:t>episodes on 2 GPUs: 672 + 328</a:t>
             </a:r>
             <a:endParaRPr lang="en-US" sz="1200" dirty="0"/>
           </a:p>
@@ -4434,7 +4434,7 @@
                   <a:srgbClr val="A1A1AA"/>
                 </a:solidFill>
               </a:rPr>
-              <a:t>Zawis na płaskiej scenie, wysokość trzyma symulator. Kierunek: wyłącznie pojedyncze DN z BANC.</a:t>
+              <a:t>Hover on a flat scene, height held by the simulator. Heading: single BANC DNs only.</a:t>
             </a:r>
             <a:endParaRPr lang="en-US" sz="1100" dirty="0"/>
           </a:p>
@@ -4544,7 +4544,7 @@
                   <a:srgbClr val="FAFAFA"/>
                 </a:solidFill>
               </a:rPr>
-              <a:t>Lot do celu w świecie: w toku</a:t>
+              <a:t>Flying to a target in the world: in progress</a:t>
             </a:r>
             <a:endParaRPr lang="en-US" sz="2800" dirty="0"/>
           </a:p>
@@ -4718,7 +4718,7 @@
                   <a:srgbClr val="A1A1AA"/>
                 </a:solidFill>
               </a:rPr>
-              <a:t>nauczyciel dolatuje do celu — jest od kogo się uczyć</a:t>
+              <a:t>the teacher reaches the target — there is something to learn from</a:t>
             </a:r>
             <a:endParaRPr lang="en-US" sz="1200" dirty="0"/>
           </a:p>
@@ -4754,7 +4754,7 @@
                   <a:srgbClr val="A1A1AA"/>
                 </a:solidFill>
               </a:rPr>
-              <a:t>18,1 m</a:t>
+              <a:t>18.1 m</a:t>
             </a:r>
             <a:endParaRPr lang="en-US" sz="3600" dirty="0"/>
           </a:p>
@@ -4790,7 +4790,7 @@
                   <a:srgbClr val="A1A1AA"/>
                 </a:solidFill>
               </a:rPr>
-              <a:t>przed treningiem: średnio najbliżej celu</a:t>
+              <a:t>before training: mean closest distance to the target</a:t>
             </a:r>
             <a:endParaRPr lang="en-US" sz="1200" dirty="0"/>
           </a:p>
@@ -4826,7 +4826,7 @@
                   <a:srgbClr val="2FD3C4"/>
                 </a:solidFill>
               </a:rPr>
-              <a:t>9,0 m</a:t>
+              <a:t>9.0 m</a:t>
             </a:r>
             <a:endParaRPr lang="en-US" sz="3600" dirty="0"/>
           </a:p>
@@ -4862,7 +4862,7 @@
                   <a:srgbClr val="A1A1AA"/>
                 </a:solidFill>
               </a:rPr>
-              <a:t>po 192 epizodach: 2× bliżej, 0 wywrotek, cel 0 / 6</a:t>
+              <a:t>after 192 episodes: 2× closer, 0 crashes, target 0 / 6</a:t>
             </a:r>
             <a:endParaRPr lang="en-US" sz="1200" dirty="0"/>
           </a:p>
@@ -4898,7 +4898,7 @@
                   <a:srgbClr val="A1A1AA"/>
                 </a:solidFill>
               </a:rPr>
-              <a:t>Uczciwie: model leci stabilnie i zbliża się do celu, ale jeszcze nie ląduje na polu. Kolejny trening: walidacja co 50 epizodów z zapisem najlepszych wag i doważenie trudnych próbek.</a:t>
+              <a:t>Honestly: the model flies stably and gets closer to the target, but does not reach it yet. Next run: validation every 50 episodes keeping the best weights, harder samples weighted up, GPS for long-range heading.</a:t>
             </a:r>
             <a:endParaRPr lang="en-US" sz="1300" dirty="0"/>
           </a:p>
@@ -5008,7 +5008,7 @@
                   <a:srgbClr val="FAFAFA"/>
                 </a:solidFill>
               </a:rPr>
-              <a:t>Co jest z BANC, a co jest naszym założeniem</a:t>
+              <a:t>From BANC vs. our assumptions</a:t>
             </a:r>
             <a:endParaRPr lang="en-US" sz="2800" dirty="0"/>
           </a:p>
@@ -5137,7 +5137,7 @@
                   <a:srgbClr val="A1A1AA"/>
                 </a:solidFill>
               </a:rPr>
-              <a:t>z BANC v888</a:t>
+              <a:t>from BANC v888</a:t>
             </a:r>
             <a:endParaRPr lang="en-US" sz="1100" dirty="0"/>
           </a:p>
@@ -5198,7 +5198,7 @@
                   <a:srgbClr val="A1A1AA"/>
                 </a:solidFill>
               </a:rPr>
-              <a:t>nasze założenia</a:t>
+              <a:t>our assumptions</a:t>
             </a:r>
             <a:endParaRPr lang="en-US" sz="1100" dirty="0"/>
           </a:p>
@@ -5238,7 +5238,7 @@
                   <a:srgbClr val="FAFAFA"/>
                 </a:solidFill>
               </a:rPr>
-              <a:t>neurony, połączenia, liczby synaps</a:t>
+              <a:t>neurons, connections, synapse counts</a:t>
             </a:r>
             <a:endParaRPr lang="en-US" sz="1400" dirty="0"/>
           </a:p>
@@ -5256,7 +5256,7 @@
                   <a:srgbClr val="FAFAFA"/>
                 </a:solidFill>
               </a:rPr>
-              <a:t>przewidywany neuroprzekaźnik</a:t>
+              <a:t>predicted neurotransmitter</a:t>
             </a:r>
             <a:endParaRPr lang="en-US" sz="1400" dirty="0"/>
           </a:p>
@@ -5274,7 +5274,7 @@
                   <a:srgbClr val="FAFAFA"/>
                 </a:solidFill>
               </a:rPr>
-              <a:t>grupy lotu z oficjalnych adnotacji</a:t>
+              <a:t>flight groups from official annotations</a:t>
             </a:r>
             <a:endParaRPr lang="en-US" sz="1400" dirty="0"/>
           </a:p>
@@ -5292,7 +5292,7 @@
                   <a:srgbClr val="FAFAFA"/>
                 </a:solidFill>
               </a:rPr>
-              <a:t>pozycje som i szkielety SWC</a:t>
+              <a:t>soma positions and SWC skeletons</a:t>
             </a:r>
             <a:endParaRPr lang="en-US" sz="1400" dirty="0"/>
           </a:p>
@@ -5332,7 +5332,7 @@
                   <a:srgbClr val="FAFAFA"/>
                 </a:solidFill>
               </a:rPr>
-              <a:t>model dynamiki i parametry</a:t>
+              <a:t>dynamics model and parameters</a:t>
             </a:r>
             <a:endParaRPr lang="en-US" sz="1400" dirty="0"/>
           </a:p>
@@ -5350,7 +5350,7 @@
                   <a:srgbClr val="FAFAFA"/>
                 </a:solidFill>
               </a:rPr>
-              <a:t>znaki neuroprzekaźników</a:t>
+              <a:t>neurotransmitter signs</a:t>
             </a:r>
             <a:endParaRPr lang="en-US" sz="1400" dirty="0"/>
           </a:p>
@@ -5368,7 +5368,7 @@
                   <a:srgbClr val="FAFAFA"/>
                 </a:solidFill>
               </a:rPr>
-              <a:t>mapa FlyVis → BANC po typach komórek</a:t>
+              <a:t>FlyVis → BANC map by cell type</a:t>
             </a:r>
             <a:endParaRPr lang="en-US" sz="1400" dirty="0"/>
           </a:p>
@@ -5386,7 +5386,7 @@
                   <a:srgbClr val="FAFAFA"/>
                 </a:solidFill>
               </a:rPr>
-              <a:t>liniowy dekoder i podział osi</a:t>
+              <a:t>linear decoder and axis split</a:t>
             </a:r>
             <a:endParaRPr lang="en-US" sz="1400" dirty="0"/>
           </a:p>
@@ -5404,7 +5404,7 @@
                   <a:srgbClr val="FAFAFA"/>
                 </a:solidFill>
               </a:rPr>
-              <a:t>czujniki drona dla thrust/roll/pitch</a:t>
+              <a:t>drone sensors for thrust/roll/pitch</a:t>
             </a:r>
             <a:endParaRPr lang="en-US" sz="1400" dirty="0"/>
           </a:p>
@@ -5560,7 +5560,7 @@
                   <a:srgbClr val="FAFAFA"/>
                 </a:solidFill>
               </a:rPr>
-              <a:t>Dziękujemy</a:t>
+              <a:t>Thank you</a:t>
             </a:r>
             <a:endParaRPr lang="en-US" sz="4400" dirty="0"/>
           </a:p>
@@ -5596,7 +5596,7 @@
                   <a:srgbClr val="A1A1AA"/>
                 </a:solidFill>
               </a:rPr>
-              <a:t>Demo: lot z panelem BANC na żywo</a:t>
+              <a:t>Live demo: BANC panel in flight</a:t>
             </a:r>
             <a:endParaRPr lang="en-US" sz="1600" dirty="0"/>
           </a:p>
@@ -5610,7 +5610,7 @@
                   <a:srgbClr val="A1A1AA"/>
                 </a:solidFill>
               </a:rPr>
-              <a:t>i eksplorator 3D connectomu</a:t>
+              <a:t>3D connectome explorer</a:t>
             </a:r>
             <a:endParaRPr lang="en-US" sz="1600" dirty="0"/>
           </a:p>
@@ -5711,7 +5711,7 @@
                   <a:srgbClr val="FAFAFA"/>
                 </a:solidFill>
               </a:rPr>
-              <a:t>Zamknięta pętla: wzrok → connectome → lot</a:t>
+              <a:t>Closed loop: vision → connectome → flight</a:t>
             </a:r>
             <a:endParaRPr lang="en-US" sz="2800" dirty="0"/>
           </a:p>
@@ -5806,7 +5806,7 @@
                   <a:srgbClr val="FAFAFA"/>
                 </a:solidFill>
               </a:rPr>
-              <a:t>Obraz</a:t>
+              <a:t>Image</a:t>
             </a:r>
             <a:endParaRPr lang="en-US" sz="1500" dirty="0"/>
           </a:p>
@@ -5842,7 +5842,7 @@
                   <a:srgbClr val="A1A1AA"/>
                 </a:solidFill>
               </a:rPr>
-              <a:t>dwie kamery-oczy drona</a:t>
+              <a:t>two eye cameras on the drone</a:t>
             </a:r>
             <a:endParaRPr lang="en-US" sz="1100" dirty="0"/>
           </a:p>
@@ -5973,7 +5973,7 @@
                   <a:srgbClr val="A1A1AA"/>
                 </a:solidFill>
               </a:rPr>
-              <a:t>BANC v888 na GPU</a:t>
+              <a:t>BANC v888 on the GPU</a:t>
             </a:r>
             <a:endParaRPr lang="en-US" sz="1100" dirty="0"/>
           </a:p>
@@ -6068,7 +6068,7 @@
                   <a:srgbClr val="FAFAFA"/>
                 </a:solidFill>
               </a:rPr>
-              <a:t>Sterowanie</a:t>
+              <a:t>Control</a:t>
             </a:r>
             <a:endParaRPr lang="en-US" sz="1500" dirty="0"/>
           </a:p>
@@ -6104,7 +6104,7 @@
                   <a:srgbClr val="A1A1AA"/>
                 </a:solidFill>
               </a:rPr>
-              <a:t>neurony lotu → komendy</a:t>
+              <a:t>flight neurons → commands</a:t>
             </a:r>
             <a:endParaRPr lang="en-US" sz="1100" dirty="0"/>
           </a:p>
@@ -6199,7 +6199,7 @@
                   <a:srgbClr val="FAFAFA"/>
                 </a:solidFill>
               </a:rPr>
-              <a:t>Ruch</a:t>
+              <a:t>Motion</a:t>
             </a:r>
             <a:endParaRPr lang="en-US" sz="1500" dirty="0"/>
           </a:p>
@@ -6235,7 +6235,7 @@
                   <a:srgbClr val="A1A1AA"/>
                 </a:solidFill>
               </a:rPr>
-              <a:t>dron w MuJoCo → nowy obraz</a:t>
+              <a:t>drone in MuJoCo → new image</a:t>
             </a:r>
             <a:endParaRPr lang="en-US" sz="1100" dirty="0"/>
           </a:p>
@@ -6369,7 +6369,7 @@
                   <a:srgbClr val="FAFAFA"/>
                 </a:solidFill>
               </a:rPr>
-              <a:t>Pipeline: od piksela do śmigła</a:t>
+              <a:t>Pipeline: from pixel to propeller</a:t>
             </a:r>
             <a:endParaRPr lang="en-US" sz="2800" dirty="0"/>
           </a:p>
@@ -6464,7 +6464,7 @@
                   <a:srgbClr val="FAFAFA"/>
                 </a:solidFill>
               </a:rPr>
-              <a:t>Kamera</a:t>
+              <a:t>Camera</a:t>
             </a:r>
             <a:endParaRPr lang="en-US" sz="1500" dirty="0"/>
           </a:p>
@@ -6500,7 +6500,7 @@
                   <a:srgbClr val="A1A1AA"/>
                 </a:solidFill>
               </a:rPr>
-              <a:t>2 oczy MuJoCo, 157°, ±70°</a:t>
+              <a:t>2 MuJoCo eyes, 157°, ±70°</a:t>
             </a:r>
             <a:endParaRPr lang="en-US" sz="1100" dirty="0"/>
           </a:p>
@@ -6619,7 +6619,7 @@
                   <a:srgbClr val="FAFAFA"/>
                 </a:solidFill>
               </a:rPr>
-              <a:t>Siatkówka</a:t>
+              <a:t>Retina</a:t>
             </a:r>
             <a:endParaRPr lang="en-US" sz="1500" dirty="0"/>
           </a:p>
@@ -6655,7 +6655,7 @@
                   <a:srgbClr val="A1A1AA"/>
                 </a:solidFill>
               </a:rPr>
-              <a:t>FlyGym: 721 ommatidiów / oko</a:t>
+              <a:t>FlyGym: 721 ommatidia / eye</a:t>
             </a:r>
             <a:endParaRPr lang="en-US" sz="1100" dirty="0"/>
           </a:p>
@@ -6810,7 +6810,7 @@
                   <a:srgbClr val="A1A1AA"/>
                 </a:solidFill>
               </a:rPr>
-              <a:t>model płata wzrokowego</a:t>
+              <a:t>optic lobe model</a:t>
             </a:r>
             <a:endParaRPr lang="en-US" sz="1100" dirty="0"/>
           </a:p>
@@ -6929,7 +6929,7 @@
                   <a:srgbClr val="FAFAFA"/>
                 </a:solidFill>
               </a:rPr>
-              <a:t>Mapa → BANC</a:t>
+              <a:t>Map → BANC</a:t>
             </a:r>
             <a:endParaRPr lang="en-US" sz="1500" dirty="0"/>
           </a:p>
@@ -6965,7 +6965,7 @@
                   <a:srgbClr val="A1A1AA"/>
                 </a:solidFill>
               </a:rPr>
-              <a:t>22 462 neuronów v888</a:t>
+              <a:t>22,462 v888 neurons</a:t>
             </a:r>
             <a:endParaRPr lang="en-US" sz="1100" dirty="0"/>
           </a:p>
@@ -7096,7 +7096,7 @@
                   <a:srgbClr val="A1A1AA"/>
                 </a:solidFill>
               </a:rPr>
-              <a:t>175 401 neuronów, GPU</a:t>
+              <a:t>175,401 neurons, GPU</a:t>
             </a:r>
             <a:endParaRPr lang="en-US" sz="1100" dirty="0"/>
           </a:p>
@@ -7215,7 +7215,7 @@
                   <a:srgbClr val="FAFAFA"/>
                 </a:solidFill>
               </a:rPr>
-              <a:t>Odczyt</a:t>
+              <a:t>Readout</a:t>
             </a:r>
             <a:endParaRPr lang="en-US" sz="1500" dirty="0"/>
           </a:p>
@@ -7251,7 +7251,7 @@
                   <a:srgbClr val="A1A1AA"/>
                 </a:solidFill>
               </a:rPr>
-              <a:t>6 grup MN + 375 DN lotu</a:t>
+              <a:t>6 MN groups + 375 flight DNs</a:t>
             </a:r>
             <a:endParaRPr lang="en-US" sz="1100" dirty="0"/>
           </a:p>
@@ -7370,7 +7370,7 @@
                   <a:srgbClr val="FAFAFA"/>
                 </a:solidFill>
               </a:rPr>
-              <a:t>Dekoder</a:t>
+              <a:t>Decoder</a:t>
             </a:r>
             <a:endParaRPr lang="en-US" sz="1500" dirty="0"/>
           </a:p>
@@ -7406,7 +7406,7 @@
                   <a:srgbClr val="A1A1AA"/>
                 </a:solidFill>
               </a:rPr>
-              <a:t>liniowy, uczony (DAgger)</a:t>
+              <a:t>linear, trained (DAgger)</a:t>
             </a:r>
             <a:endParaRPr lang="en-US" sz="1100" dirty="0"/>
           </a:p>
@@ -7525,7 +7525,7 @@
                   <a:srgbClr val="FAFAFA"/>
                 </a:solidFill>
               </a:rPr>
-              <a:t>Dron</a:t>
+              <a:t>Drone</a:t>
             </a:r>
             <a:endParaRPr lang="en-US" sz="1500" dirty="0"/>
           </a:p>
@@ -7621,7 +7621,7 @@
                   <a:srgbClr val="52525B"/>
                 </a:solidFill>
               </a:rPr>
-              <a:t>następna klatka: nowy obraz z kamer</a:t>
+              <a:t>next frame: new camera image</a:t>
             </a:r>
             <a:endParaRPr lang="en-US" sz="1100" dirty="0"/>
           </a:p>
@@ -7731,7 +7731,7 @@
                   <a:srgbClr val="FAFAFA"/>
                 </a:solidFill>
               </a:rPr>
-              <a:t>Zanim sygnał trafi do BANC: oko muszki</a:t>
+              <a:t>Before the signal reaches BANC: the fly eye</a:t>
             </a:r>
             <a:endParaRPr lang="en-US" sz="2800" dirty="0"/>
           </a:p>
@@ -7798,7 +7798,7 @@
                   <a:srgbClr val="A1A1AA"/>
                 </a:solidFill>
               </a:rPr>
-              <a:t>Kamera lewa</a:t>
+              <a:t>Left camera</a:t>
             </a:r>
             <a:endParaRPr lang="en-US" sz="1100" dirty="0"/>
           </a:p>
@@ -7865,7 +7865,7 @@
                   <a:srgbClr val="A1A1AA"/>
                 </a:solidFill>
               </a:rPr>
-              <a:t>Siatkówka lewa</a:t>
+              <a:t>Left retina</a:t>
             </a:r>
             <a:endParaRPr lang="en-US" sz="1100" dirty="0"/>
           </a:p>
@@ -7932,7 +7932,7 @@
                   <a:srgbClr val="A1A1AA"/>
                 </a:solidFill>
               </a:rPr>
-              <a:t>Kamera prawa</a:t>
+              <a:t>Right camera</a:t>
             </a:r>
             <a:endParaRPr lang="en-US" sz="1100" dirty="0"/>
           </a:p>
@@ -7999,7 +7999,7 @@
                   <a:srgbClr val="A1A1AA"/>
                 </a:solidFill>
               </a:rPr>
-              <a:t>Siatkówka prawa</a:t>
+              <a:t>Right retina</a:t>
             </a:r>
             <a:endParaRPr lang="en-US" sz="1100" dirty="0"/>
           </a:p>
@@ -8035,7 +8035,7 @@
                   <a:srgbClr val="FAFAFA"/>
                 </a:solidFill>
               </a:rPr>
-              <a:t>Kamery MuJoCo z polem widzenia oka muchy → korekcja rybiego oka → 721 heksagonalnych ommatidiów na oko (FlyGym) → FlyVis: wytrenowany model płata wzrokowego oparty na connectomie → aktywność typów komórek mapowana na neurony BANC v888.</a:t>
+              <a:t>MuJoCo cameras with a fly-eye field of view → fisheye correction → 721 hexagonal ommatidia per eye (FlyGym) → FlyVis: a trained, connectome-constrained optic lobe model → cell-type activity mapped onto BANC v888 neurons.</a:t>
             </a:r>
             <a:endParaRPr lang="en-US" sz="1300" dirty="0"/>
           </a:p>
@@ -8145,7 +8145,7 @@
                   <a:srgbClr val="FAFAFA"/>
                 </a:solidFill>
               </a:rPr>
-              <a:t>BANC v888: mózg i brzuszny łańcuch nerwowy</a:t>
+              <a:t>BANC v888: brain and ventral nerve cord</a:t>
             </a:r>
             <a:endParaRPr lang="en-US" sz="2800" dirty="0"/>
           </a:p>
@@ -8205,7 +8205,7 @@
                   <a:srgbClr val="FAFAFA"/>
                 </a:solidFill>
               </a:rPr>
-              <a:t>175 401</a:t>
+              <a:t>175,401</a:t>
             </a:r>
             <a:endParaRPr lang="en-US" sz="3600" dirty="0"/>
           </a:p>
@@ -8241,7 +8241,7 @@
                   <a:srgbClr val="A1A1AA"/>
                 </a:solidFill>
               </a:rPr>
-              <a:t>neuronów (bez glejów i tchawek)</a:t>
+              <a:t>neurons (glia and trachea excluded)</a:t>
             </a:r>
             <a:endParaRPr lang="en-US" sz="1200" dirty="0"/>
           </a:p>
@@ -8277,7 +8277,7 @@
                   <a:srgbClr val="FAFAFA"/>
                 </a:solidFill>
               </a:rPr>
-              <a:t>18,6 mln</a:t>
+              <a:t>18.6 M</a:t>
             </a:r>
             <a:endParaRPr lang="en-US" sz="3600" dirty="0"/>
           </a:p>
@@ -8313,7 +8313,7 @@
                   <a:srgbClr val="A1A1AA"/>
                 </a:solidFill>
               </a:rPr>
-              <a:t>synaps w połączeniach ≥ 5</a:t>
+              <a:t>synapses in connections ≥ 5</a:t>
             </a:r>
             <a:endParaRPr lang="en-US" sz="1200" dirty="0"/>
           </a:p>
@@ -8349,7 +8349,7 @@
                   <a:srgbClr val="FAFAFA"/>
                 </a:solidFill>
               </a:rPr>
-              <a:t>1,53 mln</a:t>
+              <a:t>1.53 M</a:t>
             </a:r>
             <a:endParaRPr lang="en-US" sz="3600" dirty="0"/>
           </a:p>
@@ -8385,7 +8385,7 @@
                   <a:srgbClr val="A1A1AA"/>
                 </a:solidFill>
               </a:rPr>
-              <a:t>połączeń w grafie modelu</a:t>
+              <a:t>connections in the model graph</a:t>
             </a:r>
             <a:endParaRPr lang="en-US" sz="1200" dirty="0"/>
           </a:p>
@@ -8457,7 +8457,7 @@
                   <a:srgbClr val="A1A1AA"/>
                 </a:solidFill>
               </a:rPr>
-              <a:t>szkielety neuronów lotu (SWC)</a:t>
+              <a:t>flight-neuron skeletons (SWC)</a:t>
             </a:r>
             <a:endParaRPr lang="en-US" sz="1200" dirty="0"/>
           </a:p>
@@ -8518,7 +8518,7 @@
                   <a:srgbClr val="A1A1AA"/>
                 </a:solidFill>
               </a:rPr>
-              <a:t>płaty wzrokowe · 105 646</a:t>
+              <a:t>optic lobes · 105,646</a:t>
             </a:r>
             <a:endParaRPr lang="en-US" sz="1100" dirty="0"/>
           </a:p>
@@ -8579,7 +8579,7 @@
                   <a:srgbClr val="A1A1AA"/>
                 </a:solidFill>
               </a:rPr>
-              <a:t>mózg centralny · 42 620</a:t>
+              <a:t>central brain · 42,620</a:t>
             </a:r>
             <a:endParaRPr lang="en-US" sz="1100" dirty="0"/>
           </a:p>
@@ -8640,7 +8640,7 @@
                   <a:srgbClr val="A1A1AA"/>
                 </a:solidFill>
               </a:rPr>
-              <a:t>VNC · 26 769</a:t>
+              <a:t>VNC · 26,769</a:t>
             </a:r>
             <a:endParaRPr lang="en-US" sz="1100" dirty="0"/>
           </a:p>
@@ -8701,7 +8701,7 @@
                   <a:srgbClr val="A1A1AA"/>
                 </a:solidFill>
               </a:rPr>
-              <a:t>DN / AN · 3 165</a:t>
+              <a:t>DN / AN · 3,165</a:t>
             </a:r>
             <a:endParaRPr lang="en-US" sz="1100" dirty="0"/>
           </a:p>
@@ -8811,7 +8811,7 @@
                   <a:srgbClr val="FAFAFA"/>
                 </a:solidFill>
               </a:rPr>
-              <a:t>Jak liczymy aktywność na connectomie</a:t>
+              <a:t>How we compute activity on the connectome</a:t>
             </a:r>
             <a:endParaRPr lang="en-US" sz="2800" dirty="0"/>
           </a:p>
@@ -8956,7 +8956,7 @@
                   <a:srgbClr val="FAFAFA"/>
                 </a:solidFill>
               </a:rPr>
-              <a:t>liczby synaps z BANC, znak z przewidywanego neuroprzekaźnika, normalizacja wejść każdego neuronu</a:t>
+              <a:t>synapse counts from BANC, sign from the predicted neurotransmitter, inputs normalized per neuron</a:t>
             </a:r>
             <a:endParaRPr lang="en-US" sz="1200" dirty="0"/>
           </a:p>
@@ -9028,7 +9028,7 @@
                   <a:srgbClr val="FAFAFA"/>
                 </a:solidFill>
               </a:rPr>
-              <a:t>20 ms, 5 ms, 0,9 — 4 podkroki na klatkę obrazu</a:t>
+              <a:t>20 ms, 5 ms, 0.9 — 4 substeps per camera frame</a:t>
             </a:r>
             <a:endParaRPr lang="en-US" sz="1200" dirty="0"/>
           </a:p>
@@ -9100,7 +9100,7 @@
                   <a:srgbClr val="FAFAFA"/>
                 </a:solidFill>
               </a:rPr>
-              <a:t>wejście: wzrok (FlyVis → BANC) + żyroskop drona na aferenty halter</a:t>
+              <a:t>input: vision (FlyVis → BANC) + drone gyroscope onto haltere afferents</a:t>
             </a:r>
             <a:endParaRPr lang="en-US" sz="1200" dirty="0"/>
           </a:p>
@@ -9172,7 +9172,7 @@
                   <a:srgbClr val="FAFAFA"/>
                 </a:solidFill>
               </a:rPr>
-              <a:t>macierz rzadka CSR w torch: ~2,6 ms na klatkę (RTX 4060)</a:t>
+              <a:t>sparse CSR matrix in torch: ~2.6 ms per frame (RTX 4060)</a:t>
             </a:r>
             <a:endParaRPr lang="en-US" sz="1200" dirty="0"/>
           </a:p>
@@ -9242,7 +9242,7 @@
                   <a:srgbClr val="FAFAFA"/>
                 </a:solidFill>
               </a:rPr>
-              <a:t>Znaki synaps</a:t>
+              <a:t>Synapse signs</a:t>
             </a:r>
             <a:endParaRPr lang="en-US" sz="1500" dirty="0"/>
           </a:p>
@@ -9303,7 +9303,7 @@
                   <a:srgbClr val="A1A1AA"/>
                 </a:solidFill>
               </a:rPr>
-              <a:t>ACh — pobudzenie</a:t>
+              <a:t>ACh — excitatory</a:t>
             </a:r>
             <a:endParaRPr lang="en-US" sz="1100" dirty="0"/>
           </a:p>
@@ -9364,7 +9364,7 @@
                   <a:srgbClr val="A1A1AA"/>
                 </a:solidFill>
               </a:rPr>
-              <a:t>GABA — hamowanie</a:t>
+              <a:t>GABA — inhibitory</a:t>
             </a:r>
             <a:endParaRPr lang="en-US" sz="1100" dirty="0"/>
           </a:p>
@@ -9425,7 +9425,7 @@
                   <a:srgbClr val="A1A1AA"/>
                 </a:solidFill>
               </a:rPr>
-              <a:t>glutaminian — hamowanie</a:t>
+              <a:t>glutamate — inhibitory</a:t>
             </a:r>
             <a:endParaRPr lang="en-US" sz="1100" dirty="0"/>
           </a:p>
@@ -9486,7 +9486,7 @@
                   <a:srgbClr val="A1A1AA"/>
                 </a:solidFill>
               </a:rPr>
-              <a:t>histamina — hamowanie</a:t>
+              <a:t>histamine — inhibitory</a:t>
             </a:r>
             <a:endParaRPr lang="en-US" sz="1100" dirty="0"/>
           </a:p>
@@ -9522,7 +9522,7 @@
                   <a:srgbClr val="A1A1AA"/>
                 </a:solidFill>
               </a:rPr>
-              <a:t>Model dynamiki i znaki to nasze założenia; połączenia i liczby synaps są z BANC.</a:t>
+              <a:t>The dynamics model and signs are our assumptions; connections and synapse counts come from BANC.</a:t>
             </a:r>
             <a:endParaRPr lang="en-US" sz="1100" dirty="0"/>
           </a:p>
@@ -9632,7 +9632,7 @@
                   <a:srgbClr val="FAFAFA"/>
                 </a:solidFill>
               </a:rPr>
-              <a:t>Obwód lotu: tylko oficjalne adnotacje BANC</a:t>
+              <a:t>Flight circuit: official BANC annotations only</a:t>
             </a:r>
             <a:endParaRPr lang="en-US" sz="2800" dirty="0"/>
           </a:p>
@@ -10019,7 +10019,7 @@
                   <a:srgbClr val="A1A1AA"/>
                 </a:solidFill>
               </a:rPr>
-              <a:t>DLM / DVM — mięśnie mocy</a:t>
+              <a:t>DLM / DVM — power muscles</a:t>
             </a:r>
             <a:endParaRPr lang="en-US" sz="1100" dirty="0"/>
           </a:p>
@@ -10152,7 +10152,7 @@
                   <a:srgbClr val="A1A1AA"/>
                 </a:solidFill>
               </a:rPr>
-              <a:t>b1, i1, iii3… — mięśnie sterujące</a:t>
+              <a:t>b1, i1, iii3… — steering muscles</a:t>
             </a:r>
             <a:endParaRPr lang="en-US" sz="1100" dirty="0"/>
           </a:p>
@@ -10285,7 +10285,7 @@
                   <a:srgbClr val="A1A1AA"/>
                 </a:solidFill>
               </a:rPr>
-              <a:t>napięcie skrzydła</a:t>
+              <a:t>wing tension</a:t>
             </a:r>
             <a:endParaRPr lang="en-US" sz="1100" dirty="0"/>
           </a:p>
@@ -10382,7 +10382,7 @@
                   <a:srgbClr val="FAFAFA"/>
                 </a:solidFill>
               </a:rPr>
-              <a:t>Aferenty halter</a:t>
+              <a:t>Haltere afferents</a:t>
             </a:r>
             <a:endParaRPr lang="en-US" sz="1400" dirty="0"/>
           </a:p>
@@ -10418,7 +10418,7 @@
                   <a:srgbClr val="A1A1AA"/>
                 </a:solidFill>
               </a:rPr>
-              <a:t>czujniki obrotu → żyroskop drona</a:t>
+              <a:t>rotation sensors ← drone gyroscope</a:t>
             </a:r>
             <a:endParaRPr lang="en-US" sz="1100" dirty="0"/>
           </a:p>
@@ -10564,7 +10564,7 @@
                   <a:srgbClr val="FAFAFA"/>
                 </a:solidFill>
               </a:rPr>
-              <a:t>Strona celu jest w pojedynczych DN, nie w średnich</a:t>
+              <a:t>Target side lives in single DNs, not in averages</a:t>
             </a:r>
             <a:endParaRPr lang="en-US" sz="2800" dirty="0"/>
           </a:p>
@@ -10652,7 +10652,7 @@
                   <a:srgbClr val="A1A1AA"/>
                 </a:solidFill>
               </a:rPr>
-              <a:t>trafność strony celu z 375 pojedynczych DN lotu (walidacja: nieznana odległość)</a:t>
+              <a:t>target-side accuracy from 375 single flight DNs (validated on an unseen distance)</a:t>
             </a:r>
             <a:endParaRPr lang="en-US" sz="1200" dirty="0"/>
           </a:p>
@@ -10724,7 +10724,7 @@
                   <a:srgbClr val="A1A1AA"/>
                 </a:solidFill>
               </a:rPr>
-              <a:t>z 6 średnich grup MN — uśrednianie kasuje różnicę lewo / prawo</a:t>
+              <a:t>from 6 MN group averages — averaging cancels the left / right difference</a:t>
             </a:r>
             <a:endParaRPr lang="en-US" sz="1200" dirty="0"/>
           </a:p>
@@ -10834,7 +10834,7 @@
                   <a:srgbClr val="FAFAFA"/>
                 </a:solidFill>
               </a:rPr>
-              <a:t>Ograniczenie v888: asymetria płatów wzrokowych</a:t>
+              <a:t>v888 limitation: optic lobe asymmetry</a:t>
             </a:r>
             <a:endParaRPr lang="en-US" sz="2800" dirty="0"/>
           </a:p>
@@ -10974,7 +10974,7 @@
                   <a:srgbClr val="A1A1AA"/>
                 </a:solidFill>
               </a:rPr>
-              <a:t>neuronów lewego płata ma typ komórki</a:t>
+              <a:t>of left-lobe neurons have a cell type</a:t>
             </a:r>
             <a:endParaRPr lang="en-US" sz="1200" dirty="0"/>
           </a:p>
@@ -11010,7 +11010,7 @@
                   <a:srgbClr val="A1A1AA"/>
                 </a:solidFill>
               </a:rPr>
-              <a:t>5 535</a:t>
+              <a:t>5,535</a:t>
             </a:r>
             <a:endParaRPr lang="en-US" sz="3600" dirty="0"/>
           </a:p>
@@ -11046,7 +11046,7 @@
                   <a:srgbClr val="A1A1AA"/>
                 </a:solidFill>
               </a:rPr>
-              <a:t>neuronów zasila lewe oko</a:t>
+              <a:t>neurons driven by the left eye</a:t>
             </a:r>
             <a:endParaRPr lang="en-US" sz="1200" dirty="0"/>
           </a:p>
@@ -11118,7 +11118,7 @@
                   <a:srgbClr val="A1A1AA"/>
                 </a:solidFill>
               </a:rPr>
-              <a:t>neuronów prawego płata ma typ komórki</a:t>
+              <a:t>of right-lobe neurons have a cell type</a:t>
             </a:r>
             <a:endParaRPr lang="en-US" sz="1200" dirty="0"/>
           </a:p>
@@ -11154,7 +11154,7 @@
                   <a:srgbClr val="2FD3C4"/>
                 </a:solidFill>
               </a:rPr>
-              <a:t>16 927</a:t>
+              <a:t>16,927</a:t>
             </a:r>
             <a:endParaRPr lang="en-US" sz="3600" dirty="0"/>
           </a:p>
@@ -11190,7 +11190,7 @@
                   <a:srgbClr val="A1A1AA"/>
                 </a:solidFill>
               </a:rPr>
-              <a:t>neuronów zasila prawe oko</a:t>
+              <a:t>neurons driven by the right eye</a:t>
             </a:r>
             <a:endParaRPr lang="en-US" sz="1200" dirty="0"/>
           </a:p>
@@ -11226,7 +11226,7 @@
                   <a:srgbClr val="A1A1AA"/>
                 </a:solidFill>
               </a:rPr>
-              <a:t>Mapa FlyVis → BANC idzie po typach komórek, więc lewe oko dociera do ~3× mniej neuronów. Wyrównanie wejścia nie zmieniło wyniku; odczyt z pojedynczych DN i tak rozpoznaje obie strony.</a:t>
+              <a:t>The FlyVis → BANC map goes by cell type, so the left eye reaches ~3× fewer neurons. Equalizing the input did not change the result; the single-DN readout still recognizes both sides.</a:t>
             </a:r>
             <a:endParaRPr lang="en-US" sz="1200" dirty="0"/>
           </a:p>

</xml_diff>

<commit_message>
Prezentacja: podtytuł „The brain of a fruit fly pilots a drone”
Co-Authored-By: Claude Opus 5.5 <noreply@anthropic.com>
</commit_message>
<xml_diff>
--- a/docs/prezentacja/NeuroFly.pptx
+++ b/docs/prezentacja/NeuroFly.pptx
@@ -163,19 +163,19 @@
   <p:extLst>
     <p:ext uri="{521415D9-36F7-43E2-AB2F-B90AF26B5E84}">
       <p14:sectionLst xmlns:p14="http://schemas.microsoft.com/office/powerpoint/2010/main">
-        <p14:section name="Start" id="{C0440BE3-E535-3DF4-2AD0-EE308B188D64}">
+        <p14:section name="Start" id="{6D6991E0-145E-641C-103B-69C1B7CCA710}">
           <p14:sldIdLst>
             <p14:sldId id="256"/>
           </p14:sldIdLst>
         </p14:section>
-        <p14:section name="Idea" id="{E110B5A7-75AF-7634-68DB-C3ABA9EE012F}">
+        <p14:section name="Idea" id="{A4E24FA3-18F4-E8C8-D2EC-B11A329B7590}">
           <p14:sldIdLst>
             <p14:sldId id="257"/>
             <p14:sldId id="258"/>
             <p14:sldId id="259"/>
           </p14:sldIdLst>
         </p14:section>
-        <p14:section name="How it works" id="{4354F4E0-2296-9C49-8CF1-DCC53BF61ABC}">
+        <p14:section name="How it works" id="{15BD6867-4668-DF97-8250-185DE2B8827C}">
           <p14:sldIdLst>
             <p14:sldId id="260"/>
             <p14:sldId id="261"/>
@@ -186,20 +186,20 @@
             <p14:sldId id="266"/>
           </p14:sldIdLst>
         </p14:section>
-        <p14:section name="Results" id="{F60A02A5-5D7A-799A-8F4F-2547638EDAED}">
+        <p14:section name="Results" id="{0AB5329D-D9B6-F548-74F6-6D5C9159752F}">
           <p14:sldIdLst>
             <p14:sldId id="267"/>
             <p14:sldId id="268"/>
             <p14:sldId id="269"/>
           </p14:sldIdLst>
         </p14:section>
-        <p14:section name="Honesty" id="{2C9CA8DF-A7A7-FB8B-D1BA-C10654FE7031}">
+        <p14:section name="Honesty" id="{5DDE117D-EAD2-0903-C8BE-DDE65AD3A3C2}">
           <p14:sldIdLst>
             <p14:sldId id="270"/>
             <p14:sldId id="271"/>
           </p14:sldIdLst>
         </p14:section>
-        <p14:section name="Next" id="{4DAC8B4F-8835-10EE-3E9F-C544FB4A3B0A}">
+        <p14:section name="Next" id="{88DDCDBF-5801-2ACC-E04B-9306572FC45F}">
           <p14:sldIdLst>
             <p14:sldId id="272"/>
             <p14:sldId id="273"/>
@@ -208,7 +208,7 @@
             <p14:sldId id="276"/>
           </p14:sldIdLst>
         </p14:section>
-        <p14:section name="Appendix" id="{C67507B2-5A32-5426-A0BF-12061B4C7F05}">
+        <p14:section name="Appendix" id="{FA02D410-4F8C-49A7-31E9-55AC0410D309}">
           <p14:sldIdLst>
             <p14:sldId id="277"/>
             <p14:sldId id="278"/>
@@ -269,7 +269,7 @@
             <c:bubble3D val="0"/>
             <c:extLst>
               <c:ext xmlns:c16="http://schemas.microsoft.com/office/drawing/2014/chart" uri="{C3380CC4-5D6E-409C-BE32-E72D297353CC}">
-                <c16:uniqueId val="{00000001-6A71-40A9-879E-C288852D79EF}"/>
+                <c16:uniqueId val="{00000001-A838-44ED-8C72-17B99A65C751}"/>
               </c:ext>
             </c:extLst>
           </c:dPt>
@@ -279,7 +279,7 @@
             <c:bubble3D val="0"/>
             <c:extLst>
               <c:ext xmlns:c16="http://schemas.microsoft.com/office/drawing/2014/chart" uri="{C3380CC4-5D6E-409C-BE32-E72D297353CC}">
-                <c16:uniqueId val="{00000003-6A71-40A9-879E-C288852D79EF}"/>
+                <c16:uniqueId val="{00000003-A838-44ED-8C72-17B99A65C751}"/>
               </c:ext>
             </c:extLst>
           </c:dPt>
@@ -289,7 +289,7 @@
             <c:bubble3D val="0"/>
             <c:extLst>
               <c:ext xmlns:c16="http://schemas.microsoft.com/office/drawing/2014/chart" uri="{C3380CC4-5D6E-409C-BE32-E72D297353CC}">
-                <c16:uniqueId val="{00000005-6A71-40A9-879E-C288852D79EF}"/>
+                <c16:uniqueId val="{00000005-A838-44ED-8C72-17B99A65C751}"/>
               </c:ext>
             </c:extLst>
           </c:dPt>
@@ -305,7 +305,7 @@
             </c:spPr>
             <c:extLst>
               <c:ext xmlns:c16="http://schemas.microsoft.com/office/drawing/2014/chart" uri="{C3380CC4-5D6E-409C-BE32-E72D297353CC}">
-                <c16:uniqueId val="{00000007-6A71-40A9-879E-C288852D79EF}"/>
+                <c16:uniqueId val="{00000007-A838-44ED-8C72-17B99A65C751}"/>
               </c:ext>
             </c:extLst>
           </c:dPt>
@@ -389,7 +389,7 @@
           </c:val>
           <c:extLst>
             <c:ext xmlns:c16="http://schemas.microsoft.com/office/drawing/2014/chart" uri="{C3380CC4-5D6E-409C-BE32-E72D297353CC}">
-              <c16:uniqueId val="{00000008-6A71-40A9-879E-C288852D79EF}"/>
+              <c16:uniqueId val="{00000008-A838-44ED-8C72-17B99A65C751}"/>
             </c:ext>
           </c:extLst>
         </c:ser>
@@ -602,7 +602,7 @@
           </c:val>
           <c:extLst>
             <c:ext xmlns:c16="http://schemas.microsoft.com/office/drawing/2014/chart" uri="{C3380CC4-5D6E-409C-BE32-E72D297353CC}">
-              <c16:uniqueId val="{00000000-74F8-4EFE-BA24-5DFCC8011B0F}"/>
+              <c16:uniqueId val="{00000000-336B-4455-9677-BE4DEC425EF6}"/>
             </c:ext>
           </c:extLst>
         </c:ser>
@@ -707,7 +707,7 @@
           </c:val>
           <c:extLst>
             <c:ext xmlns:c16="http://schemas.microsoft.com/office/drawing/2014/chart" uri="{C3380CC4-5D6E-409C-BE32-E72D297353CC}">
-              <c16:uniqueId val="{00000001-74F8-4EFE-BA24-5DFCC8011B0F}"/>
+              <c16:uniqueId val="{00000001-336B-4455-9677-BE4DEC425EF6}"/>
             </c:ext>
           </c:extLst>
         </c:ser>
@@ -864,7 +864,7 @@
             <c:bubble3D val="0"/>
             <c:extLst>
               <c:ext xmlns:c16="http://schemas.microsoft.com/office/drawing/2014/chart" uri="{C3380CC4-5D6E-409C-BE32-E72D297353CC}">
-                <c16:uniqueId val="{00000001-B38F-4EA9-B0FD-33CD8D6984C5}"/>
+                <c16:uniqueId val="{00000001-E962-4DEE-AA28-1746774CD2D4}"/>
               </c:ext>
             </c:extLst>
           </c:dPt>
@@ -874,7 +874,7 @@
             <c:bubble3D val="0"/>
             <c:extLst>
               <c:ext xmlns:c16="http://schemas.microsoft.com/office/drawing/2014/chart" uri="{C3380CC4-5D6E-409C-BE32-E72D297353CC}">
-                <c16:uniqueId val="{00000003-B38F-4EA9-B0FD-33CD8D6984C5}"/>
+                <c16:uniqueId val="{00000003-E962-4DEE-AA28-1746774CD2D4}"/>
               </c:ext>
             </c:extLst>
           </c:dPt>
@@ -890,7 +890,7 @@
             </c:spPr>
             <c:extLst>
               <c:ext xmlns:c16="http://schemas.microsoft.com/office/drawing/2014/chart" uri="{C3380CC4-5D6E-409C-BE32-E72D297353CC}">
-                <c16:uniqueId val="{00000005-B38F-4EA9-B0FD-33CD8D6984C5}"/>
+                <c16:uniqueId val="{00000005-E962-4DEE-AA28-1746774CD2D4}"/>
               </c:ext>
             </c:extLst>
           </c:dPt>
@@ -900,7 +900,7 @@
             <c:bubble3D val="0"/>
             <c:extLst>
               <c:ext xmlns:c16="http://schemas.microsoft.com/office/drawing/2014/chart" uri="{C3380CC4-5D6E-409C-BE32-E72D297353CC}">
-                <c16:uniqueId val="{00000007-B38F-4EA9-B0FD-33CD8D6984C5}"/>
+                <c16:uniqueId val="{00000007-E962-4DEE-AA28-1746774CD2D4}"/>
               </c:ext>
             </c:extLst>
           </c:dPt>
@@ -910,7 +910,7 @@
             <c:bubble3D val="0"/>
             <c:extLst>
               <c:ext xmlns:c16="http://schemas.microsoft.com/office/drawing/2014/chart" uri="{C3380CC4-5D6E-409C-BE32-E72D297353CC}">
-                <c16:uniqueId val="{00000009-B38F-4EA9-B0FD-33CD8D6984C5}"/>
+                <c16:uniqueId val="{00000009-E962-4DEE-AA28-1746774CD2D4}"/>
               </c:ext>
             </c:extLst>
           </c:dPt>
@@ -920,7 +920,7 @@
             <c:bubble3D val="0"/>
             <c:extLst>
               <c:ext xmlns:c16="http://schemas.microsoft.com/office/drawing/2014/chart" uri="{C3380CC4-5D6E-409C-BE32-E72D297353CC}">
-                <c16:uniqueId val="{0000000B-B38F-4EA9-B0FD-33CD8D6984C5}"/>
+                <c16:uniqueId val="{0000000B-E962-4DEE-AA28-1746774CD2D4}"/>
               </c:ext>
             </c:extLst>
           </c:dPt>
@@ -930,7 +930,7 @@
             <c:bubble3D val="0"/>
             <c:extLst>
               <c:ext xmlns:c16="http://schemas.microsoft.com/office/drawing/2014/chart" uri="{C3380CC4-5D6E-409C-BE32-E72D297353CC}">
-                <c16:uniqueId val="{0000000D-B38F-4EA9-B0FD-33CD8D6984C5}"/>
+                <c16:uniqueId val="{0000000D-E962-4DEE-AA28-1746774CD2D4}"/>
               </c:ext>
             </c:extLst>
           </c:dPt>
@@ -1032,7 +1032,7 @@
           </c:val>
           <c:extLst>
             <c:ext xmlns:c16="http://schemas.microsoft.com/office/drawing/2014/chart" uri="{C3380CC4-5D6E-409C-BE32-E72D297353CC}">
-              <c16:uniqueId val="{0000000E-B38F-4EA9-B0FD-33CD8D6984C5}"/>
+              <c16:uniqueId val="{0000000E-E962-4DEE-AA28-1746774CD2D4}"/>
             </c:ext>
           </c:extLst>
         </c:ser>
@@ -1171,7 +1171,7 @@
             <c:bubble3D val="0"/>
             <c:extLst>
               <c:ext xmlns:c16="http://schemas.microsoft.com/office/drawing/2014/chart" uri="{C3380CC4-5D6E-409C-BE32-E72D297353CC}">
-                <c16:uniqueId val="{00000001-FE84-43F6-A9B0-CCCF5DF5BDB9}"/>
+                <c16:uniqueId val="{00000001-1DB8-4383-B3D3-17AC73097084}"/>
               </c:ext>
             </c:extLst>
           </c:dPt>
@@ -1181,7 +1181,7 @@
             <c:bubble3D val="0"/>
             <c:extLst>
               <c:ext xmlns:c16="http://schemas.microsoft.com/office/drawing/2014/chart" uri="{C3380CC4-5D6E-409C-BE32-E72D297353CC}">
-                <c16:uniqueId val="{00000003-FE84-43F6-A9B0-CCCF5DF5BDB9}"/>
+                <c16:uniqueId val="{00000003-1DB8-4383-B3D3-17AC73097084}"/>
               </c:ext>
             </c:extLst>
           </c:dPt>
@@ -1191,7 +1191,7 @@
             <c:bubble3D val="0"/>
             <c:extLst>
               <c:ext xmlns:c16="http://schemas.microsoft.com/office/drawing/2014/chart" uri="{C3380CC4-5D6E-409C-BE32-E72D297353CC}">
-                <c16:uniqueId val="{00000005-FE84-43F6-A9B0-CCCF5DF5BDB9}"/>
+                <c16:uniqueId val="{00000005-1DB8-4383-B3D3-17AC73097084}"/>
               </c:ext>
             </c:extLst>
           </c:dPt>
@@ -1207,7 +1207,7 @@
             </c:spPr>
             <c:extLst>
               <c:ext xmlns:c16="http://schemas.microsoft.com/office/drawing/2014/chart" uri="{C3380CC4-5D6E-409C-BE32-E72D297353CC}">
-                <c16:uniqueId val="{00000007-FE84-43F6-A9B0-CCCF5DF5BDB9}"/>
+                <c16:uniqueId val="{00000007-1DB8-4383-B3D3-17AC73097084}"/>
               </c:ext>
             </c:extLst>
           </c:dPt>
@@ -1223,7 +1223,7 @@
             </c:spPr>
             <c:extLst>
               <c:ext xmlns:c16="http://schemas.microsoft.com/office/drawing/2014/chart" uri="{C3380CC4-5D6E-409C-BE32-E72D297353CC}">
-                <c16:uniqueId val="{00000009-FE84-43F6-A9B0-CCCF5DF5BDB9}"/>
+                <c16:uniqueId val="{00000009-1DB8-4383-B3D3-17AC73097084}"/>
               </c:ext>
             </c:extLst>
           </c:dPt>
@@ -1239,7 +1239,7 @@
             </c:spPr>
             <c:extLst>
               <c:ext xmlns:c16="http://schemas.microsoft.com/office/drawing/2014/chart" uri="{C3380CC4-5D6E-409C-BE32-E72D297353CC}">
-                <c16:uniqueId val="{0000000B-FE84-43F6-A9B0-CCCF5DF5BDB9}"/>
+                <c16:uniqueId val="{0000000B-1DB8-4383-B3D3-17AC73097084}"/>
               </c:ext>
             </c:extLst>
           </c:dPt>
@@ -1335,7 +1335,7 @@
           </c:val>
           <c:extLst>
             <c:ext xmlns:c16="http://schemas.microsoft.com/office/drawing/2014/chart" uri="{C3380CC4-5D6E-409C-BE32-E72D297353CC}">
-              <c16:uniqueId val="{0000000C-FE84-43F6-A9B0-CCCF5DF5BDB9}"/>
+              <c16:uniqueId val="{0000000C-1DB8-4383-B3D3-17AC73097084}"/>
             </c:ext>
           </c:extLst>
         </c:ser>
@@ -1474,7 +1474,7 @@
             <c:bubble3D val="0"/>
             <c:extLst>
               <c:ext xmlns:c16="http://schemas.microsoft.com/office/drawing/2014/chart" uri="{C3380CC4-5D6E-409C-BE32-E72D297353CC}">
-                <c16:uniqueId val="{00000001-719A-4908-9A20-E4F36B67F323}"/>
+                <c16:uniqueId val="{00000001-D08A-459F-84F5-36AB07EA2AAF}"/>
               </c:ext>
             </c:extLst>
           </c:dPt>
@@ -1490,7 +1490,7 @@
             </c:spPr>
             <c:extLst>
               <c:ext xmlns:c16="http://schemas.microsoft.com/office/drawing/2014/chart" uri="{C3380CC4-5D6E-409C-BE32-E72D297353CC}">
-                <c16:uniqueId val="{00000003-719A-4908-9A20-E4F36B67F323}"/>
+                <c16:uniqueId val="{00000003-D08A-459F-84F5-36AB07EA2AAF}"/>
               </c:ext>
             </c:extLst>
           </c:dPt>
@@ -1562,7 +1562,7 @@
           </c:val>
           <c:extLst>
             <c:ext xmlns:c16="http://schemas.microsoft.com/office/drawing/2014/chart" uri="{C3380CC4-5D6E-409C-BE32-E72D297353CC}">
-              <c16:uniqueId val="{00000004-719A-4908-9A20-E4F36B67F323}"/>
+              <c16:uniqueId val="{00000004-D08A-459F-84F5-36AB07EA2AAF}"/>
             </c:ext>
           </c:extLst>
         </c:ser>
@@ -1685,7 +1685,7 @@
     </p:spTree>
     <p:extLst>
       <p:ext uri="{BB962C8B-B14F-4D97-AF65-F5344CB8AC3E}">
-        <p14:creationId xmlns:p14="http://schemas.microsoft.com/office/powerpoint/2010/main" val="1363849047"/>
+        <p14:creationId xmlns:p14="http://schemas.microsoft.com/office/powerpoint/2010/main" val="462478716"/>
       </p:ext>
     </p:extLst>
   </p:cSld>
@@ -5001,7 +5001,7 @@
                   <a:srgbClr val="A1A1AA"/>
                 </a:solidFill>
               </a:rPr>
-              <a:t>A fruit-fly brain</a:t>
+              <a:t>The brain of a fruit fly</a:t>
             </a:r>
             <a:endParaRPr lang="en-US" sz="1800" dirty="0"/>
           </a:p>
@@ -5015,7 +5015,7 @@
                   <a:srgbClr val="A1A1AA"/>
                 </a:solidFill>
               </a:rPr>
-              <a:t>flies a drone</a:t>
+              <a:t>pilots a drone</a:t>
             </a:r>
             <a:endParaRPr lang="en-US" sz="1800" dirty="0"/>
           </a:p>

</xml_diff>

<commit_message>
Prezentacja: wynik zawis/skręt/podmuch zamiast slajdu o ograniczeniach
Co-Authored-By: Claude Opus 5.5 <noreply@anthropic.com>
</commit_message>
<xml_diff>
--- a/docs/prezentacja/NeuroFly.pptx
+++ b/docs/prezentacja/NeuroFly.pptx
@@ -14,8 +14,8 @@
     <p:sldId id="261" r:id="rId7"/>
     <p:sldId id="263" r:id="rId9"/>
     <p:sldId id="266" r:id="rId12"/>
+    <p:sldId id="268" r:id="rId14"/>
     <p:sldId id="269" r:id="rId15"/>
-    <p:sldId id="270" r:id="rId16"/>
     <p:sldId id="272" r:id="rId18"/>
     <p:sldId id="276" r:id="rId22"/>
   </p:sldIdLst>
@@ -165,12 +165,8 @@
         </p14:section>
         <p14:section name="Results" id="{0AB5329D-D9B6-F548-74F6-6D5C9159752F}">
           <p14:sldIdLst>
+            <p14:sldId id="268"/>
             <p14:sldId id="269"/>
-          </p14:sldIdLst>
-        </p14:section>
-        <p14:section name="Honesty" id="{5DDE117D-EAD2-0903-C8BE-DDE65AD3A3C2}">
-          <p14:sldIdLst>
-            <p14:sldId id="270"/>
           </p14:sldIdLst>
         </p14:section>
         <p14:section name="Next" id="{88DDCDBF-5801-2ACC-E04B-9306572FC45F}">
@@ -1053,6 +1049,93 @@
 </p:notes>
 </file>
 
+<file path=ppt/notesSlides/notesSlide13.xml><?xml version="1.0" encoding="utf-8"?>
+<p:notes xmlns:a="http://schemas.openxmlformats.org/drawingml/2006/main" xmlns:r="http://schemas.openxmlformats.org/officeDocument/2006/relationships" xmlns:p="http://schemas.openxmlformats.org/presentationml/2006/main">
+  <p:cSld>
+    <p:spTree>
+      <p:nvGrpSpPr>
+        <p:cNvPr id="1" name=""/>
+        <p:cNvGrpSpPr/>
+        <p:nvPr/>
+      </p:nvGrpSpPr>
+      <p:grpSpPr>
+        <a:xfrm>
+          <a:off x="0" y="0"/>
+          <a:ext cx="0" cy="0"/>
+          <a:chOff x="0" y="0"/>
+          <a:chExt cx="0" cy="0"/>
+        </a:xfrm>
+      </p:grpSpPr>
+      <p:sp>
+        <p:nvSpPr>
+          <p:cNvPr id="2" name="Slide Image Placeholder 1"/>
+          <p:cNvSpPr>
+            <a:spLocks noGrp="1" noRot="1" noChangeAspect="1"/>
+          </p:cNvSpPr>
+          <p:nvPr>
+            <p:ph type="sldImg"/>
+          </p:nvPr>
+        </p:nvSpPr>
+        <p:spPr/>
+      </p:sp>
+      <p:sp>
+        <p:nvSpPr>
+          <p:cNvPr id="3" name="Notes Placeholder 2"/>
+          <p:cNvSpPr>
+            <a:spLocks noGrp="1"/>
+          </p:cNvSpPr>
+          <p:nvPr>
+            <p:ph type="body" idx="1"/>
+          </p:nvPr>
+        </p:nvSpPr>
+        <p:spPr/>
+        <p:txBody>
+          <a:bodyPr/>
+          <a:lstStyle/>
+          <a:p>
+            <a:r>
+              <a:rPr lang="en-US" dirty="0"/>
+              <a:t>fly_banc.py --local --decoder data/decoders/planB_dn.npz --thrust hold. Thrust is held by the simulator; the connectome decides the heading and, through the halteres, damps the rotation after the gust.</a:t>
+            </a:r>
+          </a:p>
+        </p:txBody>
+      </p:sp>
+      <p:sp>
+        <p:nvSpPr>
+          <p:cNvPr id="4" name="Slide Number Placeholder 3"/>
+          <p:cNvSpPr>
+            <a:spLocks noGrp="1"/>
+          </p:cNvSpPr>
+          <p:nvPr>
+            <p:ph type="sldNum" sz="quarter" idx="10"/>
+          </p:nvPr>
+        </p:nvSpPr>
+        <p:spPr/>
+        <p:txBody>
+          <a:bodyPr/>
+          <a:lstStyle/>
+          <a:p>
+            <a:fld id="{F7021451-1387-4CA6-816F-3879F97B5CBC}" type="slidenum">
+              <a:rPr lang="en-US"/>
+              <a:t>13</a:t>
+            </a:fld>
+            <a:endParaRPr lang="en-US"/>
+          </a:p>
+        </p:txBody>
+      </p:sp>
+    </p:spTree>
+    <p:extLst>
+      <p:ext uri="{BB962C8B-B14F-4D97-AF65-F5344CB8AC3E}">
+        <p14:creationId xmlns:p14="http://schemas.microsoft.com/office/powerpoint/2010/main" val="1024086991"/>
+      </p:ext>
+    </p:extLst>
+  </p:cSld>
+  <p:clrMapOvr>
+    <a:masterClrMapping/>
+  </p:clrMapOvr>
+</p:notes>
+</file>
+
 <file path=ppt/notesSlides/notesSlide14.xml><?xml version="1.0" encoding="utf-8"?>
 <p:notes xmlns:a="http://schemas.openxmlformats.org/drawingml/2006/main" xmlns:r="http://schemas.openxmlformats.org/officeDocument/2006/relationships" xmlns:p="http://schemas.openxmlformats.org/presentationml/2006/main">
   <p:cSld>
@@ -1122,93 +1205,6 @@
             <a:fld id="{F7021451-1387-4CA6-816F-3879F97B5CBC}" type="slidenum">
               <a:rPr lang="en-US"/>
               <a:t>14</a:t>
-            </a:fld>
-            <a:endParaRPr lang="en-US"/>
-          </a:p>
-        </p:txBody>
-      </p:sp>
-    </p:spTree>
-    <p:extLst>
-      <p:ext uri="{BB962C8B-B14F-4D97-AF65-F5344CB8AC3E}">
-        <p14:creationId xmlns:p14="http://schemas.microsoft.com/office/powerpoint/2010/main" val="1024086991"/>
-      </p:ext>
-    </p:extLst>
-  </p:cSld>
-  <p:clrMapOvr>
-    <a:masterClrMapping/>
-  </p:clrMapOvr>
-</p:notes>
-</file>
-
-<file path=ppt/notesSlides/notesSlide15.xml><?xml version="1.0" encoding="utf-8"?>
-<p:notes xmlns:a="http://schemas.openxmlformats.org/drawingml/2006/main" xmlns:r="http://schemas.openxmlformats.org/officeDocument/2006/relationships" xmlns:p="http://schemas.openxmlformats.org/presentationml/2006/main">
-  <p:cSld>
-    <p:spTree>
-      <p:nvGrpSpPr>
-        <p:cNvPr id="1" name=""/>
-        <p:cNvGrpSpPr/>
-        <p:nvPr/>
-      </p:nvGrpSpPr>
-      <p:grpSpPr>
-        <a:xfrm>
-          <a:off x="0" y="0"/>
-          <a:ext cx="0" cy="0"/>
-          <a:chOff x="0" y="0"/>
-          <a:chExt cx="0" cy="0"/>
-        </a:xfrm>
-      </p:grpSpPr>
-      <p:sp>
-        <p:nvSpPr>
-          <p:cNvPr id="2" name="Slide Image Placeholder 1"/>
-          <p:cNvSpPr>
-            <a:spLocks noGrp="1" noRot="1" noChangeAspect="1"/>
-          </p:cNvSpPr>
-          <p:nvPr>
-            <p:ph type="sldImg"/>
-          </p:nvPr>
-        </p:nvSpPr>
-        <p:spPr/>
-      </p:sp>
-      <p:sp>
-        <p:nvSpPr>
-          <p:cNvPr id="3" name="Notes Placeholder 2"/>
-          <p:cNvSpPr>
-            <a:spLocks noGrp="1"/>
-          </p:cNvSpPr>
-          <p:nvPr>
-            <p:ph type="body" idx="1"/>
-          </p:nvPr>
-        </p:nvSpPr>
-        <p:spPr/>
-        <p:txBody>
-          <a:bodyPr/>
-          <a:lstStyle/>
-          <a:p>
-            <a:r>
-              <a:rPr lang="en-US" dirty="0"/>
-              <a:t>We would rather show the limits than hide them. Each of these is a concrete next step.</a:t>
-            </a:r>
-          </a:p>
-        </p:txBody>
-      </p:sp>
-      <p:sp>
-        <p:nvSpPr>
-          <p:cNvPr id="4" name="Slide Number Placeholder 3"/>
-          <p:cNvSpPr>
-            <a:spLocks noGrp="1"/>
-          </p:cNvSpPr>
-          <p:nvPr>
-            <p:ph type="sldNum" sz="quarter" idx="10"/>
-          </p:nvPr>
-        </p:nvSpPr>
-        <p:spPr/>
-        <p:txBody>
-          <a:bodyPr/>
-          <a:lstStyle/>
-          <a:p>
-            <a:fld id="{F7021451-1387-4CA6-816F-3879F97B5CBC}" type="slidenum">
-              <a:rPr lang="en-US"/>
-              <a:t>15</a:t>
             </a:fld>
             <a:endParaRPr lang="en-US"/>
           </a:p>
@@ -3449,6 +3445,962 @@
 </p:sld>
 </file>
 
+<file path=ppt/slides/slide13.xml><?xml version="1.0" encoding="utf-8"?>
+<p:sld xmlns:a="http://schemas.openxmlformats.org/drawingml/2006/main" xmlns:r="http://schemas.openxmlformats.org/officeDocument/2006/relationships" xmlns:p="http://schemas.openxmlformats.org/presentationml/2006/main">
+  <p:cSld name="Slide 13">
+    <p:spTree>
+      <p:nvGrpSpPr>
+        <p:cNvPr id="1" name=""/>
+        <p:cNvGrpSpPr/>
+        <p:nvPr/>
+      </p:nvGrpSpPr>
+      <p:grpSpPr>
+        <a:xfrm>
+          <a:off x="0" y="0"/>
+          <a:ext cx="0" cy="0"/>
+          <a:chOff x="0" y="0"/>
+          <a:chExt cx="0" cy="0"/>
+        </a:xfrm>
+      </p:grpSpPr>
+      <p:sp>
+        <p:nvSpPr>
+          <p:cNvPr id="2" name="eyebrow"/>
+          <p:cNvSpPr txBox="1"/>
+          <p:nvPr/>
+        </p:nvSpPr>
+        <p:spPr>
+          <a:xfrm>
+            <a:off x="566928" y="219456"/>
+            <a:ext cx="5486400" cy="201168"/>
+          </a:xfrm>
+          <a:prstGeom prst="rect">
+            <a:avLst/>
+          </a:prstGeom>
+          <a:noFill/>
+          <a:ln/>
+        </p:spPr>
+        <p:txBody>
+          <a:bodyPr wrap="square" lIns="0" tIns="0" rIns="0" bIns="0" rtlCol="0" anchor="t"/>
+          <a:lstStyle/>
+          <a:p>
+            <a:pPr marL="0" indent="0">
+              <a:buNone/>
+            </a:pPr>
+            <a:r>
+              <a:rPr lang="en-US" sz="800" kern="0" spc="500" dirty="0">
+                <a:solidFill>
+                  <a:srgbClr val="FF2D6F"/>
+                </a:solidFill>
+              </a:rPr>
+              <a:t>RESULTS</a:t>
+            </a:r>
+            <a:endParaRPr lang="en-US" sz="800" dirty="0"/>
+          </a:p>
+        </p:txBody>
+      </p:sp>
+      <p:sp>
+        <p:nvSpPr>
+          <p:cNvPr id="3" name="Text 1"/>
+          <p:cNvSpPr>
+            <a:spLocks noGrp="1"/>
+          </p:cNvSpPr>
+          <p:nvPr>
+            <p:ph type="title" idx="103" hasCustomPrompt="1"/>
+          </p:nvPr>
+        </p:nvSpPr>
+        <p:spPr>
+          <a:xfrm>
+            <a:off x="566928" y="457200"/>
+            <a:ext cx="7589520" cy="365760"/>
+          </a:xfrm>
+          <a:prstGeom prst="rect">
+            <a:avLst/>
+          </a:prstGeom>
+          <a:noFill/>
+          <a:ln/>
+        </p:spPr>
+        <p:txBody>
+          <a:bodyPr wrap="square" lIns="0" tIns="0" rIns="0" bIns="0" rtlCol="0" anchor="t"/>
+          <a:lstStyle/>
+          <a:p>
+            <a:pPr marL="0" indent="0" algn="l">
+              <a:buNone/>
+            </a:pPr>
+            <a:r>
+              <a:rPr lang="en-US" sz="1600" kern="0" spc="100" dirty="0">
+                <a:solidFill>
+                  <a:srgbClr val="FAFAFA"/>
+                </a:solidFill>
+                <a:latin typeface="Michroma" pitchFamily="34" charset="0"/>
+                <a:ea typeface="Michroma" pitchFamily="34" charset="-122"/>
+                <a:cs typeface="Michroma" pitchFamily="34" charset="-120"/>
+              </a:rPr>
+              <a:t>RESULT: HOVER, TURN, GUST</a:t>
+            </a:r>
+            <a:endParaRPr lang="en-US" sz="1600" dirty="0"/>
+          </a:p>
+        </p:txBody>
+      </p:sp>
+      <p:sp>
+        <p:nvSpPr>
+          <p:cNvPr id="4" name="r-0"/>
+          <p:cNvSpPr/>
+          <p:nvPr/>
+        </p:nvSpPr>
+        <p:spPr>
+          <a:xfrm>
+            <a:off x="502920" y="1051560"/>
+            <a:ext cx="5029200" cy="658368"/>
+          </a:xfrm>
+          <a:prstGeom prst="rect">
+            <a:avLst/>
+          </a:prstGeom>
+          <a:solidFill>
+            <a:srgbClr val="18181B">
+              <a:alpha val="88000"/>
+            </a:srgbClr>
+          </a:solidFill>
+          <a:ln w="9525">
+            <a:solidFill>
+              <a:srgbClr val="3F3F46"/>
+            </a:solidFill>
+            <a:prstDash val="solid"/>
+          </a:ln>
+          <a:effectLst>
+            <a:outerShdw blurRad="228600" dist="76200" dir="5400000" algn="bl" rotWithShape="0">
+              <a:srgbClr val="000000">
+                <a:alpha val="55000"/>
+              </a:srgbClr>
+            </a:outerShdw>
+          </a:effectLst>
+        </p:spPr>
+        <p:txBody>
+          <a:bodyPr/>
+          <a:lstStyle/>
+          <a:p>
+            <a:endParaRPr lang="pl-PL"/>
+          </a:p>
+        </p:txBody>
+      </p:sp>
+      <p:sp>
+        <p:nvSpPr>
+          <p:cNvPr id="5" name="r-0-k"/>
+          <p:cNvSpPr txBox="1"/>
+          <p:nvPr/>
+        </p:nvSpPr>
+        <p:spPr>
+          <a:xfrm>
+            <a:off x="713232" y="1243584"/>
+            <a:ext cx="1371600" cy="292608"/>
+          </a:xfrm>
+          <a:prstGeom prst="rect">
+            <a:avLst/>
+          </a:prstGeom>
+          <a:noFill/>
+          <a:ln/>
+        </p:spPr>
+        <p:txBody>
+          <a:bodyPr wrap="square" lIns="0" tIns="0" rIns="0" bIns="0" rtlCol="0" anchor="t"/>
+          <a:lstStyle/>
+          <a:p>
+            <a:pPr marL="0" indent="0">
+              <a:buNone/>
+            </a:pPr>
+            <a:r>
+              <a:rPr lang="en-US" sz="1300" b="1" dirty="0">
+                <a:solidFill>
+                  <a:srgbClr val="FAFAFA"/>
+                </a:solidFill>
+              </a:rPr>
+              <a:t>Hover</a:t>
+            </a:r>
+            <a:endParaRPr lang="en-US" sz="1300" dirty="0"/>
+          </a:p>
+        </p:txBody>
+      </p:sp>
+      <p:sp>
+        <p:nvSpPr>
+          <p:cNvPr id="6" name="r-0-v"/>
+          <p:cNvSpPr txBox="1"/>
+          <p:nvPr/>
+        </p:nvSpPr>
+        <p:spPr>
+          <a:xfrm>
+            <a:off x="2057400" y="1170432"/>
+            <a:ext cx="1600200" cy="411480"/>
+          </a:xfrm>
+          <a:prstGeom prst="rect">
+            <a:avLst/>
+          </a:prstGeom>
+          <a:noFill/>
+          <a:ln/>
+        </p:spPr>
+        <p:txBody>
+          <a:bodyPr wrap="square" lIns="0" tIns="0" rIns="0" bIns="0" rtlCol="0" anchor="t"/>
+          <a:lstStyle/>
+          <a:p>
+            <a:pPr marL="0" indent="0">
+              <a:buNone/>
+            </a:pPr>
+            <a:r>
+              <a:rPr lang="en-US" sz="2200" dirty="0">
+                <a:solidFill>
+                  <a:srgbClr val="FF2D6F"/>
+                </a:solidFill>
+                <a:latin typeface="Roboto Light" pitchFamily="34" charset="0"/>
+                <a:ea typeface="Roboto Light" pitchFamily="34" charset="-122"/>
+                <a:cs typeface="Roboto Light" pitchFamily="34" charset="-120"/>
+              </a:rPr>
+              <a:t>1.7°</a:t>
+            </a:r>
+            <a:endParaRPr lang="en-US" sz="2200" dirty="0"/>
+          </a:p>
+        </p:txBody>
+      </p:sp>
+      <p:sp>
+        <p:nvSpPr>
+          <p:cNvPr id="7" name="r-0-d"/>
+          <p:cNvSpPr txBox="1"/>
+          <p:nvPr/>
+        </p:nvSpPr>
+        <p:spPr>
+          <a:xfrm>
+            <a:off x="3703320" y="1170432"/>
+            <a:ext cx="1737360" cy="457200"/>
+          </a:xfrm>
+          <a:prstGeom prst="rect">
+            <a:avLst/>
+          </a:prstGeom>
+          <a:noFill/>
+          <a:ln/>
+        </p:spPr>
+        <p:txBody>
+          <a:bodyPr wrap="square" lIns="0" tIns="0" rIns="0" bIns="0" rtlCol="0" anchor="t"/>
+          <a:lstStyle/>
+          <a:p>
+            <a:pPr marL="0" indent="0">
+              <a:buNone/>
+            </a:pPr>
+            <a:r>
+              <a:rPr lang="en-US" sz="1000" dirty="0">
+                <a:solidFill>
+                  <a:srgbClr val="A1A1AA"/>
+                </a:solidFill>
+              </a:rPr>
+              <a:t>heading error while hovering</a:t>
+            </a:r>
+            <a:endParaRPr lang="en-US" sz="1000" dirty="0"/>
+          </a:p>
+        </p:txBody>
+      </p:sp>
+      <p:sp>
+        <p:nvSpPr>
+          <p:cNvPr id="8" name="r-1"/>
+          <p:cNvSpPr/>
+          <p:nvPr/>
+        </p:nvSpPr>
+        <p:spPr>
+          <a:xfrm>
+            <a:off x="502920" y="1819656"/>
+            <a:ext cx="5029200" cy="658368"/>
+          </a:xfrm>
+          <a:prstGeom prst="rect">
+            <a:avLst/>
+          </a:prstGeom>
+          <a:solidFill>
+            <a:srgbClr val="18181B">
+              <a:alpha val="88000"/>
+            </a:srgbClr>
+          </a:solidFill>
+          <a:ln w="9525">
+            <a:solidFill>
+              <a:srgbClr val="3F3F46"/>
+            </a:solidFill>
+            <a:prstDash val="solid"/>
+          </a:ln>
+          <a:effectLst>
+            <a:outerShdw blurRad="228600" dist="76200" dir="5400000" algn="bl" rotWithShape="0">
+              <a:srgbClr val="000000">
+                <a:alpha val="55000"/>
+              </a:srgbClr>
+            </a:outerShdw>
+          </a:effectLst>
+        </p:spPr>
+        <p:txBody>
+          <a:bodyPr/>
+          <a:lstStyle/>
+          <a:p>
+            <a:endParaRPr lang="pl-PL"/>
+          </a:p>
+        </p:txBody>
+      </p:sp>
+      <p:sp>
+        <p:nvSpPr>
+          <p:cNvPr id="9" name="r-1-k"/>
+          <p:cNvSpPr txBox="1"/>
+          <p:nvPr/>
+        </p:nvSpPr>
+        <p:spPr>
+          <a:xfrm>
+            <a:off x="713232" y="2011680"/>
+            <a:ext cx="1371600" cy="292608"/>
+          </a:xfrm>
+          <a:prstGeom prst="rect">
+            <a:avLst/>
+          </a:prstGeom>
+          <a:noFill/>
+          <a:ln/>
+        </p:spPr>
+        <p:txBody>
+          <a:bodyPr wrap="square" lIns="0" tIns="0" rIns="0" bIns="0" rtlCol="0" anchor="t"/>
+          <a:lstStyle/>
+          <a:p>
+            <a:pPr marL="0" indent="0">
+              <a:buNone/>
+            </a:pPr>
+            <a:r>
+              <a:rPr lang="en-US" sz="1300" b="1" dirty="0">
+                <a:solidFill>
+                  <a:srgbClr val="FAFAFA"/>
+                </a:solidFill>
+              </a:rPr>
+              <a:t>Target +60°</a:t>
+            </a:r>
+            <a:endParaRPr lang="en-US" sz="1300" dirty="0"/>
+          </a:p>
+        </p:txBody>
+      </p:sp>
+      <p:sp>
+        <p:nvSpPr>
+          <p:cNvPr id="10" name="r-1-v"/>
+          <p:cNvSpPr txBox="1"/>
+          <p:nvPr/>
+        </p:nvSpPr>
+        <p:spPr>
+          <a:xfrm>
+            <a:off x="2057400" y="1938528"/>
+            <a:ext cx="1600200" cy="411480"/>
+          </a:xfrm>
+          <a:prstGeom prst="rect">
+            <a:avLst/>
+          </a:prstGeom>
+          <a:noFill/>
+          <a:ln/>
+        </p:spPr>
+        <p:txBody>
+          <a:bodyPr wrap="square" lIns="0" tIns="0" rIns="0" bIns="0" rtlCol="0" anchor="t"/>
+          <a:lstStyle/>
+          <a:p>
+            <a:pPr marL="0" indent="0">
+              <a:buNone/>
+            </a:pPr>
+            <a:r>
+              <a:rPr lang="en-US" sz="2200" dirty="0">
+                <a:solidFill>
+                  <a:srgbClr val="FF2D6F"/>
+                </a:solidFill>
+                <a:latin typeface="Roboto Light" pitchFamily="34" charset="0"/>
+                <a:ea typeface="Roboto Light" pitchFamily="34" charset="-122"/>
+                <a:cs typeface="Roboto Light" pitchFamily="34" charset="-120"/>
+              </a:rPr>
+              <a:t>7°</a:t>
+            </a:r>
+            <a:endParaRPr lang="en-US" sz="2200" dirty="0"/>
+          </a:p>
+        </p:txBody>
+      </p:sp>
+      <p:sp>
+        <p:nvSpPr>
+          <p:cNvPr id="11" name="r-1-d"/>
+          <p:cNvSpPr txBox="1"/>
+          <p:nvPr/>
+        </p:nvSpPr>
+        <p:spPr>
+          <a:xfrm>
+            <a:off x="3703320" y="1938528"/>
+            <a:ext cx="1737360" cy="457200"/>
+          </a:xfrm>
+          <a:prstGeom prst="rect">
+            <a:avLst/>
+          </a:prstGeom>
+          <a:noFill/>
+          <a:ln/>
+        </p:spPr>
+        <p:txBody>
+          <a:bodyPr wrap="square" lIns="0" tIns="0" rIns="0" bIns="0" rtlCol="0" anchor="t"/>
+          <a:lstStyle/>
+          <a:p>
+            <a:pPr marL="0" indent="0">
+              <a:buNone/>
+            </a:pPr>
+            <a:r>
+              <a:rPr lang="en-US" sz="1000" dirty="0">
+                <a:solidFill>
+                  <a:srgbClr val="A1A1AA"/>
+                </a:solidFill>
+              </a:rPr>
+              <a:t>error after the turn settles (6 s)</a:t>
+            </a:r>
+            <a:endParaRPr lang="en-US" sz="1000" dirty="0"/>
+          </a:p>
+        </p:txBody>
+      </p:sp>
+      <p:sp>
+        <p:nvSpPr>
+          <p:cNvPr id="12" name="r-2"/>
+          <p:cNvSpPr/>
+          <p:nvPr/>
+        </p:nvSpPr>
+        <p:spPr>
+          <a:xfrm>
+            <a:off x="502920" y="2587752"/>
+            <a:ext cx="5029200" cy="658368"/>
+          </a:xfrm>
+          <a:prstGeom prst="rect">
+            <a:avLst/>
+          </a:prstGeom>
+          <a:solidFill>
+            <a:srgbClr val="18181B">
+              <a:alpha val="88000"/>
+            </a:srgbClr>
+          </a:solidFill>
+          <a:ln w="9525">
+            <a:solidFill>
+              <a:srgbClr val="3F3F46"/>
+            </a:solidFill>
+            <a:prstDash val="solid"/>
+          </a:ln>
+          <a:effectLst>
+            <a:outerShdw blurRad="228600" dist="76200" dir="5400000" algn="bl" rotWithShape="0">
+              <a:srgbClr val="000000">
+                <a:alpha val="55000"/>
+              </a:srgbClr>
+            </a:outerShdw>
+          </a:effectLst>
+        </p:spPr>
+        <p:txBody>
+          <a:bodyPr/>
+          <a:lstStyle/>
+          <a:p>
+            <a:endParaRPr lang="pl-PL"/>
+          </a:p>
+        </p:txBody>
+      </p:sp>
+      <p:sp>
+        <p:nvSpPr>
+          <p:cNvPr id="13" name="r-2-k"/>
+          <p:cNvSpPr txBox="1"/>
+          <p:nvPr/>
+        </p:nvSpPr>
+        <p:spPr>
+          <a:xfrm>
+            <a:off x="713232" y="2779776"/>
+            <a:ext cx="1371600" cy="292608"/>
+          </a:xfrm>
+          <a:prstGeom prst="rect">
+            <a:avLst/>
+          </a:prstGeom>
+          <a:noFill/>
+          <a:ln/>
+        </p:spPr>
+        <p:txBody>
+          <a:bodyPr wrap="square" lIns="0" tIns="0" rIns="0" bIns="0" rtlCol="0" anchor="t"/>
+          <a:lstStyle/>
+          <a:p>
+            <a:pPr marL="0" indent="0">
+              <a:buNone/>
+            </a:pPr>
+            <a:r>
+              <a:rPr lang="en-US" sz="1300" b="1" dirty="0">
+                <a:solidFill>
+                  <a:srgbClr val="FAFAFA"/>
+                </a:solidFill>
+              </a:rPr>
+              <a:t>Target −60°</a:t>
+            </a:r>
+            <a:endParaRPr lang="en-US" sz="1300" dirty="0"/>
+          </a:p>
+        </p:txBody>
+      </p:sp>
+      <p:sp>
+        <p:nvSpPr>
+          <p:cNvPr id="14" name="r-2-v"/>
+          <p:cNvSpPr txBox="1"/>
+          <p:nvPr/>
+        </p:nvSpPr>
+        <p:spPr>
+          <a:xfrm>
+            <a:off x="2057400" y="2706624"/>
+            <a:ext cx="1600200" cy="411480"/>
+          </a:xfrm>
+          <a:prstGeom prst="rect">
+            <a:avLst/>
+          </a:prstGeom>
+          <a:noFill/>
+          <a:ln/>
+        </p:spPr>
+        <p:txBody>
+          <a:bodyPr wrap="square" lIns="0" tIns="0" rIns="0" bIns="0" rtlCol="0" anchor="t"/>
+          <a:lstStyle/>
+          <a:p>
+            <a:pPr marL="0" indent="0">
+              <a:buNone/>
+            </a:pPr>
+            <a:r>
+              <a:rPr lang="en-US" sz="2200" dirty="0">
+                <a:solidFill>
+                  <a:srgbClr val="FF2D6F"/>
+                </a:solidFill>
+                <a:latin typeface="Roboto Light" pitchFamily="34" charset="0"/>
+                <a:ea typeface="Roboto Light" pitchFamily="34" charset="-122"/>
+                <a:cs typeface="Roboto Light" pitchFamily="34" charset="-120"/>
+              </a:rPr>
+              <a:t>21°</a:t>
+            </a:r>
+            <a:endParaRPr lang="en-US" sz="2200" dirty="0"/>
+          </a:p>
+        </p:txBody>
+      </p:sp>
+      <p:sp>
+        <p:nvSpPr>
+          <p:cNvPr id="15" name="r-2-d"/>
+          <p:cNvSpPr txBox="1"/>
+          <p:nvPr/>
+        </p:nvSpPr>
+        <p:spPr>
+          <a:xfrm>
+            <a:off x="3703320" y="2706624"/>
+            <a:ext cx="1737360" cy="457200"/>
+          </a:xfrm>
+          <a:prstGeom prst="rect">
+            <a:avLst/>
+          </a:prstGeom>
+          <a:noFill/>
+          <a:ln/>
+        </p:spPr>
+        <p:txBody>
+          <a:bodyPr wrap="square" lIns="0" tIns="0" rIns="0" bIns="0" rtlCol="0" anchor="t"/>
+          <a:lstStyle/>
+          <a:p>
+            <a:pPr marL="0" indent="0">
+              <a:buNone/>
+            </a:pPr>
+            <a:r>
+              <a:rPr lang="en-US" sz="1000" dirty="0">
+                <a:solidFill>
+                  <a:srgbClr val="A1A1AA"/>
+                </a:solidFill>
+              </a:rPr>
+              <a:t>turns, a bit weaker on the left</a:t>
+            </a:r>
+            <a:endParaRPr lang="en-US" sz="1000" dirty="0"/>
+          </a:p>
+        </p:txBody>
+      </p:sp>
+      <p:sp>
+        <p:nvSpPr>
+          <p:cNvPr id="16" name="r-3"/>
+          <p:cNvSpPr/>
+          <p:nvPr/>
+        </p:nvSpPr>
+        <p:spPr>
+          <a:xfrm>
+            <a:off x="502920" y="3355848"/>
+            <a:ext cx="5029200" cy="658368"/>
+          </a:xfrm>
+          <a:prstGeom prst="rect">
+            <a:avLst/>
+          </a:prstGeom>
+          <a:solidFill>
+            <a:srgbClr val="18181B">
+              <a:alpha val="88000"/>
+            </a:srgbClr>
+          </a:solidFill>
+          <a:ln w="9525">
+            <a:solidFill>
+              <a:srgbClr val="3F3F46"/>
+            </a:solidFill>
+            <a:prstDash val="solid"/>
+          </a:ln>
+          <a:effectLst>
+            <a:outerShdw blurRad="228600" dist="76200" dir="5400000" algn="bl" rotWithShape="0">
+              <a:srgbClr val="000000">
+                <a:alpha val="55000"/>
+              </a:srgbClr>
+            </a:outerShdw>
+          </a:effectLst>
+        </p:spPr>
+        <p:txBody>
+          <a:bodyPr/>
+          <a:lstStyle/>
+          <a:p>
+            <a:endParaRPr lang="pl-PL"/>
+          </a:p>
+        </p:txBody>
+      </p:sp>
+      <p:sp>
+        <p:nvSpPr>
+          <p:cNvPr id="17" name="r-3-k"/>
+          <p:cNvSpPr txBox="1"/>
+          <p:nvPr/>
+        </p:nvSpPr>
+        <p:spPr>
+          <a:xfrm>
+            <a:off x="713232" y="3547872"/>
+            <a:ext cx="1371600" cy="292608"/>
+          </a:xfrm>
+          <a:prstGeom prst="rect">
+            <a:avLst/>
+          </a:prstGeom>
+          <a:noFill/>
+          <a:ln/>
+        </p:spPr>
+        <p:txBody>
+          <a:bodyPr wrap="square" lIns="0" tIns="0" rIns="0" bIns="0" rtlCol="0" anchor="t"/>
+          <a:lstStyle/>
+          <a:p>
+            <a:pPr marL="0" indent="0">
+              <a:buNone/>
+            </a:pPr>
+            <a:r>
+              <a:rPr lang="en-US" sz="1300" b="1" dirty="0">
+                <a:solidFill>
+                  <a:srgbClr val="FAFAFA"/>
+                </a:solidFill>
+              </a:rPr>
+              <a:t>Gust</a:t>
+            </a:r>
+            <a:endParaRPr lang="en-US" sz="1300" dirty="0"/>
+          </a:p>
+        </p:txBody>
+      </p:sp>
+      <p:sp>
+        <p:nvSpPr>
+          <p:cNvPr id="18" name="r-3-v"/>
+          <p:cNvSpPr txBox="1"/>
+          <p:nvPr/>
+        </p:nvSpPr>
+        <p:spPr>
+          <a:xfrm>
+            <a:off x="2057400" y="3474720"/>
+            <a:ext cx="1600200" cy="411480"/>
+          </a:xfrm>
+          <a:prstGeom prst="rect">
+            <a:avLst/>
+          </a:prstGeom>
+          <a:noFill/>
+          <a:ln/>
+        </p:spPr>
+        <p:txBody>
+          <a:bodyPr wrap="square" lIns="0" tIns="0" rIns="0" bIns="0" rtlCol="0" anchor="t"/>
+          <a:lstStyle/>
+          <a:p>
+            <a:pPr marL="0" indent="0">
+              <a:buNone/>
+            </a:pPr>
+            <a:r>
+              <a:rPr lang="en-US" sz="2200" dirty="0">
+                <a:solidFill>
+                  <a:srgbClr val="FF2D6F"/>
+                </a:solidFill>
+                <a:latin typeface="Roboto Light" pitchFamily="34" charset="0"/>
+                <a:ea typeface="Roboto Light" pitchFamily="34" charset="-122"/>
+                <a:cs typeface="Roboto Light" pitchFamily="34" charset="-120"/>
+              </a:rPr>
+              <a:t>35° to 1.5°</a:t>
+            </a:r>
+            <a:endParaRPr lang="en-US" sz="2200" dirty="0"/>
+          </a:p>
+        </p:txBody>
+      </p:sp>
+      <p:sp>
+        <p:nvSpPr>
+          <p:cNvPr id="19" name="r-3-d"/>
+          <p:cNvSpPr txBox="1"/>
+          <p:nvPr/>
+        </p:nvSpPr>
+        <p:spPr>
+          <a:xfrm>
+            <a:off x="3703320" y="3474720"/>
+            <a:ext cx="1737360" cy="457200"/>
+          </a:xfrm>
+          <a:prstGeom prst="rect">
+            <a:avLst/>
+          </a:prstGeom>
+          <a:noFill/>
+          <a:ln/>
+        </p:spPr>
+        <p:txBody>
+          <a:bodyPr wrap="square" lIns="0" tIns="0" rIns="0" bIns="0" rtlCol="0" anchor="t"/>
+          <a:lstStyle/>
+          <a:p>
+            <a:pPr marL="0" indent="0">
+              <a:buNone/>
+            </a:pPr>
+            <a:r>
+              <a:rPr lang="en-US" sz="1000" dirty="0">
+                <a:solidFill>
+                  <a:srgbClr val="A1A1AA"/>
+                </a:solidFill>
+              </a:rPr>
+              <a:t>pushed off course, back on course in 3.9 s</a:t>
+            </a:r>
+            <a:endParaRPr lang="en-US" sz="1000" dirty="0"/>
+          </a:p>
+        </p:txBody>
+      </p:sp>
+      <p:pic>
+        <p:nvPicPr>
+          <p:cNvPr id="20" name="img-drone" descr="C:\NeuroFly\docs\prezentacja\assets\drone_chase.jpg"/>
+          <p:cNvPicPr>
+            <a:picLocks noChangeAspect="1"/>
+          </p:cNvPicPr>
+          <p:nvPr/>
+        </p:nvPicPr>
+        <p:blipFill>
+          <a:blip r:embed="rId3"/>
+          <a:stretch>
+            <a:fillRect/>
+          </a:stretch>
+        </p:blipFill>
+        <p:spPr>
+          <a:xfrm>
+            <a:off x="5806440" y="1051560"/>
+            <a:ext cx="2880360" cy="2157984"/>
+          </a:xfrm>
+          <a:prstGeom prst="rect">
+            <a:avLst/>
+          </a:prstGeom>
+          <a:effectLst>
+            <a:outerShdw blurRad="228600" dist="76200" dir="5400000" algn="bl" rotWithShape="0">
+              <a:srgbClr val="000000">
+                <a:alpha val="55000"/>
+              </a:srgbClr>
+            </a:outerShdw>
+          </a:effectLst>
+        </p:spPr>
+      </p:pic>
+      <p:sp>
+        <p:nvSpPr>
+          <p:cNvPr id="21" name="r-cap"/>
+          <p:cNvSpPr txBox="1"/>
+          <p:nvPr/>
+        </p:nvSpPr>
+        <p:spPr>
+          <a:xfrm>
+            <a:off x="5806440" y="3337560"/>
+            <a:ext cx="2880360" cy="731520"/>
+          </a:xfrm>
+          <a:prstGeom prst="rect">
+            <a:avLst/>
+          </a:prstGeom>
+          <a:noFill/>
+          <a:ln/>
+        </p:spPr>
+        <p:txBody>
+          <a:bodyPr wrap="square" lIns="0" tIns="0" rIns="0" bIns="0" rtlCol="0" anchor="t"/>
+          <a:lstStyle/>
+          <a:p>
+            <a:pPr marL="0" indent="0">
+              <a:buNone/>
+            </a:pPr>
+            <a:r>
+              <a:rPr lang="en-US" sz="1000" dirty="0">
+                <a:solidFill>
+                  <a:srgbClr val="A1A1AA"/>
+                </a:solidFill>
+              </a:rPr>
+              <a:t>Real fly vision and the full fly brain, flying the simulated drone.</a:t>
+            </a:r>
+            <a:endParaRPr lang="en-US" sz="1000" dirty="0"/>
+          </a:p>
+        </p:txBody>
+      </p:sp>
+      <p:sp>
+        <p:nvSpPr>
+          <p:cNvPr id="22" name="glossary-0"/>
+          <p:cNvSpPr txBox="1"/>
+          <p:nvPr/>
+        </p:nvSpPr>
+        <p:spPr>
+          <a:xfrm>
+            <a:off x="566928" y="4206240"/>
+            <a:ext cx="3163529" cy="411480"/>
+          </a:xfrm>
+          <a:prstGeom prst="rect">
+            <a:avLst/>
+          </a:prstGeom>
+          <a:noFill/>
+          <a:ln/>
+        </p:spPr>
+        <p:txBody>
+          <a:bodyPr wrap="square" lIns="0" tIns="0" rIns="0" bIns="0" rtlCol="0" anchor="t"/>
+          <a:lstStyle/>
+          <a:p>
+            <a:pPr marL="0" indent="0">
+              <a:buNone/>
+            </a:pPr>
+            <a:r>
+              <a:rPr lang="en-US" sz="900" b="1" dirty="0">
+                <a:solidFill>
+                  <a:srgbClr val="A1A1AA"/>
+                </a:solidFill>
+              </a:rPr>
+              <a:t>Heading error:</a:t>
+            </a:r>
+            <a:r>
+              <a:rPr lang="en-US" sz="900" dirty="0">
+                <a:solidFill>
+                  <a:srgbClr val="71717A"/>
+                </a:solidFill>
+              </a:rPr>
+              <a:t> angle between the nose and the target</a:t>
+            </a:r>
+            <a:endParaRPr lang="en-US" sz="900" dirty="0"/>
+          </a:p>
+        </p:txBody>
+      </p:sp>
+      <p:sp>
+        <p:nvSpPr>
+          <p:cNvPr id="23" name="glossary-1"/>
+          <p:cNvSpPr txBox="1"/>
+          <p:nvPr/>
+        </p:nvSpPr>
+        <p:spPr>
+          <a:xfrm>
+            <a:off x="4004777" y="4206240"/>
+            <a:ext cx="2287475" cy="411480"/>
+          </a:xfrm>
+          <a:prstGeom prst="rect">
+            <a:avLst/>
+          </a:prstGeom>
+          <a:noFill/>
+          <a:ln/>
+        </p:spPr>
+        <p:txBody>
+          <a:bodyPr wrap="square" lIns="0" tIns="0" rIns="0" bIns="0" rtlCol="0" anchor="t"/>
+          <a:lstStyle/>
+          <a:p>
+            <a:pPr marL="0" indent="0">
+              <a:buNone/>
+            </a:pPr>
+            <a:r>
+              <a:rPr lang="en-US" sz="900" b="1" dirty="0">
+                <a:solidFill>
+                  <a:srgbClr val="A1A1AA"/>
+                </a:solidFill>
+              </a:rPr>
+              <a:t>Gust:</a:t>
+            </a:r>
+            <a:r>
+              <a:rPr lang="en-US" sz="900" dirty="0">
+                <a:solidFill>
+                  <a:srgbClr val="71717A"/>
+                </a:solidFill>
+              </a:rPr>
+              <a:t> a simulated sudden wind push</a:t>
+            </a:r>
+            <a:endParaRPr lang="en-US" sz="900" dirty="0"/>
+          </a:p>
+        </p:txBody>
+      </p:sp>
+      <p:sp>
+        <p:nvSpPr>
+          <p:cNvPr id="24" name="glossary-2"/>
+          <p:cNvSpPr txBox="1"/>
+          <p:nvPr/>
+        </p:nvSpPr>
+        <p:spPr>
+          <a:xfrm>
+            <a:off x="6566572" y="4206240"/>
+            <a:ext cx="2092796" cy="411480"/>
+          </a:xfrm>
+          <a:prstGeom prst="rect">
+            <a:avLst/>
+          </a:prstGeom>
+          <a:noFill/>
+          <a:ln/>
+        </p:spPr>
+        <p:txBody>
+          <a:bodyPr wrap="square" lIns="0" tIns="0" rIns="0" bIns="0" rtlCol="0" anchor="t"/>
+          <a:lstStyle/>
+          <a:p>
+            <a:pPr marL="0" indent="0">
+              <a:buNone/>
+            </a:pPr>
+            <a:r>
+              <a:rPr lang="en-US" sz="900" b="1" dirty="0">
+                <a:solidFill>
+                  <a:srgbClr val="A1A1AA"/>
+                </a:solidFill>
+              </a:rPr>
+              <a:t>Heading:</a:t>
+            </a:r>
+            <a:r>
+              <a:rPr lang="en-US" sz="900" dirty="0">
+                <a:solidFill>
+                  <a:srgbClr val="71717A"/>
+                </a:solidFill>
+              </a:rPr>
+              <a:t> where the nose points</a:t>
+            </a:r>
+            <a:endParaRPr lang="en-US" sz="900" dirty="0"/>
+          </a:p>
+        </p:txBody>
+      </p:sp>
+      <p:sp>
+        <p:nvSpPr>
+          <p:cNvPr id="25" name="Slide Number Placeholder 0"/>
+          <p:cNvSpPr>
+            <a:spLocks noGrp="1"/>
+          </p:cNvSpPr>
+          <p:nvPr>
+            <p:ph type="sldNum" sz="quarter" idx="4294967295"/>
+          </p:nvPr>
+        </p:nvSpPr>
+        <p:spPr>
+          <a:xfrm>
+            <a:off x="8229600" y="4645152"/>
+            <a:ext cx="457200" cy="274320"/>
+          </a:xfrm>
+          <a:prstGeom prst="rect">
+            <a:avLst/>
+          </a:prstGeom>
+          <a:extLst>
+            <a:ext uri="{C572A759-6A51-4108-AA02-DFA0A04FC94B}">
+              <ma14:wrappingTextBoxFlag xmlns="" xmlns:ma14="http://schemas.microsoft.com/office/mac/drawingml/2011/main" val="0"/>
+            </a:ext>
+          </a:extLst>
+        </p:spPr>
+        <p:txBody>
+          <a:bodyPr/>
+          <a:lstStyle>
+            <a:lvl1pPr>
+              <a:defRPr sz="1000">
+                <a:solidFill>
+                  <a:srgbClr val="A1A1AA"/>
+                </a:solidFill>
+              </a:defRPr>
+            </a:lvl1pPr>
+          </a:lstStyle>
+          <a:p>
+            <a:pPr algn="r"/>
+            <a:fld id="{F7021451-1387-4CA6-816F-3879F97B5CBC}" type="slidenum">
+              <a:rPr lang="en-US" b="0"/>
+              <a:t>13</a:t>
+            </a:fld>
+            <a:endParaRPr lang="en-US"/>
+          </a:p>
+        </p:txBody>
+      </p:sp>
+    </p:spTree>
+  </p:cSld>
+  <p:clrMapOvr>
+    <a:masterClrMapping/>
+  </p:clrMapOvr>
+</p:sld>
+</file>
+
 <file path=ppt/slides/slide14.xml><?xml version="1.0" encoding="utf-8"?>
 <p:sld xmlns:a="http://schemas.openxmlformats.org/drawingml/2006/main" xmlns:r="http://schemas.openxmlformats.org/officeDocument/2006/relationships" xmlns:p="http://schemas.openxmlformats.org/presentationml/2006/main">
   <p:cSld name="Slide 14">
@@ -3911,559 +4863,6 @@
             <a:fld id="{F7021451-1387-4CA6-816F-3879F97B5CBC}" type="slidenum">
               <a:rPr lang="en-US" b="0"/>
               <a:t>14</a:t>
-            </a:fld>
-            <a:endParaRPr lang="en-US"/>
-          </a:p>
-        </p:txBody>
-      </p:sp>
-    </p:spTree>
-  </p:cSld>
-  <p:clrMapOvr>
-    <a:masterClrMapping/>
-  </p:clrMapOvr>
-</p:sld>
-</file>
-
-<file path=ppt/slides/slide15.xml><?xml version="1.0" encoding="utf-8"?>
-<p:sld xmlns:a="http://schemas.openxmlformats.org/drawingml/2006/main" xmlns:r="http://schemas.openxmlformats.org/officeDocument/2006/relationships" xmlns:p="http://schemas.openxmlformats.org/presentationml/2006/main">
-  <p:cSld name="Slide 15">
-    <p:spTree>
-      <p:nvGrpSpPr>
-        <p:cNvPr id="1" name=""/>
-        <p:cNvGrpSpPr/>
-        <p:nvPr/>
-      </p:nvGrpSpPr>
-      <p:grpSpPr>
-        <a:xfrm>
-          <a:off x="0" y="0"/>
-          <a:ext cx="0" cy="0"/>
-          <a:chOff x="0" y="0"/>
-          <a:chExt cx="0" cy="0"/>
-        </a:xfrm>
-      </p:grpSpPr>
-      <p:sp>
-        <p:nvSpPr>
-          <p:cNvPr id="2" name="eyebrow"/>
-          <p:cNvSpPr txBox="1"/>
-          <p:nvPr/>
-        </p:nvSpPr>
-        <p:spPr>
-          <a:xfrm>
-            <a:off x="566928" y="219456"/>
-            <a:ext cx="5486400" cy="201168"/>
-          </a:xfrm>
-          <a:prstGeom prst="rect">
-            <a:avLst/>
-          </a:prstGeom>
-          <a:noFill/>
-          <a:ln/>
-        </p:spPr>
-        <p:txBody>
-          <a:bodyPr wrap="square" lIns="0" tIns="0" rIns="0" bIns="0" rtlCol="0" anchor="t"/>
-          <a:lstStyle/>
-          <a:p>
-            <a:pPr marL="0" indent="0">
-              <a:buNone/>
-            </a:pPr>
-            <a:r>
-              <a:rPr lang="en-US" sz="800" kern="0" spc="500" dirty="0">
-                <a:solidFill>
-                  <a:srgbClr val="FF2D6F"/>
-                </a:solidFill>
-              </a:rPr>
-              <a:t>HONESTY</a:t>
-            </a:r>
-            <a:endParaRPr lang="en-US" sz="800" dirty="0"/>
-          </a:p>
-        </p:txBody>
-      </p:sp>
-      <p:sp>
-        <p:nvSpPr>
-          <p:cNvPr id="3" name="Text 1"/>
-          <p:cNvSpPr>
-            <a:spLocks noGrp="1"/>
-          </p:cNvSpPr>
-          <p:nvPr>
-            <p:ph type="title" idx="103" hasCustomPrompt="1"/>
-          </p:nvPr>
-        </p:nvSpPr>
-        <p:spPr>
-          <a:xfrm>
-            <a:off x="566928" y="457200"/>
-            <a:ext cx="7589520" cy="365760"/>
-          </a:xfrm>
-          <a:prstGeom prst="rect">
-            <a:avLst/>
-          </a:prstGeom>
-          <a:noFill/>
-          <a:ln/>
-        </p:spPr>
-        <p:txBody>
-          <a:bodyPr wrap="square" lIns="0" tIns="0" rIns="0" bIns="0" rtlCol="0" anchor="t"/>
-          <a:lstStyle/>
-          <a:p>
-            <a:pPr marL="0" indent="0" algn="l">
-              <a:buNone/>
-            </a:pPr>
-            <a:r>
-              <a:rPr lang="en-US" sz="1600" kern="0" spc="100" dirty="0">
-                <a:solidFill>
-                  <a:srgbClr val="FAFAFA"/>
-                </a:solidFill>
-                <a:latin typeface="Michroma" pitchFamily="34" charset="0"/>
-                <a:ea typeface="Michroma" pitchFamily="34" charset="-122"/>
-                <a:cs typeface="Michroma" pitchFamily="34" charset="-120"/>
-              </a:rPr>
-              <a:t>WHAT DOES NOT WORK YET</a:t>
-            </a:r>
-            <a:endParaRPr lang="en-US" sz="1600" dirty="0"/>
-          </a:p>
-        </p:txBody>
-      </p:sp>
-      <p:sp>
-        <p:nvSpPr>
-          <p:cNvPr id="4" name="lim-0-h"/>
-          <p:cNvSpPr txBox="1"/>
-          <p:nvPr/>
-        </p:nvSpPr>
-        <p:spPr>
-          <a:xfrm>
-            <a:off x="566928" y="1097280"/>
-            <a:ext cx="2468880" cy="274320"/>
-          </a:xfrm>
-          <a:prstGeom prst="rect">
-            <a:avLst/>
-          </a:prstGeom>
-          <a:noFill/>
-          <a:ln/>
-        </p:spPr>
-        <p:txBody>
-          <a:bodyPr wrap="square" lIns="0" tIns="0" rIns="0" bIns="0" rtlCol="0" anchor="t"/>
-          <a:lstStyle/>
-          <a:p>
-            <a:pPr marL="0" indent="0">
-              <a:buNone/>
-            </a:pPr>
-            <a:r>
-              <a:rPr lang="en-US" sz="1300" b="1" dirty="0">
-                <a:solidFill>
-                  <a:srgbClr val="FF2D6F"/>
-                </a:solidFill>
-              </a:rPr>
-              <a:t>Lift from the fly brain</a:t>
-            </a:r>
-            <a:endParaRPr lang="en-US" sz="1300" dirty="0"/>
-          </a:p>
-        </p:txBody>
-      </p:sp>
-      <p:sp>
-        <p:nvSpPr>
-          <p:cNvPr id="5" name="lim-0-d"/>
-          <p:cNvSpPr txBox="1"/>
-          <p:nvPr/>
-        </p:nvSpPr>
-        <p:spPr>
-          <a:xfrm>
-            <a:off x="3108960" y="1097280"/>
-            <a:ext cx="5486400" cy="502920"/>
-          </a:xfrm>
-          <a:prstGeom prst="rect">
-            <a:avLst/>
-          </a:prstGeom>
-          <a:noFill/>
-          <a:ln/>
-        </p:spPr>
-        <p:txBody>
-          <a:bodyPr wrap="square" lIns="0" tIns="0" rIns="0" bIns="0" rtlCol="0" anchor="t"/>
-          <a:lstStyle/>
-          <a:p>
-            <a:pPr marL="0" indent="0">
-              <a:buNone/>
-            </a:pPr>
-            <a:r>
-              <a:rPr lang="en-US" sz="1200" dirty="0">
-                <a:solidFill>
-                  <a:srgbClr val="A1A1AA"/>
-                </a:solidFill>
-              </a:rPr>
-              <a:t>too weak: the drone slowly sinks, so the simulator holds the height</a:t>
-            </a:r>
-            <a:endParaRPr lang="en-US" sz="1200" dirty="0"/>
-          </a:p>
-        </p:txBody>
-      </p:sp>
-      <p:sp>
-        <p:nvSpPr>
-          <p:cNvPr id="6" name="lim-1-h"/>
-          <p:cNvSpPr txBox="1"/>
-          <p:nvPr/>
-        </p:nvSpPr>
-        <p:spPr>
-          <a:xfrm>
-            <a:off x="566928" y="1700784"/>
-            <a:ext cx="2468880" cy="274320"/>
-          </a:xfrm>
-          <a:prstGeom prst="rect">
-            <a:avLst/>
-          </a:prstGeom>
-          <a:noFill/>
-          <a:ln/>
-        </p:spPr>
-        <p:txBody>
-          <a:bodyPr wrap="square" lIns="0" tIns="0" rIns="0" bIns="0" rtlCol="0" anchor="t"/>
-          <a:lstStyle/>
-          <a:p>
-            <a:pPr marL="0" indent="0">
-              <a:buNone/>
-            </a:pPr>
-            <a:r>
-              <a:rPr lang="en-US" sz="1300" b="1" dirty="0">
-                <a:solidFill>
-                  <a:srgbClr val="FF2D6F"/>
-                </a:solidFill>
-              </a:rPr>
-              <a:t>Averaged muscle neurons</a:t>
-            </a:r>
-            <a:endParaRPr lang="en-US" sz="1300" dirty="0"/>
-          </a:p>
-        </p:txBody>
-      </p:sp>
-      <p:sp>
-        <p:nvSpPr>
-          <p:cNvPr id="7" name="lim-1-d"/>
-          <p:cNvSpPr txBox="1"/>
-          <p:nvPr/>
-        </p:nvSpPr>
-        <p:spPr>
-          <a:xfrm>
-            <a:off x="3108960" y="1700784"/>
-            <a:ext cx="5486400" cy="502920"/>
-          </a:xfrm>
-          <a:prstGeom prst="rect">
-            <a:avLst/>
-          </a:prstGeom>
-          <a:noFill/>
-          <a:ln/>
-        </p:spPr>
-        <p:txBody>
-          <a:bodyPr wrap="square" lIns="0" tIns="0" rIns="0" bIns="0" rtlCol="0" anchor="t"/>
-          <a:lstStyle/>
-          <a:p>
-            <a:pPr marL="0" indent="0">
-              <a:buNone/>
-            </a:pPr>
-            <a:r>
-              <a:rPr lang="en-US" sz="1200" dirty="0">
-                <a:solidFill>
-                  <a:srgbClr val="A1A1AA"/>
-                </a:solidFill>
-              </a:rPr>
-              <a:t>do not turn the drone; the direction is only in single flight neurons</a:t>
-            </a:r>
-            <a:endParaRPr lang="en-US" sz="1200" dirty="0"/>
-          </a:p>
-        </p:txBody>
-      </p:sp>
-      <p:sp>
-        <p:nvSpPr>
-          <p:cNvPr id="8" name="lim-2-h"/>
-          <p:cNvSpPr txBox="1"/>
-          <p:nvPr/>
-        </p:nvSpPr>
-        <p:spPr>
-          <a:xfrm>
-            <a:off x="566928" y="2304288"/>
-            <a:ext cx="2468880" cy="274320"/>
-          </a:xfrm>
-          <a:prstGeom prst="rect">
-            <a:avLst/>
-          </a:prstGeom>
-          <a:noFill/>
-          <a:ln/>
-        </p:spPr>
-        <p:txBody>
-          <a:bodyPr wrap="square" lIns="0" tIns="0" rIns="0" bIns="0" rtlCol="0" anchor="t"/>
-          <a:lstStyle/>
-          <a:p>
-            <a:pPr marL="0" indent="0">
-              <a:buNone/>
-            </a:pPr>
-            <a:r>
-              <a:rPr lang="en-US" sz="1300" b="1" dirty="0">
-                <a:solidFill>
-                  <a:srgbClr val="FF6A2B"/>
-                </a:solidFill>
-              </a:rPr>
-              <a:t>Vision range</a:t>
-            </a:r>
-            <a:endParaRPr lang="en-US" sz="1300" dirty="0"/>
-          </a:p>
-        </p:txBody>
-      </p:sp>
-      <p:sp>
-        <p:nvSpPr>
-          <p:cNvPr id="9" name="lim-2-d"/>
-          <p:cNvSpPr txBox="1"/>
-          <p:nvPr/>
-        </p:nvSpPr>
-        <p:spPr>
-          <a:xfrm>
-            <a:off x="3108960" y="2304288"/>
-            <a:ext cx="5486400" cy="502920"/>
-          </a:xfrm>
-          <a:prstGeom prst="rect">
-            <a:avLst/>
-          </a:prstGeom>
-          <a:noFill/>
-          <a:ln/>
-        </p:spPr>
-        <p:txBody>
-          <a:bodyPr wrap="square" lIns="0" tIns="0" rIns="0" bIns="0" rtlCol="0" anchor="t"/>
-          <a:lstStyle/>
-          <a:p>
-            <a:pPr marL="0" indent="0">
-              <a:buNone/>
-            </a:pPr>
-            <a:r>
-              <a:rPr lang="en-US" sz="1200" dirty="0">
-                <a:solidFill>
-                  <a:srgbClr val="A1A1AA"/>
-                </a:solidFill>
-              </a:rPr>
-              <a:t>the fly brain steers only the last 4 m; farther away GPS does</a:t>
-            </a:r>
-            <a:endParaRPr lang="en-US" sz="1200" dirty="0"/>
-          </a:p>
-        </p:txBody>
-      </p:sp>
-      <p:sp>
-        <p:nvSpPr>
-          <p:cNvPr id="10" name="lim-3-h"/>
-          <p:cNvSpPr txBox="1"/>
-          <p:nvPr/>
-        </p:nvSpPr>
-        <p:spPr>
-          <a:xfrm>
-            <a:off x="566928" y="2907792"/>
-            <a:ext cx="2468880" cy="274320"/>
-          </a:xfrm>
-          <a:prstGeom prst="rect">
-            <a:avLst/>
-          </a:prstGeom>
-          <a:noFill/>
-          <a:ln/>
-        </p:spPr>
-        <p:txBody>
-          <a:bodyPr wrap="square" lIns="0" tIns="0" rIns="0" bIns="0" rtlCol="0" anchor="t"/>
-          <a:lstStyle/>
-          <a:p>
-            <a:pPr marL="0" indent="0">
-              <a:buNone/>
-            </a:pPr>
-            <a:r>
-              <a:rPr lang="en-US" sz="1300" b="1" dirty="0">
-                <a:solidFill>
-                  <a:srgbClr val="FF6A2B"/>
-                </a:solidFill>
-              </a:rPr>
-              <a:t>Left eye</a:t>
-            </a:r>
-            <a:endParaRPr lang="en-US" sz="1300" dirty="0"/>
-          </a:p>
-        </p:txBody>
-      </p:sp>
-      <p:sp>
-        <p:nvSpPr>
-          <p:cNvPr id="11" name="lim-3-d"/>
-          <p:cNvSpPr txBox="1"/>
-          <p:nvPr/>
-        </p:nvSpPr>
-        <p:spPr>
-          <a:xfrm>
-            <a:off x="3108960" y="2907792"/>
-            <a:ext cx="5486400" cy="502920"/>
-          </a:xfrm>
-          <a:prstGeom prst="rect">
-            <a:avLst/>
-          </a:prstGeom>
-          <a:noFill/>
-          <a:ln/>
-        </p:spPr>
-        <p:txBody>
-          <a:bodyPr wrap="square" lIns="0" tIns="0" rIns="0" bIns="0" rtlCol="0" anchor="t"/>
-          <a:lstStyle/>
-          <a:p>
-            <a:pPr marL="0" indent="0">
-              <a:buNone/>
-            </a:pPr>
-            <a:r>
-              <a:rPr lang="en-US" sz="1200" dirty="0">
-                <a:solidFill>
-                  <a:srgbClr val="A1A1AA"/>
-                </a:solidFill>
-              </a:rPr>
-              <a:t>fewer labelled neurons in the data, so the left eye reaches ~3× fewer</a:t>
-            </a:r>
-            <a:endParaRPr lang="en-US" sz="1200" dirty="0"/>
-          </a:p>
-        </p:txBody>
-      </p:sp>
-      <p:sp>
-        <p:nvSpPr>
-          <p:cNvPr id="12" name="lim-4-h"/>
-          <p:cNvSpPr txBox="1"/>
-          <p:nvPr/>
-        </p:nvSpPr>
-        <p:spPr>
-          <a:xfrm>
-            <a:off x="566928" y="3511296"/>
-            <a:ext cx="2468880" cy="274320"/>
-          </a:xfrm>
-          <a:prstGeom prst="rect">
-            <a:avLst/>
-          </a:prstGeom>
-          <a:noFill/>
-          <a:ln/>
-        </p:spPr>
-        <p:txBody>
-          <a:bodyPr wrap="square" lIns="0" tIns="0" rIns="0" bIns="0" rtlCol="0" anchor="t"/>
-          <a:lstStyle/>
-          <a:p>
-            <a:pPr marL="0" indent="0">
-              <a:buNone/>
-            </a:pPr>
-            <a:r>
-              <a:rPr lang="en-US" sz="1300" b="1" dirty="0">
-                <a:solidFill>
-                  <a:srgbClr val="FF6A2B"/>
-                </a:solidFill>
-              </a:rPr>
-              <a:t>Simulation only</a:t>
-            </a:r>
-            <a:endParaRPr lang="en-US" sz="1300" dirty="0"/>
-          </a:p>
-        </p:txBody>
-      </p:sp>
-      <p:sp>
-        <p:nvSpPr>
-          <p:cNvPr id="13" name="lim-4-d"/>
-          <p:cNvSpPr txBox="1"/>
-          <p:nvPr/>
-        </p:nvSpPr>
-        <p:spPr>
-          <a:xfrm>
-            <a:off x="3108960" y="3511296"/>
-            <a:ext cx="5486400" cy="502920"/>
-          </a:xfrm>
-          <a:prstGeom prst="rect">
-            <a:avLst/>
-          </a:prstGeom>
-          <a:noFill/>
-          <a:ln/>
-        </p:spPr>
-        <p:txBody>
-          <a:bodyPr wrap="square" lIns="0" tIns="0" rIns="0" bIns="0" rtlCol="0" anchor="t"/>
-          <a:lstStyle/>
-          <a:p>
-            <a:pPr marL="0" indent="0">
-              <a:buNone/>
-            </a:pPr>
-            <a:r>
-              <a:rPr lang="en-US" sz="1200" dirty="0">
-                <a:solidFill>
-                  <a:srgbClr val="A1A1AA"/>
-                </a:solidFill>
-              </a:rPr>
-              <a:t>no real drone flown yet; obstacles are cleared from the path to the target</a:t>
-            </a:r>
-            <a:endParaRPr lang="en-US" sz="1200" dirty="0"/>
-          </a:p>
-        </p:txBody>
-      </p:sp>
-      <p:sp>
-        <p:nvSpPr>
-          <p:cNvPr id="14" name="glossary-0"/>
-          <p:cNvSpPr txBox="1"/>
-          <p:nvPr/>
-        </p:nvSpPr>
-        <p:spPr>
-          <a:xfrm>
-            <a:off x="566928" y="4206240"/>
-            <a:ext cx="8092440" cy="411480"/>
-          </a:xfrm>
-          <a:prstGeom prst="rect">
-            <a:avLst/>
-          </a:prstGeom>
-          <a:noFill/>
-          <a:ln/>
-        </p:spPr>
-        <p:txBody>
-          <a:bodyPr wrap="square" lIns="0" tIns="0" rIns="0" bIns="0" rtlCol="0" anchor="t"/>
-          <a:lstStyle/>
-          <a:p>
-            <a:pPr marL="0" indent="0">
-              <a:buNone/>
-            </a:pPr>
-            <a:r>
-              <a:rPr lang="en-US" sz="900" b="1" dirty="0">
-                <a:solidFill>
-                  <a:srgbClr val="A1A1AA"/>
-                </a:solidFill>
-              </a:rPr>
-              <a:t>Lift:</a:t>
-            </a:r>
-            <a:r>
-              <a:rPr lang="en-US" sz="900" dirty="0">
-                <a:solidFill>
-                  <a:srgbClr val="71717A"/>
-                </a:solidFill>
-              </a:rPr>
-              <a:t> propeller power that keeps the drone in the air</a:t>
-            </a:r>
-            <a:endParaRPr lang="en-US" sz="900" dirty="0"/>
-          </a:p>
-        </p:txBody>
-      </p:sp>
-      <p:sp>
-        <p:nvSpPr>
-          <p:cNvPr id="25" name="Slide Number Placeholder 0"/>
-          <p:cNvSpPr>
-            <a:spLocks noGrp="1"/>
-          </p:cNvSpPr>
-          <p:nvPr>
-            <p:ph type="sldNum" sz="quarter" idx="4294967295"/>
-          </p:nvPr>
-        </p:nvSpPr>
-        <p:spPr>
-          <a:xfrm>
-            <a:off x="8229600" y="4645152"/>
-            <a:ext cx="457200" cy="274320"/>
-          </a:xfrm>
-          <a:prstGeom prst="rect">
-            <a:avLst/>
-          </a:prstGeom>
-          <a:extLst>
-            <a:ext uri="{C572A759-6A51-4108-AA02-DFA0A04FC94B}">
-              <ma14:wrappingTextBoxFlag xmlns="" xmlns:ma14="http://schemas.microsoft.com/office/mac/drawingml/2011/main" val="0"/>
-            </a:ext>
-          </a:extLst>
-        </p:spPr>
-        <p:txBody>
-          <a:bodyPr/>
-          <a:lstStyle>
-            <a:lvl1pPr>
-              <a:defRPr sz="1000">
-                <a:solidFill>
-                  <a:srgbClr val="A1A1AA"/>
-                </a:solidFill>
-              </a:defRPr>
-            </a:lvl1pPr>
-          </a:lstStyle>
-          <a:p>
-            <a:pPr algn="r"/>
-            <a:fld id="{F7021451-1387-4CA6-816F-3879F97B5CBC}" type="slidenum">
-              <a:rPr lang="en-US" b="0"/>
-              <a:t>15</a:t>
             </a:fld>
             <a:endParaRPr lang="en-US"/>
           </a:p>

</xml_diff>